<commit_message>
Redesign CFD boundary-condition slide
</commit_message>
<xml_diff>
--- a/references/cfd.pptx
+++ b/references/cfd.pptx
@@ -2,20 +2,20 @@
 <file path=ppt/presentation.xml><?xml version="1.0" encoding="utf-8"?>
 <p:presentation xmlns:p="http://schemas.openxmlformats.org/presentationml/2006/main">
   <p:sldMasterIdLst>
-    <p:sldMasterId xmlns:r="http://schemas.openxmlformats.org/officeDocument/2006/relationships" id="2147483648" r:id="R09339113e1e04fe2"/>
+    <p:sldMasterId xmlns:r="http://schemas.openxmlformats.org/officeDocument/2006/relationships" id="2147483648" r:id="Rd52d1fdcc9a54afd"/>
   </p:sldMasterIdLst>
   <p:notesMasterIdLst>
-    <p:notesMasterId xmlns:r="http://schemas.openxmlformats.org/officeDocument/2006/relationships" r:id="Rfbc281e48ce74141"/>
+    <p:notesMasterId xmlns:r="http://schemas.openxmlformats.org/officeDocument/2006/relationships" r:id="Rd6465588ac30467c"/>
   </p:notesMasterIdLst>
   <p:sldIdLst>
-    <p:sldId xmlns:r="http://schemas.openxmlformats.org/officeDocument/2006/relationships" id="256" r:id="R28b50a3294684117"/>
-    <p:sldId xmlns:r="http://schemas.openxmlformats.org/officeDocument/2006/relationships" id="257" r:id="Rf751a792772e4f88"/>
-    <p:sldId xmlns:r="http://schemas.openxmlformats.org/officeDocument/2006/relationships" id="258" r:id="R4e278c754cf84407"/>
-    <p:sldId xmlns:r="http://schemas.openxmlformats.org/officeDocument/2006/relationships" id="259" r:id="Rf6d9eb6895924286"/>
-    <p:sldId xmlns:r="http://schemas.openxmlformats.org/officeDocument/2006/relationships" id="260" r:id="R0d5d3f5762e241c8"/>
-    <p:sldId xmlns:r="http://schemas.openxmlformats.org/officeDocument/2006/relationships" id="261" r:id="R1aa37cfb9def4774"/>
-    <p:sldId xmlns:r="http://schemas.openxmlformats.org/officeDocument/2006/relationships" id="262" r:id="R9a56d701312c46a5"/>
-    <p:sldId xmlns:r="http://schemas.openxmlformats.org/officeDocument/2006/relationships" id="263" r:id="R0800de6c82ca4275"/>
+    <p:sldId xmlns:r="http://schemas.openxmlformats.org/officeDocument/2006/relationships" id="256" r:id="R08e9d7bf483d483b"/>
+    <p:sldId xmlns:r="http://schemas.openxmlformats.org/officeDocument/2006/relationships" id="257" r:id="Rdbcd0e9241104e90"/>
+    <p:sldId xmlns:r="http://schemas.openxmlformats.org/officeDocument/2006/relationships" id="258" r:id="R7506b929b3b84edd"/>
+    <p:sldId xmlns:r="http://schemas.openxmlformats.org/officeDocument/2006/relationships" id="259" r:id="Rf150c493c81e4ad1"/>
+    <p:sldId xmlns:r="http://schemas.openxmlformats.org/officeDocument/2006/relationships" id="260" r:id="Re2bd0c908b854658"/>
+    <p:sldId xmlns:r="http://schemas.openxmlformats.org/officeDocument/2006/relationships" id="261" r:id="Rb7b41bc4264a4420"/>
+    <p:sldId xmlns:r="http://schemas.openxmlformats.org/officeDocument/2006/relationships" id="262" r:id="R891fe0c576c043a0"/>
+    <p:sldId xmlns:r="http://schemas.openxmlformats.org/officeDocument/2006/relationships" id="263" r:id="R573237f4f3cb49de"/>
   </p:sldIdLst>
   <p:sldSz cx="12192000" cy="6858000"/>
   <p:notesSz cx="6858000" cy="9144000"/>
@@ -639,6 +639,36 @@
           </a:p>
           <a:p xmlns:a="http://schemas.openxmlformats.org/drawingml/2006/main">
             <a:r>
+              <a:t>- https://github.com/OZAKI39/ulm-3d-vascular-model-generation/blob/codex/cfd-wall-force-numerics-validated-sync-20260830/outputs/cfd_surface_prepare/vmtk_tps_boundarynormal_crossseam_finalized_recovery_anchor003274_20260826_221611/bc/boundary_conditions_vmtk_boundarynormal_crossseam.json</a:t>
+            </a:r>
+          </a:p>
+          <a:p xmlns:a="http://schemas.openxmlformats.org/drawingml/2006/main">
+            <a:r>
+              <a:t>- https://github.com/OZAKI39/ulm-3d-vascular-model-generation/blob/codex/cfd-wall-force-numerics-validated-sync-20260830/utils/cfd_preprocess/one_d_flow.py</a:t>
+            </a:r>
+          </a:p>
+          <a:p xmlns:a="http://schemas.openxmlformats.org/drawingml/2006/main">
+            <a:r>
+              <a:t>- https://github.com/OZAKI39/ulm-3d-vascular-model-generation/blob/codex/cfd-wall-force-numerics-validated-sync-20260830/utils/cfd_preprocess/port_transfer.py</a:t>
+            </a:r>
+          </a:p>
+          <a:p xmlns:a="http://schemas.openxmlformats.org/drawingml/2006/main">
+            <a:r>
+              <a:t>- https://github.com/OZAKI39/ulm-3d-vascular-model-generation/blob/codex/cfd-wall-force-numerics-validated-sync-20260830/utils/cfd_surface_prepare/vmtk_qc.py</a:t>
+            </a:r>
+          </a:p>
+          <a:p xmlns:a="http://schemas.openxmlformats.org/drawingml/2006/main">
+            <a:r>
+              <a:t>- https://github.com/OZAKI39/ulm-3d-vascular-model-generation/blob/codex/cfd-wall-force-numerics-validated-sync-20260830/outputs/cfd_flow/healthy_mouse_capillary_calibration_anchor003274_20260829_180310/qc/healthy_flow_target_calculation.json</a:t>
+            </a:r>
+          </a:p>
+          <a:p xmlns:a="http://schemas.openxmlformats.org/drawingml/2006/main">
+            <a:r>
+              <a:t>- https://github.com/OZAKI39/ulm-3d-vascular-model-generation/blob/codex/cfd-wall-force-numerics-validated-sync-20260830/outputs/cfd_flow/production_tau1_base_promotion_anchor003274_20260902_013637/input/production_numerical_contract.json</a:t>
+            </a:r>
+          </a:p>
+          <a:p xmlns:a="http://schemas.openxmlformats.org/drawingml/2006/main">
+            <a:r>
               <a:t>[/Sources]</a:t>
             </a:r>
           </a:p>
@@ -1147,7 +1177,7 @@
   </p:cSld>
   <p:clrMap bg1="lt1" tx1="dk1" bg2="lt2" tx2="dk2" accent1="accent1" accent2="accent2" accent3="accent3" accent4="accent4" accent5="accent5" accent6="accent6" hlink="hlink" folHlink="folHlink"/>
   <p:sldLayoutIdLst>
-    <p:sldLayoutId xmlns:r="http://schemas.openxmlformats.org/officeDocument/2006/relationships" id="2147483649" r:id="R6cb798dc40e64144"/>
+    <p:sldLayoutId xmlns:r="http://schemas.openxmlformats.org/officeDocument/2006/relationships" id="2147483649" r:id="R35aa52cb7b444609"/>
   </p:sldLayoutIdLst>
   <p:txStyles>
     <p:titleStyle>
@@ -1680,263 +1710,6 @@
   <c:chart>
     <c:plotArea>
       <c:barChart>
-        <c:barDir val="col"/>
-        <c:grouping val="clustered"/>
-        <c:varyColors val="1"/>
-        <c:ser>
-          <c:idx val="0"/>
-          <c:order val="0"/>
-          <c:tx>
-            <c:v>Flow</c:v>
-          </c:tx>
-          <c:spPr>
-            <a:solidFill xmlns:a="http://schemas.openxmlformats.org/drawingml/2006/main">
-              <a:srgbClr val="163A5F"/>
-            </a:solidFill>
-          </c:spPr>
-          <c:dPt>
-            <c:idx val="0"/>
-            <c:invertIfNegative val="0"/>
-            <c:spPr>
-              <a:solidFill xmlns:a="http://schemas.openxmlformats.org/drawingml/2006/main">
-                <a:srgbClr val="D55E00"/>
-              </a:solidFill>
-            </c:spPr>
-          </c:dPt>
-          <c:dPt>
-            <c:idx val="1"/>
-            <c:invertIfNegative val="0"/>
-            <c:spPr>
-              <a:solidFill xmlns:a="http://schemas.openxmlformats.org/drawingml/2006/main">
-                <a:srgbClr val="0072B2"/>
-              </a:solidFill>
-            </c:spPr>
-          </c:dPt>
-          <c:dPt>
-            <c:idx val="2"/>
-            <c:invertIfNegative val="0"/>
-            <c:spPr>
-              <a:solidFill xmlns:a="http://schemas.openxmlformats.org/drawingml/2006/main">
-                <a:srgbClr val="009E73"/>
-              </a:solidFill>
-            </c:spPr>
-          </c:dPt>
-          <c:dPt>
-            <c:idx val="3"/>
-            <c:invertIfNegative val="0"/>
-            <c:spPr>
-              <a:solidFill xmlns:a="http://schemas.openxmlformats.org/drawingml/2006/main">
-                <a:srgbClr val="CC79A7"/>
-              </a:solidFill>
-            </c:spPr>
-          </c:dPt>
-          <c:cat>
-            <c:strLit>
-              <c:ptCount val="4"/>
-              <c:pt idx="0">
-                <c:v>Inlet</c:v>
-              </c:pt>
-              <c:pt idx="1">
-                <c:v>Outlet 1</c:v>
-              </c:pt>
-              <c:pt idx="2">
-                <c:v>Outlet 2</c:v>
-              </c:pt>
-              <c:pt idx="3">
-                <c:v>Outlet 3</c:v>
-              </c:pt>
-            </c:strLit>
-          </c:cat>
-          <c:val>
-            <c:numLit>
-              <c:formatCode>0.000</c:formatCode>
-              <c:ptCount val="4"/>
-              <c:pt idx="0">
-                <c:v>0.7693508475538942</c:v>
-              </c:pt>
-              <c:pt idx="1">
-                <c:v>0.04848702368821955</c:v>
-              </c:pt>
-              <c:pt idx="2">
-                <c:v>0.38152115839442513</c:v>
-              </c:pt>
-              <c:pt idx="3">
-                <c:v>0.3393426654712128</c:v>
-              </c:pt>
-            </c:numLit>
-          </c:val>
-        </c:ser>
-        <c:dLbls>
-          <c:txPr>
-            <a:bodyPr xmlns:a="http://schemas.openxmlformats.org/drawingml/2006/main" anchorCtr="1"/>
-            <a:lstStyle xmlns:a="http://schemas.openxmlformats.org/drawingml/2006/main"/>
-            <a:p xmlns:a="http://schemas.openxmlformats.org/drawingml/2006/main">
-              <a:pPr>
-                <a:defRPr sz="900" b="1">
-                  <a:solidFill>
-                    <a:srgbClr val="1F2933"/>
-                  </a:solidFill>
-                </a:defRPr>
-              </a:pPr>
-            </a:p>
-          </c:txPr>
-          <c:dLblPos val="outEnd"/>
-          <c:showLegendKey val="0"/>
-          <c:showVal val="1"/>
-          <c:showCatName val="0"/>
-          <c:showSerName val="0"/>
-          <c:showPercent val="0"/>
-          <c:showBubbleSize val="0"/>
-          <c:showLeaderLines val="0"/>
-        </c:dLbls>
-        <c:gapWidth val="48"/>
-        <c:axId val="48650112"/>
-        <c:axId val="48672768"/>
-      </c:barChart>
-      <c:catAx>
-        <c:axId val="48650112"/>
-        <c:scaling>
-          <c:orientation val="minMax"/>
-        </c:scaling>
-        <c:delete val="0"/>
-        <c:axPos val="b"/>
-        <c:numFmt formatCode="General"/>
-        <c:majorTickMark val="none"/>
-        <c:minorTickMark val="none"/>
-        <c:spPr>
-          <a:ln xmlns:a="http://schemas.openxmlformats.org/drawingml/2006/main" w="9525">
-            <a:solidFill>
-              <a:srgbClr val="CDD7DD"/>
-            </a:solidFill>
-            <a:prstDash val="solid"/>
-          </a:ln>
-        </c:spPr>
-        <c:txPr>
-          <a:bodyPr xmlns:a="http://schemas.openxmlformats.org/drawingml/2006/main" anchorCtr="1"/>
-          <a:lstStyle xmlns:a="http://schemas.openxmlformats.org/drawingml/2006/main"/>
-          <a:p xmlns:a="http://schemas.openxmlformats.org/drawingml/2006/main">
-            <a:pPr>
-              <a:defRPr sz="975">
-                <a:solidFill>
-                  <a:srgbClr val="66747E"/>
-                </a:solidFill>
-              </a:defRPr>
-            </a:pPr>
-          </a:p>
-        </c:txPr>
-        <c:crossAx val="48672768"/>
-        <c:lblAlgn val="ctr"/>
-        <c:lblOffset val="100"/>
-        <c:noMultiLvlLbl val="0"/>
-      </c:catAx>
-      <c:valAx>
-        <c:axId val="48672768"/>
-        <c:scaling>
-          <c:orientation val="minMax"/>
-          <c:max val="0.85"/>
-          <c:min val="0"/>
-        </c:scaling>
-        <c:delete val="0"/>
-        <c:axPos val="l"/>
-        <c:majorGridlines>
-          <c:spPr>
-            <a:ln xmlns:a="http://schemas.openxmlformats.org/drawingml/2006/main" w="9525">
-              <a:solidFill>
-                <a:srgbClr val="E4EAED"/>
-              </a:solidFill>
-              <a:prstDash val="solid"/>
-            </a:ln>
-          </c:spPr>
-        </c:majorGridlines>
-        <c:title>
-          <c:tx>
-            <c:rich>
-              <a:bodyPr xmlns:a="http://schemas.openxmlformats.org/drawingml/2006/main"/>
-              <a:lstStyle xmlns:a="http://schemas.openxmlformats.org/drawingml/2006/main"/>
-              <a:p xmlns:a="http://schemas.openxmlformats.org/drawingml/2006/main">
-                <a:r>
-                  <a:rPr sz="975">
-                    <a:solidFill>
-                      <a:srgbClr val="66747E"/>
-                    </a:solidFill>
-                  </a:rPr>
-                  <a:t>Flow (pL/s)</a:t>
-                </a:r>
-              </a:p>
-            </c:rich>
-          </c:tx>
-          <c:txPr>
-            <a:bodyPr xmlns:a="http://schemas.openxmlformats.org/drawingml/2006/main" anchorCtr="1"/>
-            <a:lstStyle xmlns:a="http://schemas.openxmlformats.org/drawingml/2006/main"/>
-            <a:p xmlns:a="http://schemas.openxmlformats.org/drawingml/2006/main">
-              <a:pPr>
-                <a:defRPr sz="975">
-                  <a:solidFill>
-                    <a:srgbClr val="66747E"/>
-                  </a:solidFill>
-                </a:defRPr>
-              </a:pPr>
-            </a:p>
-          </c:txPr>
-        </c:title>
-        <c:numFmt formatCode="0.0"/>
-        <c:majorTickMark val="none"/>
-        <c:minorTickMark val="none"/>
-        <c:spPr>
-          <a:ln xmlns:a="http://schemas.openxmlformats.org/drawingml/2006/main" w="9525">
-            <a:solidFill>
-              <a:srgbClr val="D4D4D4"/>
-            </a:solidFill>
-            <a:prstDash val="solid"/>
-          </a:ln>
-        </c:spPr>
-        <c:txPr>
-          <a:bodyPr xmlns:a="http://schemas.openxmlformats.org/drawingml/2006/main" anchorCtr="1"/>
-          <a:lstStyle xmlns:a="http://schemas.openxmlformats.org/drawingml/2006/main"/>
-          <a:p xmlns:a="http://schemas.openxmlformats.org/drawingml/2006/main">
-            <a:pPr>
-              <a:defRPr sz="900">
-                <a:solidFill>
-                  <a:srgbClr val="66747E"/>
-                </a:solidFill>
-              </a:defRPr>
-            </a:pPr>
-          </a:p>
-        </c:txPr>
-        <c:crossAx val="48650112"/>
-        <c:crossBetween val="between"/>
-        <c:majorUnit val="0.2"/>
-      </c:valAx>
-      <c:spPr>
-        <a:solidFill xmlns:a="http://schemas.openxmlformats.org/drawingml/2006/main">
-          <a:srgbClr val="FFFFFF"/>
-        </a:solidFill>
-        <a:ln xmlns:a="http://schemas.openxmlformats.org/drawingml/2006/main" w="0">
-          <a:noFill/>
-          <a:prstDash val="solid"/>
-        </a:ln>
-      </c:spPr>
-    </c:plotArea>
-    <c:plotVisOnly val="1"/>
-  </c:chart>
-  <c:spPr>
-    <a:solidFill xmlns:a="http://schemas.openxmlformats.org/drawingml/2006/main">
-      <a:srgbClr val="FFFFFF"/>
-    </a:solidFill>
-    <a:ln xmlns:a="http://schemas.openxmlformats.org/drawingml/2006/main" w="0">
-      <a:noFill/>
-      <a:prstDash val="solid"/>
-    </a:ln>
-  </c:spPr>
-</c:chartSpace>
-</file>
-
-<file path=ppt/slides/charts/chart2.xml><?xml version="1.0" encoding="utf-8"?>
-<c:chartSpace xmlns:c="http://schemas.openxmlformats.org/drawingml/2006/chart">
-  <c:lang val="en-US"/>
-  <c:chart>
-    <c:plotArea>
-      <c:barChart>
         <c:barDir val="bar"/>
         <c:grouping val="clustered"/>
         <c:varyColors val="1"/>
@@ -2161,7 +1934,7 @@
           <p:cNvPr id="10" name="">
             <a:extLst xmlns:a="http://schemas.openxmlformats.org/drawingml/2006/main">
               <a:ext uri="{FF2B5EF4-FFF2-40B4-BE49-F238E27FC236}">
-                <a16:creationId xmlns:a16="http://schemas.microsoft.com/office/drawing/2014/main" id="{5289EC4D-D9EF-4046-A898-51E919E2EF9C}"/>
+                <a16:creationId xmlns:a16="http://schemas.microsoft.com/office/drawing/2014/main" id="{82A99D0D-622A-451C-BD9F-BDAA0D7F7968}"/>
               </a:ext>
             </a:extLst>
           </p:cNvPr>
@@ -2192,7 +1965,7 @@
           <p:cNvPr id="2" name="">
             <a:extLst xmlns:a="http://schemas.openxmlformats.org/drawingml/2006/main">
               <a:ext uri="{FF2B5EF4-FFF2-40B4-BE49-F238E27FC236}">
-                <a16:creationId xmlns:a16="http://schemas.microsoft.com/office/drawing/2014/main" id="{53F074E7-A378-4D71-8ED5-C2774788C793}"/>
+                <a16:creationId xmlns:a16="http://schemas.microsoft.com/office/drawing/2014/main" id="{291A5D7C-FABA-436C-923E-077F902C4821}"/>
               </a:ext>
             </a:extLst>
           </p:cNvPr>
@@ -2242,7 +2015,7 @@
           <p:cNvPr id="3" name="">
             <a:extLst xmlns:a="http://schemas.openxmlformats.org/drawingml/2006/main">
               <a:ext uri="{FF2B5EF4-FFF2-40B4-BE49-F238E27FC236}">
-                <a16:creationId xmlns:a16="http://schemas.microsoft.com/office/drawing/2014/main" id="{98862C1A-A431-4FB0-AB70-63FA4D1646EE}"/>
+                <a16:creationId xmlns:a16="http://schemas.microsoft.com/office/drawing/2014/main" id="{594EF444-D065-4892-9A45-FF30AEE603FA}"/>
               </a:ext>
             </a:extLst>
           </p:cNvPr>
@@ -2292,7 +2065,7 @@
           <p:cNvPr id="4" name="">
             <a:extLst xmlns:a="http://schemas.openxmlformats.org/drawingml/2006/main">
               <a:ext uri="{FF2B5EF4-FFF2-40B4-BE49-F238E27FC236}">
-                <a16:creationId xmlns:a16="http://schemas.microsoft.com/office/drawing/2014/main" id="{FD83BC6E-AC12-4C02-9CC9-3ED065854F85}"/>
+                <a16:creationId xmlns:a16="http://schemas.microsoft.com/office/drawing/2014/main" id="{1A14BA75-76C5-40CC-AF55-A4E72489C17B}"/>
               </a:ext>
             </a:extLst>
           </p:cNvPr>
@@ -2342,7 +2115,7 @@
           <p:cNvPr id="5" name="">
             <a:extLst xmlns:a="http://schemas.openxmlformats.org/drawingml/2006/main">
               <a:ext uri="{FF2B5EF4-FFF2-40B4-BE49-F238E27FC236}">
-                <a16:creationId xmlns:a16="http://schemas.microsoft.com/office/drawing/2014/main" id="{49F79A4B-9901-4B37-A765-A71578D89771}"/>
+                <a16:creationId xmlns:a16="http://schemas.microsoft.com/office/drawing/2014/main" id="{0507E74D-B294-4A4C-8D5E-6CA6CCADD2DC}"/>
               </a:ext>
             </a:extLst>
           </p:cNvPr>
@@ -2373,7 +2146,7 @@
           <p:cNvPr id="6" name="">
             <a:extLst xmlns:a="http://schemas.openxmlformats.org/drawingml/2006/main">
               <a:ext uri="{FF2B5EF4-FFF2-40B4-BE49-F238E27FC236}">
-                <a16:creationId xmlns:a16="http://schemas.microsoft.com/office/drawing/2014/main" id="{F88D81C8-798B-47AB-AB0B-F3959D31CA0B}"/>
+                <a16:creationId xmlns:a16="http://schemas.microsoft.com/office/drawing/2014/main" id="{78C2C7DB-C8FB-4D8F-ACC0-C723F5CC8D3D}"/>
               </a:ext>
             </a:extLst>
           </p:cNvPr>
@@ -2423,7 +2196,7 @@
           <p:cNvPr id="7" name="">
             <a:extLst xmlns:a="http://schemas.openxmlformats.org/drawingml/2006/main">
               <a:ext uri="{FF2B5EF4-FFF2-40B4-BE49-F238E27FC236}">
-                <a16:creationId xmlns:a16="http://schemas.microsoft.com/office/drawing/2014/main" id="{FE4BED3E-58CE-4FFE-9151-E859D3735C4A}"/>
+                <a16:creationId xmlns:a16="http://schemas.microsoft.com/office/drawing/2014/main" id="{41B5D630-20D6-4AF4-A577-FDA6AE21CCC1}"/>
               </a:ext>
             </a:extLst>
           </p:cNvPr>
@@ -2462,7 +2235,7 @@
           <p:nvPr/>
         </p:nvPicPr>
         <p:blipFill>
-          <a:blip xmlns:r="http://schemas.openxmlformats.org/officeDocument/2006/relationships" xmlns:a="http://schemas.openxmlformats.org/drawingml/2006/main" r:embed="R9c9b28f161d04d51"/>
+          <a:blip xmlns:r="http://schemas.openxmlformats.org/officeDocument/2006/relationships" xmlns:a="http://schemas.openxmlformats.org/drawingml/2006/main" r:embed="Rf37e854226a24cf0"/>
           <a:stretch xmlns:a="http://schemas.openxmlformats.org/drawingml/2006/main"/>
         </p:blipFill>
         <p:spPr>
@@ -2480,7 +2253,7 @@
           <p:cNvPr id="9" name="">
             <a:extLst xmlns:a="http://schemas.openxmlformats.org/drawingml/2006/main">
               <a:ext uri="{FF2B5EF4-FFF2-40B4-BE49-F238E27FC236}">
-                <a16:creationId xmlns:a16="http://schemas.microsoft.com/office/drawing/2014/main" id="{D48C6D1B-73B2-4FD6-B31C-F2DE8FA0889A}"/>
+                <a16:creationId xmlns:a16="http://schemas.microsoft.com/office/drawing/2014/main" id="{00F58D1A-8005-454E-ABBE-BF351EFE9512}"/>
               </a:ext>
             </a:extLst>
           </p:cNvPr>
@@ -2528,7 +2301,7 @@
     </p:spTree>
     <p:extLst>
       <p:ext uri="{BB962C8B-B14F-4D97-AF65-F5344CB8AC3E}">
-        <p14:creationId xmlns:p14="http://schemas.microsoft.com/office/powerpoint/2010/main" val="936290406"/>
+        <p14:creationId xmlns:p14="http://schemas.microsoft.com/office/powerpoint/2010/main" val="2098920862"/>
       </p:ext>
     </p:extLst>
   </p:cSld>
@@ -2559,7 +2332,7 @@
           <p:cNvPr id="30" name="">
             <a:extLst xmlns:a="http://schemas.openxmlformats.org/drawingml/2006/main">
               <a:ext uri="{FF2B5EF4-FFF2-40B4-BE49-F238E27FC236}">
-                <a16:creationId xmlns:a16="http://schemas.microsoft.com/office/drawing/2014/main" id="{FEE9284E-97FC-41DD-8E3E-4A75AB121A94}"/>
+                <a16:creationId xmlns:a16="http://schemas.microsoft.com/office/drawing/2014/main" id="{413C2053-9666-45DB-B8AD-0496345C0B10}"/>
               </a:ext>
             </a:extLst>
           </p:cNvPr>
@@ -2609,7 +2382,7 @@
           <p:cNvPr id="2" name="">
             <a:extLst xmlns:a="http://schemas.openxmlformats.org/drawingml/2006/main">
               <a:ext uri="{FF2B5EF4-FFF2-40B4-BE49-F238E27FC236}">
-                <a16:creationId xmlns:a16="http://schemas.microsoft.com/office/drawing/2014/main" id="{299C35C1-F210-4BDC-996B-77969E240AE8}"/>
+                <a16:creationId xmlns:a16="http://schemas.microsoft.com/office/drawing/2014/main" id="{3E3090C5-035B-41BC-B01A-968AE119B10C}"/>
               </a:ext>
             </a:extLst>
           </p:cNvPr>
@@ -2659,7 +2432,7 @@
           <p:cNvPr id="3" name="">
             <a:extLst xmlns:a="http://schemas.openxmlformats.org/drawingml/2006/main">
               <a:ext uri="{FF2B5EF4-FFF2-40B4-BE49-F238E27FC236}">
-                <a16:creationId xmlns:a16="http://schemas.microsoft.com/office/drawing/2014/main" id="{6B5AD497-F232-4557-A9D7-40DD24F3C5E0}"/>
+                <a16:creationId xmlns:a16="http://schemas.microsoft.com/office/drawing/2014/main" id="{7D463E15-17EB-4738-92FC-C5C09653C7EC}"/>
               </a:ext>
             </a:extLst>
           </p:cNvPr>
@@ -2690,7 +2463,7 @@
           <p:cNvPr id="4" name="">
             <a:extLst xmlns:a="http://schemas.openxmlformats.org/drawingml/2006/main">
               <a:ext uri="{FF2B5EF4-FFF2-40B4-BE49-F238E27FC236}">
-                <a16:creationId xmlns:a16="http://schemas.microsoft.com/office/drawing/2014/main" id="{64EA4BB0-A2CA-44EF-BF21-A8DBA16F989C}"/>
+                <a16:creationId xmlns:a16="http://schemas.microsoft.com/office/drawing/2014/main" id="{4D8C3112-0767-4A7F-BAE2-F1960FD0A3FB}"/>
               </a:ext>
             </a:extLst>
           </p:cNvPr>
@@ -2721,7 +2494,7 @@
           <p:cNvPr id="5" name="">
             <a:extLst xmlns:a="http://schemas.openxmlformats.org/drawingml/2006/main">
               <a:ext uri="{FF2B5EF4-FFF2-40B4-BE49-F238E27FC236}">
-                <a16:creationId xmlns:a16="http://schemas.microsoft.com/office/drawing/2014/main" id="{16286EF1-6BB7-4B7B-A058-69AD544FE53A}"/>
+                <a16:creationId xmlns:a16="http://schemas.microsoft.com/office/drawing/2014/main" id="{92F2ECB3-8020-443D-88BB-863BE2EBBFC7}"/>
               </a:ext>
             </a:extLst>
           </p:cNvPr>
@@ -2771,7 +2544,7 @@
           <p:cNvPr id="6" name="">
             <a:extLst xmlns:a="http://schemas.openxmlformats.org/drawingml/2006/main">
               <a:ext uri="{FF2B5EF4-FFF2-40B4-BE49-F238E27FC236}">
-                <a16:creationId xmlns:a16="http://schemas.microsoft.com/office/drawing/2014/main" id="{C07A5408-502B-4257-95A1-06A1CE53B6B5}"/>
+                <a16:creationId xmlns:a16="http://schemas.microsoft.com/office/drawing/2014/main" id="{A2BDBF87-EEC5-4297-B500-8B98A79EEAC0}"/>
               </a:ext>
             </a:extLst>
           </p:cNvPr>
@@ -2806,7 +2579,7 @@
           <p:cNvPr id="7" name="">
             <a:extLst xmlns:a="http://schemas.openxmlformats.org/drawingml/2006/main">
               <a:ext uri="{FF2B5EF4-FFF2-40B4-BE49-F238E27FC236}">
-                <a16:creationId xmlns:a16="http://schemas.microsoft.com/office/drawing/2014/main" id="{BA6FCF80-3BC0-45B6-8FEA-B78A45CD1A54}"/>
+                <a16:creationId xmlns:a16="http://schemas.microsoft.com/office/drawing/2014/main" id="{A0438C13-F26B-453D-A1EA-5F063289DF6E}"/>
               </a:ext>
             </a:extLst>
           </p:cNvPr>
@@ -2837,7 +2610,7 @@
           <p:cNvPr id="8" name="">
             <a:extLst xmlns:a="http://schemas.openxmlformats.org/drawingml/2006/main">
               <a:ext uri="{FF2B5EF4-FFF2-40B4-BE49-F238E27FC236}">
-                <a16:creationId xmlns:a16="http://schemas.microsoft.com/office/drawing/2014/main" id="{DA82FC42-5EFA-4053-BF4B-E1C8156D55A6}"/>
+                <a16:creationId xmlns:a16="http://schemas.microsoft.com/office/drawing/2014/main" id="{DDAD7D57-F383-4691-948A-FA65A43EEF6A}"/>
               </a:ext>
             </a:extLst>
           </p:cNvPr>
@@ -2887,7 +2660,7 @@
           <p:cNvPr id="9" name="">
             <a:extLst xmlns:a="http://schemas.openxmlformats.org/drawingml/2006/main">
               <a:ext uri="{FF2B5EF4-FFF2-40B4-BE49-F238E27FC236}">
-                <a16:creationId xmlns:a16="http://schemas.microsoft.com/office/drawing/2014/main" id="{5D301109-63F1-40E2-8234-149C0044FA82}"/>
+                <a16:creationId xmlns:a16="http://schemas.microsoft.com/office/drawing/2014/main" id="{4B1A5CD5-4FAF-48A5-BA77-0B133B21419B}"/>
               </a:ext>
             </a:extLst>
           </p:cNvPr>
@@ -2937,7 +2710,7 @@
           <p:cNvPr id="10" name="">
             <a:extLst xmlns:a="http://schemas.openxmlformats.org/drawingml/2006/main">
               <a:ext uri="{FF2B5EF4-FFF2-40B4-BE49-F238E27FC236}">
-                <a16:creationId xmlns:a16="http://schemas.microsoft.com/office/drawing/2014/main" id="{492620AC-8C0C-4B13-A5D3-47AB18B5AECF}"/>
+                <a16:creationId xmlns:a16="http://schemas.microsoft.com/office/drawing/2014/main" id="{DD3E4BAD-EDEC-4B77-A112-E09BC0CB16EF}"/>
               </a:ext>
             </a:extLst>
           </p:cNvPr>
@@ -2974,7 +2747,7 @@
           <p:nvPr/>
         </p:nvPicPr>
         <p:blipFill>
-          <a:blip xmlns:r="http://schemas.openxmlformats.org/officeDocument/2006/relationships" xmlns:a="http://schemas.openxmlformats.org/drawingml/2006/main" r:embed="R31e9cf3e6fa24a68"/>
+          <a:blip xmlns:r="http://schemas.openxmlformats.org/officeDocument/2006/relationships" xmlns:a="http://schemas.openxmlformats.org/drawingml/2006/main" r:embed="R06ef710f93674f05"/>
           <a:stretch xmlns:a="http://schemas.openxmlformats.org/drawingml/2006/main"/>
         </p:blipFill>
         <p:spPr>
@@ -2992,7 +2765,7 @@
           <p:cNvPr id="12" name="">
             <a:extLst xmlns:a="http://schemas.openxmlformats.org/drawingml/2006/main">
               <a:ext uri="{FF2B5EF4-FFF2-40B4-BE49-F238E27FC236}">
-                <a16:creationId xmlns:a16="http://schemas.microsoft.com/office/drawing/2014/main" id="{A5774E7C-22DF-4A07-B4AA-08B6E0679938}"/>
+                <a16:creationId xmlns:a16="http://schemas.microsoft.com/office/drawing/2014/main" id="{790790DE-394D-4B2C-B10B-A6E2F755AB38}"/>
               </a:ext>
             </a:extLst>
           </p:cNvPr>
@@ -3042,7 +2815,7 @@
           <p:cNvPr id="13" name="">
             <a:extLst xmlns:a="http://schemas.openxmlformats.org/drawingml/2006/main">
               <a:ext uri="{FF2B5EF4-FFF2-40B4-BE49-F238E27FC236}">
-                <a16:creationId xmlns:a16="http://schemas.microsoft.com/office/drawing/2014/main" id="{D9681BA3-31F5-4F97-871C-2E2ECC828CDC}"/>
+                <a16:creationId xmlns:a16="http://schemas.microsoft.com/office/drawing/2014/main" id="{3B301526-C734-43C9-AED1-CC9B3E5F2548}"/>
               </a:ext>
             </a:extLst>
           </p:cNvPr>
@@ -3077,7 +2850,7 @@
           <p:cNvPr id="14" name="">
             <a:extLst xmlns:a="http://schemas.openxmlformats.org/drawingml/2006/main">
               <a:ext uri="{FF2B5EF4-FFF2-40B4-BE49-F238E27FC236}">
-                <a16:creationId xmlns:a16="http://schemas.microsoft.com/office/drawing/2014/main" id="{E89E1514-66B5-470C-94A1-0244EB04A252}"/>
+                <a16:creationId xmlns:a16="http://schemas.microsoft.com/office/drawing/2014/main" id="{CDBE98AD-4AD5-40BB-96AD-A4E3970D7085}"/>
               </a:ext>
             </a:extLst>
           </p:cNvPr>
@@ -3108,7 +2881,7 @@
           <p:cNvPr id="15" name="">
             <a:extLst xmlns:a="http://schemas.openxmlformats.org/drawingml/2006/main">
               <a:ext uri="{FF2B5EF4-FFF2-40B4-BE49-F238E27FC236}">
-                <a16:creationId xmlns:a16="http://schemas.microsoft.com/office/drawing/2014/main" id="{C879CB23-D7EB-40C3-AD0A-5F465F3D8E89}"/>
+                <a16:creationId xmlns:a16="http://schemas.microsoft.com/office/drawing/2014/main" id="{63596380-8074-45EC-91A2-B879864B7C2F}"/>
               </a:ext>
             </a:extLst>
           </p:cNvPr>
@@ -3158,7 +2931,7 @@
           <p:cNvPr id="16" name="">
             <a:extLst xmlns:a="http://schemas.openxmlformats.org/drawingml/2006/main">
               <a:ext uri="{FF2B5EF4-FFF2-40B4-BE49-F238E27FC236}">
-                <a16:creationId xmlns:a16="http://schemas.microsoft.com/office/drawing/2014/main" id="{A6B61FD7-E123-4B12-AA13-8D9B1F9BD553}"/>
+                <a16:creationId xmlns:a16="http://schemas.microsoft.com/office/drawing/2014/main" id="{1AB44BE2-6E9E-4270-AB0C-DFB9B69A6A9C}"/>
               </a:ext>
             </a:extLst>
           </p:cNvPr>
@@ -3208,7 +2981,7 @@
           <p:cNvPr id="17" name="">
             <a:extLst xmlns:a="http://schemas.openxmlformats.org/drawingml/2006/main">
               <a:ext uri="{FF2B5EF4-FFF2-40B4-BE49-F238E27FC236}">
-                <a16:creationId xmlns:a16="http://schemas.microsoft.com/office/drawing/2014/main" id="{8D94F581-CA37-4819-A650-5FE872DA0628}"/>
+                <a16:creationId xmlns:a16="http://schemas.microsoft.com/office/drawing/2014/main" id="{4CC6B539-9698-4BFC-A6EC-AF02C426E77C}"/>
               </a:ext>
             </a:extLst>
           </p:cNvPr>
@@ -3245,7 +3018,7 @@
           <p:nvPr/>
         </p:nvPicPr>
         <p:blipFill>
-          <a:blip xmlns:r="http://schemas.openxmlformats.org/officeDocument/2006/relationships" xmlns:a="http://schemas.openxmlformats.org/drawingml/2006/main" r:embed="R136ca5c7e6ba4ec3"/>
+          <a:blip xmlns:r="http://schemas.openxmlformats.org/officeDocument/2006/relationships" xmlns:a="http://schemas.openxmlformats.org/drawingml/2006/main" r:embed="Rd2d00e27299a4632"/>
           <a:stretch xmlns:a="http://schemas.openxmlformats.org/drawingml/2006/main"/>
         </p:blipFill>
         <p:spPr>
@@ -3263,7 +3036,7 @@
           <p:cNvPr id="19" name="">
             <a:extLst xmlns:a="http://schemas.openxmlformats.org/drawingml/2006/main">
               <a:ext uri="{FF2B5EF4-FFF2-40B4-BE49-F238E27FC236}">
-                <a16:creationId xmlns:a16="http://schemas.microsoft.com/office/drawing/2014/main" id="{C28BA802-C7D2-430E-A6D5-6106EA711066}"/>
+                <a16:creationId xmlns:a16="http://schemas.microsoft.com/office/drawing/2014/main" id="{4A1D4ED4-9BCD-404D-9C95-41ABF8F2AA39}"/>
               </a:ext>
             </a:extLst>
           </p:cNvPr>
@@ -3313,7 +3086,7 @@
           <p:cNvPr id="20" name="">
             <a:extLst xmlns:a="http://schemas.openxmlformats.org/drawingml/2006/main">
               <a:ext uri="{FF2B5EF4-FFF2-40B4-BE49-F238E27FC236}">
-                <a16:creationId xmlns:a16="http://schemas.microsoft.com/office/drawing/2014/main" id="{681DA1B3-8D73-4A65-9C16-C2FC6CA6B706}"/>
+                <a16:creationId xmlns:a16="http://schemas.microsoft.com/office/drawing/2014/main" id="{8EA98E99-D9A3-4505-9616-DBB6DB354185}"/>
               </a:ext>
             </a:extLst>
           </p:cNvPr>
@@ -3348,7 +3121,7 @@
           <p:cNvPr id="21" name="">
             <a:extLst xmlns:a="http://schemas.openxmlformats.org/drawingml/2006/main">
               <a:ext uri="{FF2B5EF4-FFF2-40B4-BE49-F238E27FC236}">
-                <a16:creationId xmlns:a16="http://schemas.microsoft.com/office/drawing/2014/main" id="{B0833DA8-88F9-4260-BB18-4DF60744A13C}"/>
+                <a16:creationId xmlns:a16="http://schemas.microsoft.com/office/drawing/2014/main" id="{9DD40442-5422-407D-B9AF-09BA4DD5E879}"/>
               </a:ext>
             </a:extLst>
           </p:cNvPr>
@@ -3379,7 +3152,7 @@
           <p:cNvPr id="22" name="">
             <a:extLst xmlns:a="http://schemas.openxmlformats.org/drawingml/2006/main">
               <a:ext uri="{FF2B5EF4-FFF2-40B4-BE49-F238E27FC236}">
-                <a16:creationId xmlns:a16="http://schemas.microsoft.com/office/drawing/2014/main" id="{DD4AF3FB-E7C7-41AA-9E97-57AB279F19C7}"/>
+                <a16:creationId xmlns:a16="http://schemas.microsoft.com/office/drawing/2014/main" id="{488C2344-274F-4039-8BF5-676D952310AC}"/>
               </a:ext>
             </a:extLst>
           </p:cNvPr>
@@ -3429,7 +3202,7 @@
           <p:cNvPr id="23" name="">
             <a:extLst xmlns:a="http://schemas.openxmlformats.org/drawingml/2006/main">
               <a:ext uri="{FF2B5EF4-FFF2-40B4-BE49-F238E27FC236}">
-                <a16:creationId xmlns:a16="http://schemas.microsoft.com/office/drawing/2014/main" id="{0095E553-D1CF-46AB-811D-68E2BE7FBFA2}"/>
+                <a16:creationId xmlns:a16="http://schemas.microsoft.com/office/drawing/2014/main" id="{CF9D5C35-DD75-43CB-BD5B-65D9FE18691A}"/>
               </a:ext>
             </a:extLst>
           </p:cNvPr>
@@ -3479,7 +3252,7 @@
           <p:cNvPr id="24" name="">
             <a:extLst xmlns:a="http://schemas.openxmlformats.org/drawingml/2006/main">
               <a:ext uri="{FF2B5EF4-FFF2-40B4-BE49-F238E27FC236}">
-                <a16:creationId xmlns:a16="http://schemas.microsoft.com/office/drawing/2014/main" id="{79C60110-977F-4D10-B8F7-D066D4A14DAA}"/>
+                <a16:creationId xmlns:a16="http://schemas.microsoft.com/office/drawing/2014/main" id="{9313F59F-E6EC-4148-93E4-2B0DC7B5E5BC}"/>
               </a:ext>
             </a:extLst>
           </p:cNvPr>
@@ -3516,7 +3289,7 @@
           <p:nvPr/>
         </p:nvPicPr>
         <p:blipFill>
-          <a:blip xmlns:r="http://schemas.openxmlformats.org/officeDocument/2006/relationships" xmlns:a="http://schemas.openxmlformats.org/drawingml/2006/main" r:embed="Re81bb29a18dd499a"/>
+          <a:blip xmlns:r="http://schemas.openxmlformats.org/officeDocument/2006/relationships" xmlns:a="http://schemas.openxmlformats.org/drawingml/2006/main" r:embed="R0de50503837640a5"/>
           <a:stretch xmlns:a="http://schemas.openxmlformats.org/drawingml/2006/main"/>
         </p:blipFill>
         <p:spPr>
@@ -3534,7 +3307,7 @@
           <p:cNvPr id="26" name="">
             <a:extLst xmlns:a="http://schemas.openxmlformats.org/drawingml/2006/main">
               <a:ext uri="{FF2B5EF4-FFF2-40B4-BE49-F238E27FC236}">
-                <a16:creationId xmlns:a16="http://schemas.microsoft.com/office/drawing/2014/main" id="{DCE2BB5E-4BE7-4454-8339-0C3E0E11DDE0}"/>
+                <a16:creationId xmlns:a16="http://schemas.microsoft.com/office/drawing/2014/main" id="{FAC7CD07-D44A-4674-B6CE-0610187069FA}"/>
               </a:ext>
             </a:extLst>
           </p:cNvPr>
@@ -3636,7 +3409,7 @@
           <p:cNvPr id="29" name="">
             <a:extLst xmlns:a="http://schemas.openxmlformats.org/drawingml/2006/main">
               <a:ext uri="{FF2B5EF4-FFF2-40B4-BE49-F238E27FC236}">
-                <a16:creationId xmlns:a16="http://schemas.microsoft.com/office/drawing/2014/main" id="{A81BCE90-7AF3-4B9B-9B74-70FD1227DE9B}"/>
+                <a16:creationId xmlns:a16="http://schemas.microsoft.com/office/drawing/2014/main" id="{D7D01618-C4FC-4606-B4CC-035D8B00D47E}"/>
               </a:ext>
             </a:extLst>
           </p:cNvPr>
@@ -3684,7 +3457,7 @@
     </p:spTree>
     <p:extLst>
       <p:ext uri="{BB962C8B-B14F-4D97-AF65-F5344CB8AC3E}">
-        <p14:creationId xmlns:p14="http://schemas.microsoft.com/office/powerpoint/2010/main" val="1403947180"/>
+        <p14:creationId xmlns:p14="http://schemas.microsoft.com/office/powerpoint/2010/main" val="1987299535"/>
       </p:ext>
     </p:extLst>
   </p:cSld>
@@ -3712,10 +3485,10 @@
       </p:grpSpPr>
       <p:sp>
         <p:nvSpPr>
-          <p:cNvPr id="17" name="">
-            <a:extLst xmlns:a="http://schemas.openxmlformats.org/drawingml/2006/main">
-              <a:ext uri="{FF2B5EF4-FFF2-40B4-BE49-F238E27FC236}">
-                <a16:creationId xmlns:a16="http://schemas.microsoft.com/office/drawing/2014/main" id="{4457BEE6-D79F-46AB-830B-3DA9838AFB0B}"/>
+          <p:cNvPr id="33" name="">
+            <a:extLst xmlns:a="http://schemas.openxmlformats.org/drawingml/2006/main">
+              <a:ext uri="{FF2B5EF4-FFF2-40B4-BE49-F238E27FC236}">
+                <a16:creationId xmlns:a16="http://schemas.microsoft.com/office/drawing/2014/main" id="{02BA62A0-1D15-4D7A-A385-4D232C1B66FC}"/>
               </a:ext>
             </a:extLst>
           </p:cNvPr>
@@ -3765,7 +3538,7 @@
           <p:cNvPr id="2" name="">
             <a:extLst xmlns:a="http://schemas.openxmlformats.org/drawingml/2006/main">
               <a:ext uri="{FF2B5EF4-FFF2-40B4-BE49-F238E27FC236}">
-                <a16:creationId xmlns:a16="http://schemas.microsoft.com/office/drawing/2014/main" id="{B5DF0728-3739-4E35-ACAA-4B91BE9017F2}"/>
+                <a16:creationId xmlns:a16="http://schemas.microsoft.com/office/drawing/2014/main" id="{616E35B6-E823-48F9-A874-06C60784F92F}"/>
               </a:ext>
             </a:extLst>
           </p:cNvPr>
@@ -3815,7 +3588,7 @@
           <p:cNvPr id="3" name="">
             <a:extLst xmlns:a="http://schemas.openxmlformats.org/drawingml/2006/main">
               <a:ext uri="{FF2B5EF4-FFF2-40B4-BE49-F238E27FC236}">
-                <a16:creationId xmlns:a16="http://schemas.microsoft.com/office/drawing/2014/main" id="{284477E4-0FD6-40B7-82D2-C299F31EB9A9}"/>
+                <a16:creationId xmlns:a16="http://schemas.microsoft.com/office/drawing/2014/main" id="{5A73A0FB-644E-4E18-812E-E85213720D54}"/>
               </a:ext>
             </a:extLst>
           </p:cNvPr>
@@ -3846,7 +3619,7 @@
           <p:cNvPr id="4" name="">
             <a:extLst xmlns:a="http://schemas.openxmlformats.org/drawingml/2006/main">
               <a:ext uri="{FF2B5EF4-FFF2-40B4-BE49-F238E27FC236}">
-                <a16:creationId xmlns:a16="http://schemas.microsoft.com/office/drawing/2014/main" id="{34CF6E4A-C1C5-4AB0-BD43-F9BB0F5146A3}"/>
+                <a16:creationId xmlns:a16="http://schemas.microsoft.com/office/drawing/2014/main" id="{6078E351-1F92-41F9-842E-123B21F36B73}"/>
               </a:ext>
             </a:extLst>
           </p:cNvPr>
@@ -3877,7 +3650,7 @@
           <p:cNvPr id="5" name="">
             <a:extLst xmlns:a="http://schemas.openxmlformats.org/drawingml/2006/main">
               <a:ext uri="{FF2B5EF4-FFF2-40B4-BE49-F238E27FC236}">
-                <a16:creationId xmlns:a16="http://schemas.microsoft.com/office/drawing/2014/main" id="{7CCC5ECF-6464-49CB-ACD2-F8017E794E8E}"/>
+                <a16:creationId xmlns:a16="http://schemas.microsoft.com/office/drawing/2014/main" id="{BE701488-0457-4CAF-8BB8-A783E6934E2B}"/>
               </a:ext>
             </a:extLst>
           </p:cNvPr>
@@ -3927,7 +3700,7 @@
           <p:cNvPr id="6" name="">
             <a:extLst xmlns:a="http://schemas.openxmlformats.org/drawingml/2006/main">
               <a:ext uri="{FF2B5EF4-FFF2-40B4-BE49-F238E27FC236}">
-                <a16:creationId xmlns:a16="http://schemas.microsoft.com/office/drawing/2014/main" id="{FEA4DB6E-4404-4A49-9986-B020D3C8FAF7}"/>
+                <a16:creationId xmlns:a16="http://schemas.microsoft.com/office/drawing/2014/main" id="{77E1FD0D-FF59-48D9-A9E1-21C57FEE8168}"/>
               </a:ext>
             </a:extLst>
           </p:cNvPr>
@@ -3959,14 +3732,14 @@
       </p:sp>
       <p:pic>
         <p:nvPicPr>
-          <p:cNvPr id="23" name=""/>
+          <p:cNvPr id="39" name=""/>
           <p:cNvPicPr>
             <a:picLocks xmlns:a="http://schemas.openxmlformats.org/drawingml/2006/main" noChangeAspect="1"/>
           </p:cNvPicPr>
           <p:nvPr/>
         </p:nvPicPr>
         <p:blipFill>
-          <a:blip xmlns:r="http://schemas.openxmlformats.org/officeDocument/2006/relationships" xmlns:a="http://schemas.openxmlformats.org/drawingml/2006/main" r:embed="R0d694010c2b3402d"/>
+          <a:blip xmlns:r="http://schemas.openxmlformats.org/officeDocument/2006/relationships" xmlns:a="http://schemas.openxmlformats.org/drawingml/2006/main" r:embed="Rc25c206abcd747dc"/>
           <a:stretch xmlns:a="http://schemas.openxmlformats.org/drawingml/2006/main"/>
         </p:blipFill>
         <p:spPr>
@@ -3984,7 +3757,7 @@
           <p:cNvPr id="8" name="">
             <a:extLst xmlns:a="http://schemas.openxmlformats.org/drawingml/2006/main">
               <a:ext uri="{FF2B5EF4-FFF2-40B4-BE49-F238E27FC236}">
-                <a16:creationId xmlns:a16="http://schemas.microsoft.com/office/drawing/2014/main" id="{9B8F32ED-519E-458A-9706-89B78B5EE88F}"/>
+                <a16:creationId xmlns:a16="http://schemas.microsoft.com/office/drawing/2014/main" id="{88AC38AC-8D6C-4CDE-AB5A-8088D78CC67F}"/>
               </a:ext>
             </a:extLst>
           </p:cNvPr>
@@ -4034,7 +3807,7 @@
           <p:cNvPr id="9" name="">
             <a:extLst xmlns:a="http://schemas.openxmlformats.org/drawingml/2006/main">
               <a:ext uri="{FF2B5EF4-FFF2-40B4-BE49-F238E27FC236}">
-                <a16:creationId xmlns:a16="http://schemas.microsoft.com/office/drawing/2014/main" id="{34AB2EBB-CC7C-4D72-B373-146B415AAE2C}"/>
+                <a16:creationId xmlns:a16="http://schemas.microsoft.com/office/drawing/2014/main" id="{815DD0C0-54E4-4995-A3E6-647E2151864B}"/>
               </a:ext>
             </a:extLst>
           </p:cNvPr>
@@ -4066,14 +3839,14 @@
       </p:sp>
       <p:pic>
         <p:nvPicPr>
-          <p:cNvPr id="26" name=""/>
+          <p:cNvPr id="42" name=""/>
           <p:cNvPicPr>
             <a:picLocks xmlns:a="http://schemas.openxmlformats.org/drawingml/2006/main" noChangeAspect="1"/>
           </p:cNvPicPr>
           <p:nvPr/>
         </p:nvPicPr>
         <p:blipFill>
-          <a:blip xmlns:r="http://schemas.openxmlformats.org/officeDocument/2006/relationships" xmlns:a="http://schemas.openxmlformats.org/drawingml/2006/main" r:embed="R846e7ccae3a04615"/>
+          <a:blip xmlns:r="http://schemas.openxmlformats.org/officeDocument/2006/relationships" xmlns:a="http://schemas.openxmlformats.org/drawingml/2006/main" r:embed="Rf6fb36e636b54bf6"/>
           <a:stretch xmlns:a="http://schemas.openxmlformats.org/drawingml/2006/main"/>
         </p:blipFill>
         <p:spPr>
@@ -4091,7 +3864,7 @@
           <p:cNvPr id="11" name="">
             <a:extLst xmlns:a="http://schemas.openxmlformats.org/drawingml/2006/main">
               <a:ext uri="{FF2B5EF4-FFF2-40B4-BE49-F238E27FC236}">
-                <a16:creationId xmlns:a16="http://schemas.microsoft.com/office/drawing/2014/main" id="{73FF3B17-71D9-4F81-9D3B-B1530B6C4B87}"/>
+                <a16:creationId xmlns:a16="http://schemas.microsoft.com/office/drawing/2014/main" id="{43C9688C-18B5-4349-8207-320248F6ED98}"/>
               </a:ext>
             </a:extLst>
           </p:cNvPr>
@@ -4141,19 +3914,54 @@
           <p:cNvPr id="12" name="">
             <a:extLst xmlns:a="http://schemas.openxmlformats.org/drawingml/2006/main">
               <a:ext uri="{FF2B5EF4-FFF2-40B4-BE49-F238E27FC236}">
-                <a16:creationId xmlns:a16="http://schemas.microsoft.com/office/drawing/2014/main" id="{E48D0ACC-2D54-4010-8FAE-12058C249E02}"/>
-              </a:ext>
-            </a:extLst>
-          </p:cNvPr>
-          <p:cNvSpPr>
-            <a:spLocks xmlns:a="http://schemas.openxmlformats.org/drawingml/2006/main" noGrp="1"/>
-          </p:cNvSpPr>
-          <p:nvPr/>
-        </p:nvSpPr>
-        <p:spPr>
-          <a:xfrm xmlns:a="http://schemas.openxmlformats.org/drawingml/2006/main">
-            <a:off x="5962650" y="1362075"/>
-            <a:ext cx="4953000" cy="323850"/>
+                <a16:creationId xmlns:a16="http://schemas.microsoft.com/office/drawing/2014/main" id="{7C63B1CE-38A4-4C22-871F-4A811FA22D63}"/>
+              </a:ext>
+            </a:extLst>
+          </p:cNvPr>
+          <p:cNvSpPr>
+            <a:spLocks xmlns:a="http://schemas.openxmlformats.org/drawingml/2006/main" noGrp="1"/>
+          </p:cNvSpPr>
+          <p:nvPr/>
+        </p:nvSpPr>
+        <p:spPr>
+          <a:xfrm xmlns:a="http://schemas.openxmlformats.org/drawingml/2006/main">
+            <a:off x="5772150" y="1276350"/>
+            <a:ext cx="5867400" cy="4772025"/>
+          </a:xfrm>
+          <a:prstGeom xmlns:a="http://schemas.openxmlformats.org/drawingml/2006/main" prst="roundRect">
+            <a:avLst>
+              <a:gd name="adj" fmla="val 798"/>
+            </a:avLst>
+          </a:prstGeom>
+          <a:solidFill xmlns:a="http://schemas.openxmlformats.org/drawingml/2006/main">
+            <a:srgbClr val="F6F8F9"/>
+          </a:solidFill>
+          <a:ln xmlns:a="http://schemas.openxmlformats.org/drawingml/2006/main" w="9525">
+            <a:solidFill>
+              <a:srgbClr val="CDD7DD"/>
+            </a:solidFill>
+            <a:prstDash val="solid"/>
+          </a:ln>
+        </p:spPr>
+      </p:sp>
+      <p:sp>
+        <p:nvSpPr>
+          <p:cNvPr id="13" name="">
+            <a:extLst xmlns:a="http://schemas.openxmlformats.org/drawingml/2006/main">
+              <a:ext uri="{FF2B5EF4-FFF2-40B4-BE49-F238E27FC236}">
+                <a16:creationId xmlns:a16="http://schemas.microsoft.com/office/drawing/2014/main" id="{2BC3B183-26E7-423C-AF09-10D77D7DAD59}"/>
+              </a:ext>
+            </a:extLst>
+          </p:cNvPr>
+          <p:cNvSpPr>
+            <a:spLocks xmlns:a="http://schemas.openxmlformats.org/drawingml/2006/main" noGrp="1"/>
+          </p:cNvSpPr>
+          <p:nvPr/>
+        </p:nvSpPr>
+        <p:spPr>
+          <a:xfrm xmlns:a="http://schemas.openxmlformats.org/drawingml/2006/main">
+            <a:off x="6019800" y="1438275"/>
+            <a:ext cx="5257800" cy="419100"/>
           </a:xfrm>
           <a:prstGeom xmlns:a="http://schemas.openxmlformats.org/drawingml/2006/main" prst="rect">
             <a:avLst/>
@@ -4181,56 +3989,38 @@
                   <a:srgbClr val="1F2933"/>
                 </a:solidFill>
               </a:rPr>
-              <a:t>Transferred port flow</a:t>
-            </a:r>
-          </a:p>
-        </p:txBody>
-      </p:sp>
-      <p:graphicFrame>
-        <p:nvGraphicFramePr>
-          <p:cNvPr id="29" name="Chart"/>
-          <p:cNvGraphicFramePr/>
-          <p:nvPr/>
-        </p:nvGraphicFramePr>
-        <p:xfrm>
-          <a:off xmlns:a="http://schemas.openxmlformats.org/drawingml/2006/main" x="5829300" y="1752600"/>
-          <a:ext xmlns:a="http://schemas.openxmlformats.org/drawingml/2006/main" cx="5524500" cy="2952750"/>
-        </p:xfrm>
-        <a:graphic xmlns:a="http://schemas.openxmlformats.org/drawingml/2006/main">
-          <a:graphicData uri="http://schemas.openxmlformats.org/drawingml/2006/chart">
-            <c:chart xmlns:r="http://schemas.openxmlformats.org/officeDocument/2006/relationships" xmlns:c="http://schemas.openxmlformats.org/drawingml/2006/chart" r:id="R7cbac23651a64bf4"/>
-          </a:graphicData>
-        </a:graphic>
-      </p:graphicFrame>
+              <a:t>How the 3D boundary conditions are constructed</a:t>
+            </a:r>
+          </a:p>
+        </p:txBody>
+      </p:sp>
       <p:sp>
         <p:nvSpPr>
           <p:cNvPr id="14" name="">
             <a:extLst xmlns:a="http://schemas.openxmlformats.org/drawingml/2006/main">
               <a:ext uri="{FF2B5EF4-FFF2-40B4-BE49-F238E27FC236}">
-                <a16:creationId xmlns:a16="http://schemas.microsoft.com/office/drawing/2014/main" id="{55675014-1027-48A7-9A66-40BD2C00BF83}"/>
-              </a:ext>
-            </a:extLst>
-          </p:cNvPr>
-          <p:cNvSpPr>
-            <a:spLocks xmlns:a="http://schemas.openxmlformats.org/drawingml/2006/main" noGrp="1"/>
-          </p:cNvSpPr>
-          <p:nvPr/>
-        </p:nvSpPr>
-        <p:spPr>
-          <a:xfrm xmlns:a="http://schemas.openxmlformats.org/drawingml/2006/main">
-            <a:off x="5962650" y="4876800"/>
-            <a:ext cx="5295900" cy="1076325"/>
-          </a:xfrm>
-          <a:prstGeom xmlns:a="http://schemas.openxmlformats.org/drawingml/2006/main" prst="roundRect">
-            <a:avLst>
-              <a:gd name="adj" fmla="val 3540"/>
-            </a:avLst>
-          </a:prstGeom>
-          <a:solidFill xmlns:a="http://schemas.openxmlformats.org/drawingml/2006/main">
-            <a:srgbClr val="EEF4F5"/>
-          </a:solidFill>
-          <a:ln xmlns:a="http://schemas.openxmlformats.org/drawingml/2006/main" w="0">
-            <a:noFill/>
+                <a16:creationId xmlns:a16="http://schemas.microsoft.com/office/drawing/2014/main" id="{BCADB7AF-9B13-43A3-9BB8-6D2AC7D9574A}"/>
+              </a:ext>
+            </a:extLst>
+          </p:cNvPr>
+          <p:cNvSpPr>
+            <a:spLocks xmlns:a="http://schemas.openxmlformats.org/drawingml/2006/main" noGrp="1"/>
+          </p:cNvSpPr>
+          <p:nvPr/>
+        </p:nvSpPr>
+        <p:spPr>
+          <a:xfrm xmlns:a="http://schemas.openxmlformats.org/drawingml/2006/main">
+            <a:off x="6019800" y="1952625"/>
+            <a:ext cx="5372100" cy="0"/>
+          </a:xfrm>
+          <a:prstGeom xmlns:a="http://schemas.openxmlformats.org/drawingml/2006/main" prst="line">
+            <a:avLst/>
+          </a:prstGeom>
+          <a:noFill xmlns:a="http://schemas.openxmlformats.org/drawingml/2006/main"/>
+          <a:ln xmlns:a="http://schemas.openxmlformats.org/drawingml/2006/main" w="9525">
+            <a:solidFill>
+              <a:srgbClr val="CDD7DD"/>
+            </a:solidFill>
             <a:prstDash val="solid"/>
           </a:ln>
         </p:spPr>
@@ -4240,19 +4030,19 @@
           <p:cNvPr id="15" name="">
             <a:extLst xmlns:a="http://schemas.openxmlformats.org/drawingml/2006/main">
               <a:ext uri="{FF2B5EF4-FFF2-40B4-BE49-F238E27FC236}">
-                <a16:creationId xmlns:a16="http://schemas.microsoft.com/office/drawing/2014/main" id="{5CA46FF1-514D-4333-9F7A-4F50C25B4849}"/>
-              </a:ext>
-            </a:extLst>
-          </p:cNvPr>
-          <p:cNvSpPr>
-            <a:spLocks xmlns:a="http://schemas.openxmlformats.org/drawingml/2006/main" noGrp="1"/>
-          </p:cNvSpPr>
-          <p:nvPr/>
-        </p:nvSpPr>
-        <p:spPr>
-          <a:xfrm xmlns:a="http://schemas.openxmlformats.org/drawingml/2006/main">
-            <a:off x="6172200" y="5057775"/>
-            <a:ext cx="2095500" cy="266700"/>
+                <a16:creationId xmlns:a16="http://schemas.microsoft.com/office/drawing/2014/main" id="{9344BA65-653C-47B2-A208-D68F7EF03062}"/>
+              </a:ext>
+            </a:extLst>
+          </p:cNvPr>
+          <p:cNvSpPr>
+            <a:spLocks xmlns:a="http://schemas.openxmlformats.org/drawingml/2006/main" noGrp="1"/>
+          </p:cNvSpPr>
+          <p:nvPr/>
+        </p:nvSpPr>
+        <p:spPr>
+          <a:xfrm xmlns:a="http://schemas.openxmlformats.org/drawingml/2006/main">
+            <a:off x="6019800" y="2095500"/>
+            <a:ext cx="4953000" cy="266700"/>
           </a:xfrm>
           <a:prstGeom xmlns:a="http://schemas.openxmlformats.org/drawingml/2006/main" prst="rect">
             <a:avLst/>
@@ -4268,19 +4058,19 @@
           <a:lstStyle xmlns:a="http://schemas.openxmlformats.org/drawingml/2006/main"/>
           <a:p xmlns:a="http://schemas.openxmlformats.org/drawingml/2006/main">
             <a:pPr algn="l">
-              <a:defRPr sz="1500" b="1">
+              <a:defRPr sz="1350" b="1">
                 <a:solidFill>
                   <a:srgbClr val="163A5F"/>
                 </a:solidFill>
               </a:defRPr>
             </a:pPr>
             <a:r>
-              <a:rPr sz="1500" b="1">
+              <a:rPr sz="1350" b="1">
                 <a:solidFill>
                   <a:srgbClr val="163A5F"/>
                 </a:solidFill>
               </a:rPr>
-              <a:t>1 inlet · 3 outlets</a:t>
+              <a:t>1 · Solve the 1D hydraulic network</a:t>
             </a:r>
           </a:p>
         </p:txBody>
@@ -4290,19 +4080,119 @@
           <p:cNvPr id="16" name="">
             <a:extLst xmlns:a="http://schemas.openxmlformats.org/drawingml/2006/main">
               <a:ext uri="{FF2B5EF4-FFF2-40B4-BE49-F238E27FC236}">
-                <a16:creationId xmlns:a16="http://schemas.microsoft.com/office/drawing/2014/main" id="{187CD680-1E4D-4A58-9C5B-C1E504BF9457}"/>
-              </a:ext>
-            </a:extLst>
-          </p:cNvPr>
-          <p:cNvSpPr>
-            <a:spLocks xmlns:a="http://schemas.openxmlformats.org/drawingml/2006/main" noGrp="1"/>
-          </p:cNvSpPr>
-          <p:nvPr/>
-        </p:nvSpPr>
-        <p:spPr>
-          <a:xfrm xmlns:a="http://schemas.openxmlformats.org/drawingml/2006/main">
-            <a:off x="6172200" y="5410200"/>
-            <a:ext cx="4686300" cy="428625"/>
+                <a16:creationId xmlns:a16="http://schemas.microsoft.com/office/drawing/2014/main" id="{81A99199-8AD5-4EE3-B101-DB47F4623B76}"/>
+              </a:ext>
+            </a:extLst>
+          </p:cNvPr>
+          <p:cNvSpPr>
+            <a:spLocks xmlns:a="http://schemas.openxmlformats.org/drawingml/2006/main" noGrp="1"/>
+          </p:cNvSpPr>
+          <p:nvPr/>
+        </p:nvSpPr>
+        <p:spPr>
+          <a:xfrm xmlns:a="http://schemas.openxmlformats.org/drawingml/2006/main">
+            <a:off x="6019800" y="2409825"/>
+            <a:ext cx="1676400" cy="314325"/>
+          </a:xfrm>
+          <a:prstGeom xmlns:a="http://schemas.openxmlformats.org/drawingml/2006/main" prst="rect">
+            <a:avLst/>
+          </a:prstGeom>
+          <a:noFill xmlns:a="http://schemas.openxmlformats.org/drawingml/2006/main"/>
+          <a:ln xmlns:a="http://schemas.openxmlformats.org/drawingml/2006/main" w="0">
+            <a:noFill/>
+            <a:prstDash val="solid"/>
+          </a:ln>
+        </p:spPr>
+        <p:txBody>
+          <a:bodyPr xmlns:a="http://schemas.openxmlformats.org/drawingml/2006/main"/>
+          <a:lstStyle xmlns:a="http://schemas.openxmlformats.org/drawingml/2006/main"/>
+          <a:p xmlns:a="http://schemas.openxmlformats.org/drawingml/2006/main">
+            <a:pPr algn="l">
+              <a:defRPr sz="1800" b="1">
+                <a:solidFill>
+                  <a:srgbClr val="1F2933"/>
+                </a:solidFill>
+              </a:defRPr>
+            </a:pPr>
+            <a:r>
+              <a:rPr sz="1800" b="1">
+                <a:solidFill>
+                  <a:srgbClr val="1F2933"/>
+                </a:solidFill>
+              </a:rPr>
+              <a:t>Q = Δp / R</a:t>
+            </a:r>
+          </a:p>
+        </p:txBody>
+      </p:sp>
+      <p:sp>
+        <p:nvSpPr>
+          <p:cNvPr id="17" name="">
+            <a:extLst xmlns:a="http://schemas.openxmlformats.org/drawingml/2006/main">
+              <a:ext uri="{FF2B5EF4-FFF2-40B4-BE49-F238E27FC236}">
+                <a16:creationId xmlns:a16="http://schemas.microsoft.com/office/drawing/2014/main" id="{0C366795-4460-4920-A1F1-0767871C4A90}"/>
+              </a:ext>
+            </a:extLst>
+          </p:cNvPr>
+          <p:cNvSpPr>
+            <a:spLocks xmlns:a="http://schemas.openxmlformats.org/drawingml/2006/main" noGrp="1"/>
+          </p:cNvSpPr>
+          <p:nvPr/>
+        </p:nvSpPr>
+        <p:spPr>
+          <a:xfrm xmlns:a="http://schemas.openxmlformats.org/drawingml/2006/main">
+            <a:off x="7839075" y="2428875"/>
+            <a:ext cx="3333750" cy="285750"/>
+          </a:xfrm>
+          <a:prstGeom xmlns:a="http://schemas.openxmlformats.org/drawingml/2006/main" prst="rect">
+            <a:avLst/>
+          </a:prstGeom>
+          <a:noFill xmlns:a="http://schemas.openxmlformats.org/drawingml/2006/main"/>
+          <a:ln xmlns:a="http://schemas.openxmlformats.org/drawingml/2006/main" w="0">
+            <a:noFill/>
+            <a:prstDash val="solid"/>
+          </a:ln>
+        </p:spPr>
+        <p:txBody>
+          <a:bodyPr xmlns:a="http://schemas.openxmlformats.org/drawingml/2006/main"/>
+          <a:lstStyle xmlns:a="http://schemas.openxmlformats.org/drawingml/2006/main"/>
+          <a:p xmlns:a="http://schemas.openxmlformats.org/drawingml/2006/main">
+            <a:pPr algn="l">
+              <a:defRPr sz="1425" b="1">
+                <a:solidFill>
+                  <a:srgbClr val="1F2933"/>
+                </a:solidFill>
+              </a:defRPr>
+            </a:pPr>
+            <a:r>
+              <a:rPr sz="1425" b="1">
+                <a:solidFill>
+                  <a:srgbClr val="1F2933"/>
+                </a:solidFill>
+              </a:rPr>
+              <a:t>R = (8μ/π) ∫₀ᴸ ds / r(s)⁴</a:t>
+            </a:r>
+          </a:p>
+        </p:txBody>
+      </p:sp>
+      <p:sp>
+        <p:nvSpPr>
+          <p:cNvPr id="18" name="">
+            <a:extLst xmlns:a="http://schemas.openxmlformats.org/drawingml/2006/main">
+              <a:ext uri="{FF2B5EF4-FFF2-40B4-BE49-F238E27FC236}">
+                <a16:creationId xmlns:a16="http://schemas.microsoft.com/office/drawing/2014/main" id="{2FF19616-5877-4FAD-8FE7-7E5B1665D3E1}"/>
+              </a:ext>
+            </a:extLst>
+          </p:cNvPr>
+          <p:cNvSpPr>
+            <a:spLocks xmlns:a="http://schemas.openxmlformats.org/drawingml/2006/main" noGrp="1"/>
+          </p:cNvSpPr>
+          <p:nvPr/>
+        </p:nvSpPr>
+        <p:spPr>
+          <a:xfrm xmlns:a="http://schemas.openxmlformats.org/drawingml/2006/main">
+            <a:off x="6019800" y="2762250"/>
+            <a:ext cx="5124450" cy="285750"/>
           </a:xfrm>
           <a:prstGeom xmlns:a="http://schemas.openxmlformats.org/drawingml/2006/main" prst="rect">
             <a:avLst/>
@@ -4330,7 +4220,669 @@
                   <a:srgbClr val="66747E"/>
                 </a:solidFill>
               </a:rPr>
-              <a:t>Outlet flows reproduce the inlet within 4.8 × 10⁻¹⁴ relative mismatch.</a:t>
+              <a:t>Pressure drop, viscosity and vessel radius determine segment flow.</a:t>
+            </a:r>
+          </a:p>
+        </p:txBody>
+      </p:sp>
+      <p:sp>
+        <p:nvSpPr>
+          <p:cNvPr id="19" name="">
+            <a:extLst xmlns:a="http://schemas.openxmlformats.org/drawingml/2006/main">
+              <a:ext uri="{FF2B5EF4-FFF2-40B4-BE49-F238E27FC236}">
+                <a16:creationId xmlns:a16="http://schemas.microsoft.com/office/drawing/2014/main" id="{0575A0B3-FB8F-4BAF-BBFC-E4ABB96C5276}"/>
+              </a:ext>
+            </a:extLst>
+          </p:cNvPr>
+          <p:cNvSpPr>
+            <a:spLocks xmlns:a="http://schemas.openxmlformats.org/drawingml/2006/main" noGrp="1"/>
+          </p:cNvSpPr>
+          <p:nvPr/>
+        </p:nvSpPr>
+        <p:spPr>
+          <a:xfrm xmlns:a="http://schemas.openxmlformats.org/drawingml/2006/main">
+            <a:off x="6019800" y="3133725"/>
+            <a:ext cx="5372100" cy="0"/>
+          </a:xfrm>
+          <a:prstGeom xmlns:a="http://schemas.openxmlformats.org/drawingml/2006/main" prst="line">
+            <a:avLst/>
+          </a:prstGeom>
+          <a:noFill xmlns:a="http://schemas.openxmlformats.org/drawingml/2006/main"/>
+          <a:ln xmlns:a="http://schemas.openxmlformats.org/drawingml/2006/main" w="9525">
+            <a:solidFill>
+              <a:srgbClr val="CDD7DD"/>
+            </a:solidFill>
+            <a:prstDash val="solid"/>
+          </a:ln>
+        </p:spPr>
+      </p:sp>
+      <p:sp>
+        <p:nvSpPr>
+          <p:cNvPr id="20" name="">
+            <a:extLst xmlns:a="http://schemas.openxmlformats.org/drawingml/2006/main">
+              <a:ext uri="{FF2B5EF4-FFF2-40B4-BE49-F238E27FC236}">
+                <a16:creationId xmlns:a16="http://schemas.microsoft.com/office/drawing/2014/main" id="{D4882A02-2794-41BD-89D0-BF04C91D29AC}"/>
+              </a:ext>
+            </a:extLst>
+          </p:cNvPr>
+          <p:cNvSpPr>
+            <a:spLocks xmlns:a="http://schemas.openxmlformats.org/drawingml/2006/main" noGrp="1"/>
+          </p:cNvSpPr>
+          <p:nvPr/>
+        </p:nvSpPr>
+        <p:spPr>
+          <a:xfrm xmlns:a="http://schemas.openxmlformats.org/drawingml/2006/main">
+            <a:off x="6019800" y="3276600"/>
+            <a:ext cx="4953000" cy="266700"/>
+          </a:xfrm>
+          <a:prstGeom xmlns:a="http://schemas.openxmlformats.org/drawingml/2006/main" prst="rect">
+            <a:avLst/>
+          </a:prstGeom>
+          <a:noFill xmlns:a="http://schemas.openxmlformats.org/drawingml/2006/main"/>
+          <a:ln xmlns:a="http://schemas.openxmlformats.org/drawingml/2006/main" w="0">
+            <a:noFill/>
+            <a:prstDash val="solid"/>
+          </a:ln>
+        </p:spPr>
+        <p:txBody>
+          <a:bodyPr xmlns:a="http://schemas.openxmlformats.org/drawingml/2006/main"/>
+          <a:lstStyle xmlns:a="http://schemas.openxmlformats.org/drawingml/2006/main"/>
+          <a:p xmlns:a="http://schemas.openxmlformats.org/drawingml/2006/main">
+            <a:pPr algn="l">
+              <a:defRPr sz="1350" b="1">
+                <a:solidFill>
+                  <a:srgbClr val="2A7F76"/>
+                </a:solidFill>
+              </a:defRPr>
+            </a:pPr>
+            <a:r>
+              <a:rPr sz="1350" b="1">
+                <a:solidFill>
+                  <a:srgbClr val="2A7F76"/>
+                </a:solidFill>
+              </a:rPr>
+              <a:t>2 · Map 1D pressure onto the prepared ports</a:t>
+            </a:r>
+          </a:p>
+        </p:txBody>
+      </p:sp>
+      <p:sp>
+        <p:nvSpPr>
+          <p:cNvPr id="21" name="">
+            <a:extLst xmlns:a="http://schemas.openxmlformats.org/drawingml/2006/main">
+              <a:ext uri="{FF2B5EF4-FFF2-40B4-BE49-F238E27FC236}">
+                <a16:creationId xmlns:a16="http://schemas.microsoft.com/office/drawing/2014/main" id="{4468286F-72DA-443A-8EFF-20428FEB2781}"/>
+              </a:ext>
+            </a:extLst>
+          </p:cNvPr>
+          <p:cNvSpPr>
+            <a:spLocks xmlns:a="http://schemas.openxmlformats.org/drawingml/2006/main" noGrp="1"/>
+          </p:cNvSpPr>
+          <p:nvPr/>
+        </p:nvSpPr>
+        <p:spPr>
+          <a:xfrm xmlns:a="http://schemas.openxmlformats.org/drawingml/2006/main">
+            <a:off x="6019800" y="3581400"/>
+            <a:ext cx="4610100" cy="295275"/>
+          </a:xfrm>
+          <a:prstGeom xmlns:a="http://schemas.openxmlformats.org/drawingml/2006/main" prst="rect">
+            <a:avLst/>
+          </a:prstGeom>
+          <a:noFill xmlns:a="http://schemas.openxmlformats.org/drawingml/2006/main"/>
+          <a:ln xmlns:a="http://schemas.openxmlformats.org/drawingml/2006/main" w="0">
+            <a:noFill/>
+            <a:prstDash val="solid"/>
+          </a:ln>
+        </p:spPr>
+        <p:txBody>
+          <a:bodyPr xmlns:a="http://schemas.openxmlformats.org/drawingml/2006/main"/>
+          <a:lstStyle xmlns:a="http://schemas.openxmlformats.org/drawingml/2006/main"/>
+          <a:p xmlns:a="http://schemas.openxmlformats.org/drawingml/2006/main">
+            <a:pPr algn="l">
+              <a:defRPr sz="1575" b="1">
+                <a:solidFill>
+                  <a:srgbClr val="1F2933"/>
+                </a:solidFill>
+              </a:defRPr>
+            </a:pPr>
+            <a:r>
+              <a:rPr sz="1575" b="1">
+                <a:solidFill>
+                  <a:srgbClr val="1F2933"/>
+                </a:solidFill>
+              </a:rPr>
+              <a:t>p_cut = p_parent − Q R(0→cut)</a:t>
+            </a:r>
+          </a:p>
+        </p:txBody>
+      </p:sp>
+      <p:sp>
+        <p:nvSpPr>
+          <p:cNvPr id="22" name="">
+            <a:extLst xmlns:a="http://schemas.openxmlformats.org/drawingml/2006/main">
+              <a:ext uri="{FF2B5EF4-FFF2-40B4-BE49-F238E27FC236}">
+                <a16:creationId xmlns:a16="http://schemas.microsoft.com/office/drawing/2014/main" id="{E831933A-BB53-4B97-AFA7-33EC7D51C3D1}"/>
+              </a:ext>
+            </a:extLst>
+          </p:cNvPr>
+          <p:cNvSpPr>
+            <a:spLocks xmlns:a="http://schemas.openxmlformats.org/drawingml/2006/main" noGrp="1"/>
+          </p:cNvSpPr>
+          <p:nvPr/>
+        </p:nvSpPr>
+        <p:spPr>
+          <a:xfrm xmlns:a="http://schemas.openxmlformats.org/drawingml/2006/main">
+            <a:off x="6019800" y="3867150"/>
+            <a:ext cx="5143500" cy="295275"/>
+          </a:xfrm>
+          <a:prstGeom xmlns:a="http://schemas.openxmlformats.org/drawingml/2006/main" prst="rect">
+            <a:avLst/>
+          </a:prstGeom>
+          <a:noFill xmlns:a="http://schemas.openxmlformats.org/drawingml/2006/main"/>
+          <a:ln xmlns:a="http://schemas.openxmlformats.org/drawingml/2006/main" w="0">
+            <a:noFill/>
+            <a:prstDash val="solid"/>
+          </a:ln>
+        </p:spPr>
+        <p:txBody>
+          <a:bodyPr xmlns:a="http://schemas.openxmlformats.org/drawingml/2006/main"/>
+          <a:lstStyle xmlns:a="http://schemas.openxmlformats.org/drawingml/2006/main"/>
+          <a:p xmlns:a="http://schemas.openxmlformats.org/drawingml/2006/main">
+            <a:pPr algn="l">
+              <a:defRPr sz="1425" b="1">
+                <a:solidFill>
+                  <a:srgbClr val="1F2933"/>
+                </a:solidFill>
+              </a:defRPr>
+            </a:pPr>
+            <a:r>
+              <a:rPr sz="1425" b="1">
+                <a:solidFill>
+                  <a:srgbClr val="1F2933"/>
+                </a:solidFill>
+              </a:rPr>
+              <a:t>p_out,i^3D = p_cut,i − Q_i^1D R_i,extension</a:t>
+            </a:r>
+          </a:p>
+        </p:txBody>
+      </p:sp>
+      <p:sp>
+        <p:nvSpPr>
+          <p:cNvPr id="23" name="">
+            <a:extLst xmlns:a="http://schemas.openxmlformats.org/drawingml/2006/main">
+              <a:ext uri="{FF2B5EF4-FFF2-40B4-BE49-F238E27FC236}">
+                <a16:creationId xmlns:a16="http://schemas.microsoft.com/office/drawing/2014/main" id="{BBF052D8-8359-4580-A958-82919583BDD1}"/>
+              </a:ext>
+            </a:extLst>
+          </p:cNvPr>
+          <p:cNvSpPr>
+            <a:spLocks xmlns:a="http://schemas.openxmlformats.org/drawingml/2006/main" noGrp="1"/>
+          </p:cNvSpPr>
+          <p:nvPr/>
+        </p:nvSpPr>
+        <p:spPr>
+          <a:xfrm xmlns:a="http://schemas.openxmlformats.org/drawingml/2006/main">
+            <a:off x="6019800" y="4143375"/>
+            <a:ext cx="5219700" cy="266700"/>
+          </a:xfrm>
+          <a:prstGeom xmlns:a="http://schemas.openxmlformats.org/drawingml/2006/main" prst="rect">
+            <a:avLst/>
+          </a:prstGeom>
+          <a:noFill xmlns:a="http://schemas.openxmlformats.org/drawingml/2006/main"/>
+          <a:ln xmlns:a="http://schemas.openxmlformats.org/drawingml/2006/main" w="0">
+            <a:noFill/>
+            <a:prstDash val="solid"/>
+          </a:ln>
+        </p:spPr>
+        <p:txBody>
+          <a:bodyPr xmlns:a="http://schemas.openxmlformats.org/drawingml/2006/main"/>
+          <a:lstStyle xmlns:a="http://schemas.openxmlformats.org/drawingml/2006/main"/>
+          <a:p xmlns:a="http://schemas.openxmlformats.org/drawingml/2006/main">
+            <a:pPr algn="l">
+              <a:defRPr sz="1200" b="0">
+                <a:solidFill>
+                  <a:srgbClr val="66747E"/>
+                </a:solidFill>
+              </a:defRPr>
+            </a:pPr>
+            <a:r>
+              <a:rPr sz="1200" b="0">
+                <a:solidFill>
+                  <a:srgbClr val="66747E"/>
+                </a:solidFill>
+              </a:rPr>
+              <a:t>The second term removes the artificial extension pressure loss.</a:t>
+            </a:r>
+          </a:p>
+        </p:txBody>
+      </p:sp>
+      <p:sp>
+        <p:nvSpPr>
+          <p:cNvPr id="24" name="">
+            <a:extLst xmlns:a="http://schemas.openxmlformats.org/drawingml/2006/main">
+              <a:ext uri="{FF2B5EF4-FFF2-40B4-BE49-F238E27FC236}">
+                <a16:creationId xmlns:a16="http://schemas.microsoft.com/office/drawing/2014/main" id="{3200D68B-CD21-41ED-ABDF-458D17CD52E4}"/>
+              </a:ext>
+            </a:extLst>
+          </p:cNvPr>
+          <p:cNvSpPr>
+            <a:spLocks xmlns:a="http://schemas.openxmlformats.org/drawingml/2006/main" noGrp="1"/>
+          </p:cNvSpPr>
+          <p:nvPr/>
+        </p:nvSpPr>
+        <p:spPr>
+          <a:xfrm xmlns:a="http://schemas.openxmlformats.org/drawingml/2006/main">
+            <a:off x="6019800" y="4467225"/>
+            <a:ext cx="5372100" cy="0"/>
+          </a:xfrm>
+          <a:prstGeom xmlns:a="http://schemas.openxmlformats.org/drawingml/2006/main" prst="line">
+            <a:avLst/>
+          </a:prstGeom>
+          <a:noFill xmlns:a="http://schemas.openxmlformats.org/drawingml/2006/main"/>
+          <a:ln xmlns:a="http://schemas.openxmlformats.org/drawingml/2006/main" w="9525">
+            <a:solidFill>
+              <a:srgbClr val="CDD7DD"/>
+            </a:solidFill>
+            <a:prstDash val="solid"/>
+          </a:ln>
+        </p:spPr>
+      </p:sp>
+      <p:sp>
+        <p:nvSpPr>
+          <p:cNvPr id="25" name="">
+            <a:extLst xmlns:a="http://schemas.openxmlformats.org/drawingml/2006/main">
+              <a:ext uri="{FF2B5EF4-FFF2-40B4-BE49-F238E27FC236}">
+                <a16:creationId xmlns:a16="http://schemas.microsoft.com/office/drawing/2014/main" id="{5C2161BD-D715-4D06-B44C-06357BE19E8A}"/>
+              </a:ext>
+            </a:extLst>
+          </p:cNvPr>
+          <p:cNvSpPr>
+            <a:spLocks xmlns:a="http://schemas.openxmlformats.org/drawingml/2006/main" noGrp="1"/>
+          </p:cNvSpPr>
+          <p:nvPr/>
+        </p:nvSpPr>
+        <p:spPr>
+          <a:xfrm xmlns:a="http://schemas.openxmlformats.org/drawingml/2006/main">
+            <a:off x="6019800" y="4591050"/>
+            <a:ext cx="5219700" cy="266700"/>
+          </a:xfrm>
+          <a:prstGeom xmlns:a="http://schemas.openxmlformats.org/drawingml/2006/main" prst="rect">
+            <a:avLst/>
+          </a:prstGeom>
+          <a:noFill xmlns:a="http://schemas.openxmlformats.org/drawingml/2006/main"/>
+          <a:ln xmlns:a="http://schemas.openxmlformats.org/drawingml/2006/main" w="0">
+            <a:noFill/>
+            <a:prstDash val="solid"/>
+          </a:ln>
+        </p:spPr>
+        <p:txBody>
+          <a:bodyPr xmlns:a="http://schemas.openxmlformats.org/drawingml/2006/main"/>
+          <a:lstStyle xmlns:a="http://schemas.openxmlformats.org/drawingml/2006/main"/>
+          <a:p xmlns:a="http://schemas.openxmlformats.org/drawingml/2006/main">
+            <a:pPr algn="l">
+              <a:defRPr sz="1350" b="1">
+                <a:solidFill>
+                  <a:srgbClr val="009E73"/>
+                </a:solidFill>
+              </a:defRPr>
+            </a:pPr>
+            <a:r>
+              <a:rPr sz="1350" b="1">
+                <a:solidFill>
+                  <a:srgbClr val="009E73"/>
+                </a:solidFill>
+              </a:rPr>
+              <a:t>3 · Apply the final solver boundaries</a:t>
+            </a:r>
+          </a:p>
+        </p:txBody>
+      </p:sp>
+      <p:sp>
+        <p:nvSpPr>
+          <p:cNvPr id="26" name="">
+            <a:extLst xmlns:a="http://schemas.openxmlformats.org/drawingml/2006/main">
+              <a:ext uri="{FF2B5EF4-FFF2-40B4-BE49-F238E27FC236}">
+                <a16:creationId xmlns:a16="http://schemas.microsoft.com/office/drawing/2014/main" id="{9FDD80A8-5815-413F-B4A2-031E23A9D93A}"/>
+              </a:ext>
+            </a:extLst>
+          </p:cNvPr>
+          <p:cNvSpPr>
+            <a:spLocks xmlns:a="http://schemas.openxmlformats.org/drawingml/2006/main" noGrp="1"/>
+          </p:cNvSpPr>
+          <p:nvPr/>
+        </p:nvSpPr>
+        <p:spPr>
+          <a:xfrm xmlns:a="http://schemas.openxmlformats.org/drawingml/2006/main">
+            <a:off x="6019800" y="4933950"/>
+            <a:ext cx="685800" cy="228600"/>
+          </a:xfrm>
+          <a:prstGeom xmlns:a="http://schemas.openxmlformats.org/drawingml/2006/main" prst="rect">
+            <a:avLst/>
+          </a:prstGeom>
+          <a:noFill xmlns:a="http://schemas.openxmlformats.org/drawingml/2006/main"/>
+          <a:ln xmlns:a="http://schemas.openxmlformats.org/drawingml/2006/main" w="0">
+            <a:noFill/>
+            <a:prstDash val="solid"/>
+          </a:ln>
+        </p:spPr>
+        <p:txBody>
+          <a:bodyPr xmlns:a="http://schemas.openxmlformats.org/drawingml/2006/main"/>
+          <a:lstStyle xmlns:a="http://schemas.openxmlformats.org/drawingml/2006/main"/>
+          <a:p xmlns:a="http://schemas.openxmlformats.org/drawingml/2006/main">
+            <a:pPr algn="l">
+              <a:defRPr sz="975" b="1">
+                <a:solidFill>
+                  <a:srgbClr val="D55E00"/>
+                </a:solidFill>
+              </a:defRPr>
+            </a:pPr>
+            <a:r>
+              <a:rPr sz="975" b="1">
+                <a:solidFill>
+                  <a:srgbClr val="D55E00"/>
+                </a:solidFill>
+              </a:rPr>
+              <a:t>INLET</a:t>
+            </a:r>
+          </a:p>
+        </p:txBody>
+      </p:sp>
+      <p:sp>
+        <p:nvSpPr>
+          <p:cNvPr id="27" name="">
+            <a:extLst xmlns:a="http://schemas.openxmlformats.org/drawingml/2006/main">
+              <a:ext uri="{FF2B5EF4-FFF2-40B4-BE49-F238E27FC236}">
+                <a16:creationId xmlns:a16="http://schemas.microsoft.com/office/drawing/2014/main" id="{8433D5D2-7ABB-40FF-91A5-EEF5DCF4E636}"/>
+              </a:ext>
+            </a:extLst>
+          </p:cNvPr>
+          <p:cNvSpPr>
+            <a:spLocks xmlns:a="http://schemas.openxmlformats.org/drawingml/2006/main" noGrp="1"/>
+          </p:cNvSpPr>
+          <p:nvPr/>
+        </p:nvSpPr>
+        <p:spPr>
+          <a:xfrm xmlns:a="http://schemas.openxmlformats.org/drawingml/2006/main">
+            <a:off x="6743700" y="4905375"/>
+            <a:ext cx="4419600" cy="257175"/>
+          </a:xfrm>
+          <a:prstGeom xmlns:a="http://schemas.openxmlformats.org/drawingml/2006/main" prst="rect">
+            <a:avLst/>
+          </a:prstGeom>
+          <a:noFill xmlns:a="http://schemas.openxmlformats.org/drawingml/2006/main"/>
+          <a:ln xmlns:a="http://schemas.openxmlformats.org/drawingml/2006/main" w="0">
+            <a:noFill/>
+            <a:prstDash val="solid"/>
+          </a:ln>
+        </p:spPr>
+        <p:txBody>
+          <a:bodyPr xmlns:a="http://schemas.openxmlformats.org/drawingml/2006/main"/>
+          <a:lstStyle xmlns:a="http://schemas.openxmlformats.org/drawingml/2006/main"/>
+          <a:p xmlns:a="http://schemas.openxmlformats.org/drawingml/2006/main">
+            <a:pPr algn="l">
+              <a:defRPr sz="1275" b="1">
+                <a:solidFill>
+                  <a:srgbClr val="1F2933"/>
+                </a:solidFill>
+              </a:defRPr>
+            </a:pPr>
+            <a:r>
+              <a:rPr sz="1275" b="1">
+                <a:solidFill>
+                  <a:srgbClr val="1F2933"/>
+                </a:solidFill>
+              </a:rPr>
+              <a:t>Q_target = u_mean,healthy A_inlet = ∫_A u·n dA</a:t>
+            </a:r>
+          </a:p>
+        </p:txBody>
+      </p:sp>
+      <p:sp>
+        <p:nvSpPr>
+          <p:cNvPr id="28" name="">
+            <a:extLst xmlns:a="http://schemas.openxmlformats.org/drawingml/2006/main">
+              <a:ext uri="{FF2B5EF4-FFF2-40B4-BE49-F238E27FC236}">
+                <a16:creationId xmlns:a16="http://schemas.microsoft.com/office/drawing/2014/main" id="{B4E01D70-9677-499D-8E35-73204D8F4342}"/>
+              </a:ext>
+            </a:extLst>
+          </p:cNvPr>
+          <p:cNvSpPr>
+            <a:spLocks xmlns:a="http://schemas.openxmlformats.org/drawingml/2006/main" noGrp="1"/>
+          </p:cNvSpPr>
+          <p:nvPr/>
+        </p:nvSpPr>
+        <p:spPr>
+          <a:xfrm xmlns:a="http://schemas.openxmlformats.org/drawingml/2006/main">
+            <a:off x="6743700" y="5133975"/>
+            <a:ext cx="4476750" cy="228600"/>
+          </a:xfrm>
+          <a:prstGeom xmlns:a="http://schemas.openxmlformats.org/drawingml/2006/main" prst="rect">
+            <a:avLst/>
+          </a:prstGeom>
+          <a:noFill xmlns:a="http://schemas.openxmlformats.org/drawingml/2006/main"/>
+          <a:ln xmlns:a="http://schemas.openxmlformats.org/drawingml/2006/main" w="0">
+            <a:noFill/>
+            <a:prstDash val="solid"/>
+          </a:ln>
+        </p:spPr>
+        <p:txBody>
+          <a:bodyPr xmlns:a="http://schemas.openxmlformats.org/drawingml/2006/main"/>
+          <a:lstStyle xmlns:a="http://schemas.openxmlformats.org/drawingml/2006/main"/>
+          <a:p xmlns:a="http://schemas.openxmlformats.org/drawingml/2006/main">
+            <a:pPr algn="l">
+              <a:defRPr sz="1200" b="0">
+                <a:solidFill>
+                  <a:srgbClr val="66747E"/>
+                </a:solidFill>
+              </a:defRPr>
+            </a:pPr>
+            <a:r>
+              <a:rPr sz="1200" b="0">
+                <a:solidFill>
+                  <a:srgbClr val="66747E"/>
+                </a:solidFill>
+              </a:rPr>
+              <a:t>adaptive_flux_pressure adjusts inlet pressure to match Q_target</a:t>
+            </a:r>
+          </a:p>
+        </p:txBody>
+      </p:sp>
+      <p:sp>
+        <p:nvSpPr>
+          <p:cNvPr id="29" name="">
+            <a:extLst xmlns:a="http://schemas.openxmlformats.org/drawingml/2006/main">
+              <a:ext uri="{FF2B5EF4-FFF2-40B4-BE49-F238E27FC236}">
+                <a16:creationId xmlns:a16="http://schemas.microsoft.com/office/drawing/2014/main" id="{08E5A3AD-FB9D-4AD4-83F2-FDCEF246FE56}"/>
+              </a:ext>
+            </a:extLst>
+          </p:cNvPr>
+          <p:cNvSpPr>
+            <a:spLocks xmlns:a="http://schemas.openxmlformats.org/drawingml/2006/main" noGrp="1"/>
+          </p:cNvSpPr>
+          <p:nvPr/>
+        </p:nvSpPr>
+        <p:spPr>
+          <a:xfrm xmlns:a="http://schemas.openxmlformats.org/drawingml/2006/main">
+            <a:off x="6019800" y="5429250"/>
+            <a:ext cx="685800" cy="228600"/>
+          </a:xfrm>
+          <a:prstGeom xmlns:a="http://schemas.openxmlformats.org/drawingml/2006/main" prst="rect">
+            <a:avLst/>
+          </a:prstGeom>
+          <a:noFill xmlns:a="http://schemas.openxmlformats.org/drawingml/2006/main"/>
+          <a:ln xmlns:a="http://schemas.openxmlformats.org/drawingml/2006/main" w="0">
+            <a:noFill/>
+            <a:prstDash val="solid"/>
+          </a:ln>
+        </p:spPr>
+        <p:txBody>
+          <a:bodyPr xmlns:a="http://schemas.openxmlformats.org/drawingml/2006/main"/>
+          <a:lstStyle xmlns:a="http://schemas.openxmlformats.org/drawingml/2006/main"/>
+          <a:p xmlns:a="http://schemas.openxmlformats.org/drawingml/2006/main">
+            <a:pPr algn="l">
+              <a:defRPr sz="975" b="1">
+                <a:solidFill>
+                  <a:srgbClr val="0072B2"/>
+                </a:solidFill>
+              </a:defRPr>
+            </a:pPr>
+            <a:r>
+              <a:rPr sz="975" b="1">
+                <a:solidFill>
+                  <a:srgbClr val="0072B2"/>
+                </a:solidFill>
+              </a:rPr>
+              <a:t>OUTLETS</a:t>
+            </a:r>
+          </a:p>
+        </p:txBody>
+      </p:sp>
+      <p:sp>
+        <p:nvSpPr>
+          <p:cNvPr id="30" name="">
+            <a:extLst xmlns:a="http://schemas.openxmlformats.org/drawingml/2006/main">
+              <a:ext uri="{FF2B5EF4-FFF2-40B4-BE49-F238E27FC236}">
+                <a16:creationId xmlns:a16="http://schemas.microsoft.com/office/drawing/2014/main" id="{B79C7A35-EC54-4138-8E72-E1AC9621B7AC}"/>
+              </a:ext>
+            </a:extLst>
+          </p:cNvPr>
+          <p:cNvSpPr>
+            <a:spLocks xmlns:a="http://schemas.openxmlformats.org/drawingml/2006/main" noGrp="1"/>
+          </p:cNvSpPr>
+          <p:nvPr/>
+        </p:nvSpPr>
+        <p:spPr>
+          <a:xfrm xmlns:a="http://schemas.openxmlformats.org/drawingml/2006/main">
+            <a:off x="6743700" y="5400675"/>
+            <a:ext cx="3676650" cy="257175"/>
+          </a:xfrm>
+          <a:prstGeom xmlns:a="http://schemas.openxmlformats.org/drawingml/2006/main" prst="rect">
+            <a:avLst/>
+          </a:prstGeom>
+          <a:noFill xmlns:a="http://schemas.openxmlformats.org/drawingml/2006/main"/>
+          <a:ln xmlns:a="http://schemas.openxmlformats.org/drawingml/2006/main" w="0">
+            <a:noFill/>
+            <a:prstDash val="solid"/>
+          </a:ln>
+        </p:spPr>
+        <p:txBody>
+          <a:bodyPr xmlns:a="http://schemas.openxmlformats.org/drawingml/2006/main"/>
+          <a:lstStyle xmlns:a="http://schemas.openxmlformats.org/drawingml/2006/main"/>
+          <a:p xmlns:a="http://schemas.openxmlformats.org/drawingml/2006/main">
+            <a:pPr algn="l">
+              <a:defRPr sz="1275" b="1">
+                <a:solidFill>
+                  <a:srgbClr val="1F2933"/>
+                </a:solidFill>
+              </a:defRPr>
+            </a:pPr>
+            <a:r>
+              <a:rPr sz="1275" b="1">
+                <a:solidFill>
+                  <a:srgbClr val="1F2933"/>
+                </a:solidFill>
+              </a:rPr>
+              <a:t>pressure_eq: p_gauge,i = p_out,i^3D</a:t>
+            </a:r>
+          </a:p>
+        </p:txBody>
+      </p:sp>
+      <p:sp>
+        <p:nvSpPr>
+          <p:cNvPr id="31" name="">
+            <a:extLst xmlns:a="http://schemas.openxmlformats.org/drawingml/2006/main">
+              <a:ext uri="{FF2B5EF4-FFF2-40B4-BE49-F238E27FC236}">
+                <a16:creationId xmlns:a16="http://schemas.microsoft.com/office/drawing/2014/main" id="{BEC8ED93-841E-47F6-BEC2-1EE4AD0E6541}"/>
+              </a:ext>
+            </a:extLst>
+          </p:cNvPr>
+          <p:cNvSpPr>
+            <a:spLocks xmlns:a="http://schemas.openxmlformats.org/drawingml/2006/main" noGrp="1"/>
+          </p:cNvSpPr>
+          <p:nvPr/>
+        </p:nvSpPr>
+        <p:spPr>
+          <a:xfrm xmlns:a="http://schemas.openxmlformats.org/drawingml/2006/main">
+            <a:off x="6019800" y="5695950"/>
+            <a:ext cx="685800" cy="228600"/>
+          </a:xfrm>
+          <a:prstGeom xmlns:a="http://schemas.openxmlformats.org/drawingml/2006/main" prst="rect">
+            <a:avLst/>
+          </a:prstGeom>
+          <a:noFill xmlns:a="http://schemas.openxmlformats.org/drawingml/2006/main"/>
+          <a:ln xmlns:a="http://schemas.openxmlformats.org/drawingml/2006/main" w="0">
+            <a:noFill/>
+            <a:prstDash val="solid"/>
+          </a:ln>
+        </p:spPr>
+        <p:txBody>
+          <a:bodyPr xmlns:a="http://schemas.openxmlformats.org/drawingml/2006/main"/>
+          <a:lstStyle xmlns:a="http://schemas.openxmlformats.org/drawingml/2006/main"/>
+          <a:p xmlns:a="http://schemas.openxmlformats.org/drawingml/2006/main">
+            <a:pPr algn="l">
+              <a:defRPr sz="975" b="1">
+                <a:solidFill>
+                  <a:srgbClr val="163A5F"/>
+                </a:solidFill>
+              </a:defRPr>
+            </a:pPr>
+            <a:r>
+              <a:rPr sz="975" b="1">
+                <a:solidFill>
+                  <a:srgbClr val="163A5F"/>
+                </a:solidFill>
+              </a:rPr>
+              <a:t>WALL</a:t>
+            </a:r>
+          </a:p>
+        </p:txBody>
+      </p:sp>
+      <p:sp>
+        <p:nvSpPr>
+          <p:cNvPr id="32" name="">
+            <a:extLst xmlns:a="http://schemas.openxmlformats.org/drawingml/2006/main">
+              <a:ext uri="{FF2B5EF4-FFF2-40B4-BE49-F238E27FC236}">
+                <a16:creationId xmlns:a16="http://schemas.microsoft.com/office/drawing/2014/main" id="{186CA23F-7114-429A-B42D-480F236CA20E}"/>
+              </a:ext>
+            </a:extLst>
+          </p:cNvPr>
+          <p:cNvSpPr>
+            <a:spLocks xmlns:a="http://schemas.openxmlformats.org/drawingml/2006/main" noGrp="1"/>
+          </p:cNvSpPr>
+          <p:nvPr/>
+        </p:nvSpPr>
+        <p:spPr>
+          <a:xfrm xmlns:a="http://schemas.openxmlformats.org/drawingml/2006/main">
+            <a:off x="6743700" y="5667375"/>
+            <a:ext cx="2381250" cy="257175"/>
+          </a:xfrm>
+          <a:prstGeom xmlns:a="http://schemas.openxmlformats.org/drawingml/2006/main" prst="rect">
+            <a:avLst/>
+          </a:prstGeom>
+          <a:noFill xmlns:a="http://schemas.openxmlformats.org/drawingml/2006/main"/>
+          <a:ln xmlns:a="http://schemas.openxmlformats.org/drawingml/2006/main" w="0">
+            <a:noFill/>
+            <a:prstDash val="solid"/>
+          </a:ln>
+        </p:spPr>
+        <p:txBody>
+          <a:bodyPr xmlns:a="http://schemas.openxmlformats.org/drawingml/2006/main"/>
+          <a:lstStyle xmlns:a="http://schemas.openxmlformats.org/drawingml/2006/main"/>
+          <a:p xmlns:a="http://schemas.openxmlformats.org/drawingml/2006/main">
+            <a:pPr algn="l">
+              <a:defRPr sz="1275" b="1">
+                <a:solidFill>
+                  <a:srgbClr val="1F2933"/>
+                </a:solidFill>
+              </a:defRPr>
+            </a:pPr>
+            <a:r>
+              <a:rPr sz="1275" b="1">
+                <a:solidFill>
+                  <a:srgbClr val="1F2933"/>
+                </a:solidFill>
+              </a:rPr>
+              <a:t>wall_libb: u_wall = 0</a:t>
             </a:r>
           </a:p>
         </p:txBody>
@@ -4338,7 +4890,7 @@
     </p:spTree>
     <p:extLst>
       <p:ext uri="{BB962C8B-B14F-4D97-AF65-F5344CB8AC3E}">
-        <p14:creationId xmlns:p14="http://schemas.microsoft.com/office/powerpoint/2010/main" val="1876847894"/>
+        <p14:creationId xmlns:p14="http://schemas.microsoft.com/office/powerpoint/2010/main" val="84832028"/>
       </p:ext>
     </p:extLst>
   </p:cSld>
@@ -4369,7 +4921,7 @@
           <p:cNvPr id="26" name="">
             <a:extLst xmlns:a="http://schemas.openxmlformats.org/drawingml/2006/main">
               <a:ext uri="{FF2B5EF4-FFF2-40B4-BE49-F238E27FC236}">
-                <a16:creationId xmlns:a16="http://schemas.microsoft.com/office/drawing/2014/main" id="{8131896C-C88C-4CFA-9B6E-4D09A284E71E}"/>
+                <a16:creationId xmlns:a16="http://schemas.microsoft.com/office/drawing/2014/main" id="{D1E434CF-E81F-4281-A9E1-773C804139A7}"/>
               </a:ext>
             </a:extLst>
           </p:cNvPr>
@@ -4419,7 +4971,7 @@
           <p:cNvPr id="2" name="">
             <a:extLst xmlns:a="http://schemas.openxmlformats.org/drawingml/2006/main">
               <a:ext uri="{FF2B5EF4-FFF2-40B4-BE49-F238E27FC236}">
-                <a16:creationId xmlns:a16="http://schemas.microsoft.com/office/drawing/2014/main" id="{76818A88-F0F4-4D20-80C1-14AC7E2F221B}"/>
+                <a16:creationId xmlns:a16="http://schemas.microsoft.com/office/drawing/2014/main" id="{2B9EFDE6-8106-4176-B447-39E37EF19D53}"/>
               </a:ext>
             </a:extLst>
           </p:cNvPr>
@@ -4469,7 +5021,7 @@
           <p:cNvPr id="3" name="">
             <a:extLst xmlns:a="http://schemas.openxmlformats.org/drawingml/2006/main">
               <a:ext uri="{FF2B5EF4-FFF2-40B4-BE49-F238E27FC236}">
-                <a16:creationId xmlns:a16="http://schemas.microsoft.com/office/drawing/2014/main" id="{72C5EFC0-FEFB-4737-B38B-8067071C192D}"/>
+                <a16:creationId xmlns:a16="http://schemas.microsoft.com/office/drawing/2014/main" id="{C9E6780E-D153-4C7F-86CA-CED13A3B3E62}"/>
               </a:ext>
             </a:extLst>
           </p:cNvPr>
@@ -4500,7 +5052,7 @@
           <p:cNvPr id="4" name="">
             <a:extLst xmlns:a="http://schemas.openxmlformats.org/drawingml/2006/main">
               <a:ext uri="{FF2B5EF4-FFF2-40B4-BE49-F238E27FC236}">
-                <a16:creationId xmlns:a16="http://schemas.microsoft.com/office/drawing/2014/main" id="{63CFD99D-BC59-4497-A8DB-8D4F7E98C5EE}"/>
+                <a16:creationId xmlns:a16="http://schemas.microsoft.com/office/drawing/2014/main" id="{7DD8E819-BE36-418D-96A5-557A8EDBE266}"/>
               </a:ext>
             </a:extLst>
           </p:cNvPr>
@@ -4531,7 +5083,7 @@
           <p:cNvPr id="5" name="">
             <a:extLst xmlns:a="http://schemas.openxmlformats.org/drawingml/2006/main">
               <a:ext uri="{FF2B5EF4-FFF2-40B4-BE49-F238E27FC236}">
-                <a16:creationId xmlns:a16="http://schemas.microsoft.com/office/drawing/2014/main" id="{915B1D23-EA36-487B-A195-783224177159}"/>
+                <a16:creationId xmlns:a16="http://schemas.microsoft.com/office/drawing/2014/main" id="{D56A2D76-08E7-4FEA-8707-9D64D0525F31}"/>
               </a:ext>
             </a:extLst>
           </p:cNvPr>
@@ -4581,7 +5133,7 @@
           <p:cNvPr id="6" name="">
             <a:extLst xmlns:a="http://schemas.openxmlformats.org/drawingml/2006/main">
               <a:ext uri="{FF2B5EF4-FFF2-40B4-BE49-F238E27FC236}">
-                <a16:creationId xmlns:a16="http://schemas.microsoft.com/office/drawing/2014/main" id="{19BFB201-A6AA-4A20-8AB6-2A9EF722D535}"/>
+                <a16:creationId xmlns:a16="http://schemas.microsoft.com/office/drawing/2014/main" id="{9CBBEF7D-DF52-4452-AF77-83DED3D9921A}"/>
               </a:ext>
             </a:extLst>
           </p:cNvPr>
@@ -4620,7 +5172,7 @@
           <p:nvPr/>
         </p:nvPicPr>
         <p:blipFill>
-          <a:blip xmlns:r="http://schemas.openxmlformats.org/officeDocument/2006/relationships" xmlns:a="http://schemas.openxmlformats.org/drawingml/2006/main" r:embed="R49bbc0856922478d"/>
+          <a:blip xmlns:r="http://schemas.openxmlformats.org/officeDocument/2006/relationships" xmlns:a="http://schemas.openxmlformats.org/drawingml/2006/main" r:embed="Ra758dfdc999c4d08"/>
           <a:stretch xmlns:a="http://schemas.openxmlformats.org/drawingml/2006/main"/>
         </p:blipFill>
         <p:spPr>
@@ -4638,7 +5190,7 @@
           <p:cNvPr id="8" name="">
             <a:extLst xmlns:a="http://schemas.openxmlformats.org/drawingml/2006/main">
               <a:ext uri="{FF2B5EF4-FFF2-40B4-BE49-F238E27FC236}">
-                <a16:creationId xmlns:a16="http://schemas.microsoft.com/office/drawing/2014/main" id="{F3501AC4-9978-435B-8A34-A7CDC0B7F1DC}"/>
+                <a16:creationId xmlns:a16="http://schemas.microsoft.com/office/drawing/2014/main" id="{F6538AF6-3A9E-43E1-B3AB-F5DFD936D2E0}"/>
               </a:ext>
             </a:extLst>
           </p:cNvPr>
@@ -4688,7 +5240,7 @@
           <p:cNvPr id="9" name="">
             <a:extLst xmlns:a="http://schemas.openxmlformats.org/drawingml/2006/main">
               <a:ext uri="{FF2B5EF4-FFF2-40B4-BE49-F238E27FC236}">
-                <a16:creationId xmlns:a16="http://schemas.microsoft.com/office/drawing/2014/main" id="{D9548D9D-76CD-4783-A53E-34B93BEB196B}"/>
+                <a16:creationId xmlns:a16="http://schemas.microsoft.com/office/drawing/2014/main" id="{8F697437-FFA1-4A15-A9A6-0BBAD4EF5105}"/>
               </a:ext>
             </a:extLst>
           </p:cNvPr>
@@ -4738,7 +5290,7 @@
           <p:cNvPr id="10" name="">
             <a:extLst xmlns:a="http://schemas.openxmlformats.org/drawingml/2006/main">
               <a:ext uri="{FF2B5EF4-FFF2-40B4-BE49-F238E27FC236}">
-                <a16:creationId xmlns:a16="http://schemas.microsoft.com/office/drawing/2014/main" id="{258D1324-F93A-4C10-9C4F-F8EC350013DD}"/>
+                <a16:creationId xmlns:a16="http://schemas.microsoft.com/office/drawing/2014/main" id="{1070539E-2D4E-4131-A409-F472F0EE9D29}"/>
               </a:ext>
             </a:extLst>
           </p:cNvPr>
@@ -4769,7 +5321,7 @@
           <p:cNvPr id="11" name="">
             <a:extLst xmlns:a="http://schemas.openxmlformats.org/drawingml/2006/main">
               <a:ext uri="{FF2B5EF4-FFF2-40B4-BE49-F238E27FC236}">
-                <a16:creationId xmlns:a16="http://schemas.microsoft.com/office/drawing/2014/main" id="{C8543CA0-1662-42EE-A543-18CC3CD49510}"/>
+                <a16:creationId xmlns:a16="http://schemas.microsoft.com/office/drawing/2014/main" id="{E4323E7D-D0B6-415B-9E77-694DAFF26278}"/>
               </a:ext>
             </a:extLst>
           </p:cNvPr>
@@ -4804,7 +5356,7 @@
           <p:cNvPr id="12" name="">
             <a:extLst xmlns:a="http://schemas.openxmlformats.org/drawingml/2006/main">
               <a:ext uri="{FF2B5EF4-FFF2-40B4-BE49-F238E27FC236}">
-                <a16:creationId xmlns:a16="http://schemas.microsoft.com/office/drawing/2014/main" id="{415A99B4-3CF8-440D-9066-3598B5935C95}"/>
+                <a16:creationId xmlns:a16="http://schemas.microsoft.com/office/drawing/2014/main" id="{C1553316-6788-4A68-9363-3A14FDE2AAC8}"/>
               </a:ext>
             </a:extLst>
           </p:cNvPr>
@@ -4854,7 +5406,7 @@
           <p:cNvPr id="13" name="">
             <a:extLst xmlns:a="http://schemas.openxmlformats.org/drawingml/2006/main">
               <a:ext uri="{FF2B5EF4-FFF2-40B4-BE49-F238E27FC236}">
-                <a16:creationId xmlns:a16="http://schemas.microsoft.com/office/drawing/2014/main" id="{51D34589-9F98-4265-8303-EC6F14743C4F}"/>
+                <a16:creationId xmlns:a16="http://schemas.microsoft.com/office/drawing/2014/main" id="{4B00AFE5-4E20-4FC6-9649-612DFB9ED74F}"/>
               </a:ext>
             </a:extLst>
           </p:cNvPr>
@@ -4904,7 +5456,7 @@
           <p:cNvPr id="14" name="">
             <a:extLst xmlns:a="http://schemas.openxmlformats.org/drawingml/2006/main">
               <a:ext uri="{FF2B5EF4-FFF2-40B4-BE49-F238E27FC236}">
-                <a16:creationId xmlns:a16="http://schemas.microsoft.com/office/drawing/2014/main" id="{2FB0CF68-99FA-4397-831B-76EC3192D0D0}"/>
+                <a16:creationId xmlns:a16="http://schemas.microsoft.com/office/drawing/2014/main" id="{B0D676FB-FD5B-43D6-98FB-2F99BE660FDF}"/>
               </a:ext>
             </a:extLst>
           </p:cNvPr>
@@ -4954,7 +5506,7 @@
           <p:cNvPr id="15" name="">
             <a:extLst xmlns:a="http://schemas.openxmlformats.org/drawingml/2006/main">
               <a:ext uri="{FF2B5EF4-FFF2-40B4-BE49-F238E27FC236}">
-                <a16:creationId xmlns:a16="http://schemas.microsoft.com/office/drawing/2014/main" id="{D9CFA60D-70E5-4EAB-8155-7A4F2E234566}"/>
+                <a16:creationId xmlns:a16="http://schemas.microsoft.com/office/drawing/2014/main" id="{45F25584-BE7B-4924-B15A-CC21B7A634C5}"/>
               </a:ext>
             </a:extLst>
           </p:cNvPr>
@@ -5004,7 +5556,7 @@
           <p:cNvPr id="16" name="">
             <a:extLst xmlns:a="http://schemas.openxmlformats.org/drawingml/2006/main">
               <a:ext uri="{FF2B5EF4-FFF2-40B4-BE49-F238E27FC236}">
-                <a16:creationId xmlns:a16="http://schemas.microsoft.com/office/drawing/2014/main" id="{6D495C91-92DD-4C9B-BCAB-741059499168}"/>
+                <a16:creationId xmlns:a16="http://schemas.microsoft.com/office/drawing/2014/main" id="{382A2589-C8F6-405F-AF9B-36E731EA802E}"/>
               </a:ext>
             </a:extLst>
           </p:cNvPr>
@@ -5054,7 +5606,7 @@
           <p:cNvPr id="17" name="">
             <a:extLst xmlns:a="http://schemas.openxmlformats.org/drawingml/2006/main">
               <a:ext uri="{FF2B5EF4-FFF2-40B4-BE49-F238E27FC236}">
-                <a16:creationId xmlns:a16="http://schemas.microsoft.com/office/drawing/2014/main" id="{0DEF16A9-FA52-472E-9357-044CE0A90732}"/>
+                <a16:creationId xmlns:a16="http://schemas.microsoft.com/office/drawing/2014/main" id="{B015D3A2-1BAA-4D43-A3A7-BBD746E52E17}"/>
               </a:ext>
             </a:extLst>
           </p:cNvPr>
@@ -5104,7 +5656,7 @@
           <p:cNvPr id="18" name="">
             <a:extLst xmlns:a="http://schemas.openxmlformats.org/drawingml/2006/main">
               <a:ext uri="{FF2B5EF4-FFF2-40B4-BE49-F238E27FC236}">
-                <a16:creationId xmlns:a16="http://schemas.microsoft.com/office/drawing/2014/main" id="{8CB94378-6DC4-4E9B-974B-6A058DD2F7FD}"/>
+                <a16:creationId xmlns:a16="http://schemas.microsoft.com/office/drawing/2014/main" id="{3FA8F0F5-5DC8-45A6-A836-063704A06298}"/>
               </a:ext>
             </a:extLst>
           </p:cNvPr>
@@ -5135,7 +5687,7 @@
           <p:cNvPr id="19" name="">
             <a:extLst xmlns:a="http://schemas.openxmlformats.org/drawingml/2006/main">
               <a:ext uri="{FF2B5EF4-FFF2-40B4-BE49-F238E27FC236}">
-                <a16:creationId xmlns:a16="http://schemas.microsoft.com/office/drawing/2014/main" id="{3AC8AEB5-91A4-467C-A8D6-22F4FFF70767}"/>
+                <a16:creationId xmlns:a16="http://schemas.microsoft.com/office/drawing/2014/main" id="{F57DE11C-99FE-4043-B404-0711CE6E446F}"/>
               </a:ext>
             </a:extLst>
           </p:cNvPr>
@@ -5185,7 +5737,7 @@
           <p:cNvPr id="20" name="">
             <a:extLst xmlns:a="http://schemas.openxmlformats.org/drawingml/2006/main">
               <a:ext uri="{FF2B5EF4-FFF2-40B4-BE49-F238E27FC236}">
-                <a16:creationId xmlns:a16="http://schemas.microsoft.com/office/drawing/2014/main" id="{D7225FE8-5D79-4D8D-9736-45EAD692E743}"/>
+                <a16:creationId xmlns:a16="http://schemas.microsoft.com/office/drawing/2014/main" id="{39DE9AED-2287-43D5-81BB-078E1E14782C}"/>
               </a:ext>
             </a:extLst>
           </p:cNvPr>
@@ -5216,7 +5768,7 @@
           <p:cNvPr id="21" name="">
             <a:extLst xmlns:a="http://schemas.openxmlformats.org/drawingml/2006/main">
               <a:ext uri="{FF2B5EF4-FFF2-40B4-BE49-F238E27FC236}">
-                <a16:creationId xmlns:a16="http://schemas.microsoft.com/office/drawing/2014/main" id="{D069ED80-B60F-41CF-82EF-0194B6DC0B08}"/>
+                <a16:creationId xmlns:a16="http://schemas.microsoft.com/office/drawing/2014/main" id="{D96F14F2-A3B0-47DD-B0A5-A578C659D61D}"/>
               </a:ext>
             </a:extLst>
           </p:cNvPr>
@@ -5266,7 +5818,7 @@
           <p:cNvPr id="22" name="">
             <a:extLst xmlns:a="http://schemas.openxmlformats.org/drawingml/2006/main">
               <a:ext uri="{FF2B5EF4-FFF2-40B4-BE49-F238E27FC236}">
-                <a16:creationId xmlns:a16="http://schemas.microsoft.com/office/drawing/2014/main" id="{5D760E3E-EFD5-480F-B43B-EA723C216950}"/>
+                <a16:creationId xmlns:a16="http://schemas.microsoft.com/office/drawing/2014/main" id="{00AFF916-66B9-42B1-B52D-6BC9E7BD111A}"/>
               </a:ext>
             </a:extLst>
           </p:cNvPr>
@@ -5297,7 +5849,7 @@
           <p:cNvPr id="23" name="">
             <a:extLst xmlns:a="http://schemas.openxmlformats.org/drawingml/2006/main">
               <a:ext uri="{FF2B5EF4-FFF2-40B4-BE49-F238E27FC236}">
-                <a16:creationId xmlns:a16="http://schemas.microsoft.com/office/drawing/2014/main" id="{F7AEB7D7-B1A7-4FEF-B8D6-97C2B8D4EE80}"/>
+                <a16:creationId xmlns:a16="http://schemas.microsoft.com/office/drawing/2014/main" id="{3EC14F50-3848-4ECE-A280-059C9665A4A3}"/>
               </a:ext>
             </a:extLst>
           </p:cNvPr>
@@ -5347,7 +5899,7 @@
           <p:cNvPr id="24" name="">
             <a:extLst xmlns:a="http://schemas.openxmlformats.org/drawingml/2006/main">
               <a:ext uri="{FF2B5EF4-FFF2-40B4-BE49-F238E27FC236}">
-                <a16:creationId xmlns:a16="http://schemas.microsoft.com/office/drawing/2014/main" id="{B4A0A725-4829-40BF-BC5B-FAB1095EBFFD}"/>
+                <a16:creationId xmlns:a16="http://schemas.microsoft.com/office/drawing/2014/main" id="{26753557-5265-4217-8B4F-713539BD9D1C}"/>
               </a:ext>
             </a:extLst>
           </p:cNvPr>
@@ -5378,7 +5930,7 @@
           <p:cNvPr id="25" name="">
             <a:extLst xmlns:a="http://schemas.openxmlformats.org/drawingml/2006/main">
               <a:ext uri="{FF2B5EF4-FFF2-40B4-BE49-F238E27FC236}">
-                <a16:creationId xmlns:a16="http://schemas.microsoft.com/office/drawing/2014/main" id="{BC407AAE-351C-4AA8-B628-4CE723599C94}"/>
+                <a16:creationId xmlns:a16="http://schemas.microsoft.com/office/drawing/2014/main" id="{ED6ED8B6-8C04-4B23-8AC4-CC32D5E4D574}"/>
               </a:ext>
             </a:extLst>
           </p:cNvPr>
@@ -5426,7 +5978,7 @@
     </p:spTree>
     <p:extLst>
       <p:ext uri="{BB962C8B-B14F-4D97-AF65-F5344CB8AC3E}">
-        <p14:creationId xmlns:p14="http://schemas.microsoft.com/office/powerpoint/2010/main" val="500397123"/>
+        <p14:creationId xmlns:p14="http://schemas.microsoft.com/office/powerpoint/2010/main" val="1168348269"/>
       </p:ext>
     </p:extLst>
   </p:cSld>
@@ -5457,7 +6009,7 @@
           <p:cNvPr id="40" name="">
             <a:extLst xmlns:a="http://schemas.openxmlformats.org/drawingml/2006/main">
               <a:ext uri="{FF2B5EF4-FFF2-40B4-BE49-F238E27FC236}">
-                <a16:creationId xmlns:a16="http://schemas.microsoft.com/office/drawing/2014/main" id="{F93300CF-8ACE-40B7-89EA-6C9B71EF9541}"/>
+                <a16:creationId xmlns:a16="http://schemas.microsoft.com/office/drawing/2014/main" id="{FF0C7F45-6FE3-426B-8F57-31A606129648}"/>
               </a:ext>
             </a:extLst>
           </p:cNvPr>
@@ -5507,7 +6059,7 @@
           <p:cNvPr id="2" name="">
             <a:extLst xmlns:a="http://schemas.openxmlformats.org/drawingml/2006/main">
               <a:ext uri="{FF2B5EF4-FFF2-40B4-BE49-F238E27FC236}">
-                <a16:creationId xmlns:a16="http://schemas.microsoft.com/office/drawing/2014/main" id="{0F3B9D12-522B-42B3-9165-3A3A0F7E8C2C}"/>
+                <a16:creationId xmlns:a16="http://schemas.microsoft.com/office/drawing/2014/main" id="{9241DB89-8422-4833-AB35-A076E3F9886E}"/>
               </a:ext>
             </a:extLst>
           </p:cNvPr>
@@ -5557,7 +6109,7 @@
           <p:cNvPr id="3" name="">
             <a:extLst xmlns:a="http://schemas.openxmlformats.org/drawingml/2006/main">
               <a:ext uri="{FF2B5EF4-FFF2-40B4-BE49-F238E27FC236}">
-                <a16:creationId xmlns:a16="http://schemas.microsoft.com/office/drawing/2014/main" id="{CE005F26-3EA4-49ED-A7CD-47E356C7D4FD}"/>
+                <a16:creationId xmlns:a16="http://schemas.microsoft.com/office/drawing/2014/main" id="{32B869B7-B3BB-4840-97B4-3F554B470555}"/>
               </a:ext>
             </a:extLst>
           </p:cNvPr>
@@ -5588,7 +6140,7 @@
           <p:cNvPr id="4" name="">
             <a:extLst xmlns:a="http://schemas.openxmlformats.org/drawingml/2006/main">
               <a:ext uri="{FF2B5EF4-FFF2-40B4-BE49-F238E27FC236}">
-                <a16:creationId xmlns:a16="http://schemas.microsoft.com/office/drawing/2014/main" id="{C6CB0869-CBA7-45D7-A233-E5FF708D894E}"/>
+                <a16:creationId xmlns:a16="http://schemas.microsoft.com/office/drawing/2014/main" id="{18D501C6-D7CC-4E1A-B9CF-197F9D066F42}"/>
               </a:ext>
             </a:extLst>
           </p:cNvPr>
@@ -5619,7 +6171,7 @@
           <p:cNvPr id="5" name="">
             <a:extLst xmlns:a="http://schemas.openxmlformats.org/drawingml/2006/main">
               <a:ext uri="{FF2B5EF4-FFF2-40B4-BE49-F238E27FC236}">
-                <a16:creationId xmlns:a16="http://schemas.microsoft.com/office/drawing/2014/main" id="{5C42ABAA-413A-480F-8A7C-EC063DAE2EA6}"/>
+                <a16:creationId xmlns:a16="http://schemas.microsoft.com/office/drawing/2014/main" id="{DE219B31-34A8-4AA0-8301-E3F652A3F757}"/>
               </a:ext>
             </a:extLst>
           </p:cNvPr>
@@ -5669,7 +6221,7 @@
           <p:cNvPr id="6" name="">
             <a:extLst xmlns:a="http://schemas.openxmlformats.org/drawingml/2006/main">
               <a:ext uri="{FF2B5EF4-FFF2-40B4-BE49-F238E27FC236}">
-                <a16:creationId xmlns:a16="http://schemas.microsoft.com/office/drawing/2014/main" id="{2AB73222-A2BF-4CFB-B339-8B731FD34E81}"/>
+                <a16:creationId xmlns:a16="http://schemas.microsoft.com/office/drawing/2014/main" id="{3D6AA0C0-A24D-4668-AE76-F082F2CD0956}"/>
               </a:ext>
             </a:extLst>
           </p:cNvPr>
@@ -5719,7 +6271,7 @@
           <p:cNvPr id="7" name="">
             <a:extLst xmlns:a="http://schemas.openxmlformats.org/drawingml/2006/main">
               <a:ext uri="{FF2B5EF4-FFF2-40B4-BE49-F238E27FC236}">
-                <a16:creationId xmlns:a16="http://schemas.microsoft.com/office/drawing/2014/main" id="{E0127767-7115-41A6-997F-71EF705EAD87}"/>
+                <a16:creationId xmlns:a16="http://schemas.microsoft.com/office/drawing/2014/main" id="{7E4805E7-0552-41D1-B1DB-64ACA05FED54}"/>
               </a:ext>
             </a:extLst>
           </p:cNvPr>
@@ -5754,7 +6306,7 @@
           <p:cNvPr id="8" name="">
             <a:extLst xmlns:a="http://schemas.openxmlformats.org/drawingml/2006/main">
               <a:ext uri="{FF2B5EF4-FFF2-40B4-BE49-F238E27FC236}">
-                <a16:creationId xmlns:a16="http://schemas.microsoft.com/office/drawing/2014/main" id="{02B5E306-4974-4027-991E-360166FD3558}"/>
+                <a16:creationId xmlns:a16="http://schemas.microsoft.com/office/drawing/2014/main" id="{25C64C4B-C5B3-459C-B522-F0BE9383A1B2}"/>
               </a:ext>
             </a:extLst>
           </p:cNvPr>
@@ -5785,7 +6337,7 @@
           <p:cNvPr id="9" name="">
             <a:extLst xmlns:a="http://schemas.openxmlformats.org/drawingml/2006/main">
               <a:ext uri="{FF2B5EF4-FFF2-40B4-BE49-F238E27FC236}">
-                <a16:creationId xmlns:a16="http://schemas.microsoft.com/office/drawing/2014/main" id="{9F4A1EFF-320F-4C02-A450-603719CBE0EF}"/>
+                <a16:creationId xmlns:a16="http://schemas.microsoft.com/office/drawing/2014/main" id="{D77C158E-22F7-4DE5-83F0-96C467B6C993}"/>
               </a:ext>
             </a:extLst>
           </p:cNvPr>
@@ -5835,7 +6387,7 @@
           <p:cNvPr id="10" name="">
             <a:extLst xmlns:a="http://schemas.openxmlformats.org/drawingml/2006/main">
               <a:ext uri="{FF2B5EF4-FFF2-40B4-BE49-F238E27FC236}">
-                <a16:creationId xmlns:a16="http://schemas.microsoft.com/office/drawing/2014/main" id="{34E16AE9-E5E8-44D8-B610-3E68CCF04099}"/>
+                <a16:creationId xmlns:a16="http://schemas.microsoft.com/office/drawing/2014/main" id="{F76BB961-C504-451A-9460-FDED48F62886}"/>
               </a:ext>
             </a:extLst>
           </p:cNvPr>
@@ -5885,7 +6437,7 @@
           <p:cNvPr id="11" name="">
             <a:extLst xmlns:a="http://schemas.openxmlformats.org/drawingml/2006/main">
               <a:ext uri="{FF2B5EF4-FFF2-40B4-BE49-F238E27FC236}">
-                <a16:creationId xmlns:a16="http://schemas.microsoft.com/office/drawing/2014/main" id="{47765F0B-F38C-4C7A-9E02-D4E444500A19}"/>
+                <a16:creationId xmlns:a16="http://schemas.microsoft.com/office/drawing/2014/main" id="{71A506DF-1E57-4BAD-A918-2EBC5C97D826}"/>
               </a:ext>
             </a:extLst>
           </p:cNvPr>
@@ -5920,7 +6472,7 @@
           <p:cNvPr id="12" name="">
             <a:extLst xmlns:a="http://schemas.openxmlformats.org/drawingml/2006/main">
               <a:ext uri="{FF2B5EF4-FFF2-40B4-BE49-F238E27FC236}">
-                <a16:creationId xmlns:a16="http://schemas.microsoft.com/office/drawing/2014/main" id="{F215179C-23F8-45AA-89A2-39F661304980}"/>
+                <a16:creationId xmlns:a16="http://schemas.microsoft.com/office/drawing/2014/main" id="{EA0574CA-6398-407D-BE1D-E9BFAC5DA3D9}"/>
               </a:ext>
             </a:extLst>
           </p:cNvPr>
@@ -5951,7 +6503,7 @@
           <p:cNvPr id="13" name="">
             <a:extLst xmlns:a="http://schemas.openxmlformats.org/drawingml/2006/main">
               <a:ext uri="{FF2B5EF4-FFF2-40B4-BE49-F238E27FC236}">
-                <a16:creationId xmlns:a16="http://schemas.microsoft.com/office/drawing/2014/main" id="{3B166B8C-A6A0-442A-A8E0-3292E7CABB25}"/>
+                <a16:creationId xmlns:a16="http://schemas.microsoft.com/office/drawing/2014/main" id="{1B5D9978-CDAE-4C4B-8A92-3DD053277FD9}"/>
               </a:ext>
             </a:extLst>
           </p:cNvPr>
@@ -6001,7 +6553,7 @@
           <p:cNvPr id="14" name="">
             <a:extLst xmlns:a="http://schemas.openxmlformats.org/drawingml/2006/main">
               <a:ext uri="{FF2B5EF4-FFF2-40B4-BE49-F238E27FC236}">
-                <a16:creationId xmlns:a16="http://schemas.microsoft.com/office/drawing/2014/main" id="{3EA0E8B4-EF41-40F5-BE17-248B2A90342C}"/>
+                <a16:creationId xmlns:a16="http://schemas.microsoft.com/office/drawing/2014/main" id="{CFE0B499-6BE6-4AF7-96FC-03CFF7461E4D}"/>
               </a:ext>
             </a:extLst>
           </p:cNvPr>
@@ -6051,7 +6603,7 @@
           <p:cNvPr id="15" name="">
             <a:extLst xmlns:a="http://schemas.openxmlformats.org/drawingml/2006/main">
               <a:ext uri="{FF2B5EF4-FFF2-40B4-BE49-F238E27FC236}">
-                <a16:creationId xmlns:a16="http://schemas.microsoft.com/office/drawing/2014/main" id="{4F933761-27BB-4337-BE09-8A4CEC5083D1}"/>
+                <a16:creationId xmlns:a16="http://schemas.microsoft.com/office/drawing/2014/main" id="{2844BB8E-3BBF-403D-B331-EAC9691B72DF}"/>
               </a:ext>
             </a:extLst>
           </p:cNvPr>
@@ -6086,7 +6638,7 @@
           <p:cNvPr id="16" name="">
             <a:extLst xmlns:a="http://schemas.openxmlformats.org/drawingml/2006/main">
               <a:ext uri="{FF2B5EF4-FFF2-40B4-BE49-F238E27FC236}">
-                <a16:creationId xmlns:a16="http://schemas.microsoft.com/office/drawing/2014/main" id="{A6FE274A-2A1A-400B-AAE7-5613AF0E3724}"/>
+                <a16:creationId xmlns:a16="http://schemas.microsoft.com/office/drawing/2014/main" id="{9A9E5133-8D95-4430-9334-5C4533980735}"/>
               </a:ext>
             </a:extLst>
           </p:cNvPr>
@@ -6117,7 +6669,7 @@
           <p:cNvPr id="17" name="">
             <a:extLst xmlns:a="http://schemas.openxmlformats.org/drawingml/2006/main">
               <a:ext uri="{FF2B5EF4-FFF2-40B4-BE49-F238E27FC236}">
-                <a16:creationId xmlns:a16="http://schemas.microsoft.com/office/drawing/2014/main" id="{B66D49E0-A410-4246-ABB8-E96F68BC52CB}"/>
+                <a16:creationId xmlns:a16="http://schemas.microsoft.com/office/drawing/2014/main" id="{E919D105-F471-42B6-A8A0-E36CAA32E905}"/>
               </a:ext>
             </a:extLst>
           </p:cNvPr>
@@ -6167,7 +6719,7 @@
           <p:cNvPr id="18" name="">
             <a:extLst xmlns:a="http://schemas.openxmlformats.org/drawingml/2006/main">
               <a:ext uri="{FF2B5EF4-FFF2-40B4-BE49-F238E27FC236}">
-                <a16:creationId xmlns:a16="http://schemas.microsoft.com/office/drawing/2014/main" id="{C5D8C4F3-E72A-41EC-98BB-6D6CA962E3A5}"/>
+                <a16:creationId xmlns:a16="http://schemas.microsoft.com/office/drawing/2014/main" id="{AAAAC141-A30D-4DB6-9F96-BD400B685D47}"/>
               </a:ext>
             </a:extLst>
           </p:cNvPr>
@@ -6269,7 +6821,7 @@
           <p:cNvPr id="21" name="">
             <a:extLst xmlns:a="http://schemas.openxmlformats.org/drawingml/2006/main">
               <a:ext uri="{FF2B5EF4-FFF2-40B4-BE49-F238E27FC236}">
-                <a16:creationId xmlns:a16="http://schemas.microsoft.com/office/drawing/2014/main" id="{1E7FE3FA-A920-4FE1-A757-1A3B2C55908C}"/>
+                <a16:creationId xmlns:a16="http://schemas.microsoft.com/office/drawing/2014/main" id="{8084AFAF-96C6-4559-872F-DB63624F590F}"/>
               </a:ext>
             </a:extLst>
           </p:cNvPr>
@@ -6302,7 +6854,7 @@
           <p:cNvPr id="22" name="">
             <a:extLst xmlns:a="http://schemas.openxmlformats.org/drawingml/2006/main">
               <a:ext uri="{FF2B5EF4-FFF2-40B4-BE49-F238E27FC236}">
-                <a16:creationId xmlns:a16="http://schemas.microsoft.com/office/drawing/2014/main" id="{51D81A04-D003-4DC9-9575-EBEE337C7B57}"/>
+                <a16:creationId xmlns:a16="http://schemas.microsoft.com/office/drawing/2014/main" id="{7D3EB990-A69F-4F2B-B68B-58BA03510CC6}"/>
               </a:ext>
             </a:extLst>
           </p:cNvPr>
@@ -6352,7 +6904,7 @@
           <p:cNvPr id="23" name="">
             <a:extLst xmlns:a="http://schemas.openxmlformats.org/drawingml/2006/main">
               <a:ext uri="{FF2B5EF4-FFF2-40B4-BE49-F238E27FC236}">
-                <a16:creationId xmlns:a16="http://schemas.microsoft.com/office/drawing/2014/main" id="{827C6955-C10A-4758-99EA-308DAD3DDD3B}"/>
+                <a16:creationId xmlns:a16="http://schemas.microsoft.com/office/drawing/2014/main" id="{46009C04-0981-4569-B37D-EE4857DDE6AC}"/>
               </a:ext>
             </a:extLst>
           </p:cNvPr>
@@ -6419,7 +6971,7 @@
           <p:cNvPr id="24" name="">
             <a:extLst xmlns:a="http://schemas.openxmlformats.org/drawingml/2006/main">
               <a:ext uri="{FF2B5EF4-FFF2-40B4-BE49-F238E27FC236}">
-                <a16:creationId xmlns:a16="http://schemas.microsoft.com/office/drawing/2014/main" id="{7C416AD9-129E-4FFD-8DB6-8DFA566A0F51}"/>
+                <a16:creationId xmlns:a16="http://schemas.microsoft.com/office/drawing/2014/main" id="{82FEF0B8-6A14-48CC-80A4-8CA566154C2C}"/>
               </a:ext>
             </a:extLst>
           </p:cNvPr>
@@ -6450,7 +7002,7 @@
           <p:cNvPr id="25" name="">
             <a:extLst xmlns:a="http://schemas.openxmlformats.org/drawingml/2006/main">
               <a:ext uri="{FF2B5EF4-FFF2-40B4-BE49-F238E27FC236}">
-                <a16:creationId xmlns:a16="http://schemas.microsoft.com/office/drawing/2014/main" id="{4BBE89DF-066C-4668-AC5C-1C77C57B89B0}"/>
+                <a16:creationId xmlns:a16="http://schemas.microsoft.com/office/drawing/2014/main" id="{40A6ECCB-EC2A-44B8-BC12-004DB2F47C71}"/>
               </a:ext>
             </a:extLst>
           </p:cNvPr>
@@ -6517,7 +7069,7 @@
           <p:cNvPr id="26" name="">
             <a:extLst xmlns:a="http://schemas.openxmlformats.org/drawingml/2006/main">
               <a:ext uri="{FF2B5EF4-FFF2-40B4-BE49-F238E27FC236}">
-                <a16:creationId xmlns:a16="http://schemas.microsoft.com/office/drawing/2014/main" id="{9164986F-4848-4E46-91B6-61594EFD158E}"/>
+                <a16:creationId xmlns:a16="http://schemas.microsoft.com/office/drawing/2014/main" id="{05309DF4-5499-48CB-85C8-DEC9B9664DBF}"/>
               </a:ext>
             </a:extLst>
           </p:cNvPr>
@@ -6567,7 +7119,7 @@
           <p:cNvPr id="27" name="">
             <a:extLst xmlns:a="http://schemas.openxmlformats.org/drawingml/2006/main">
               <a:ext uri="{FF2B5EF4-FFF2-40B4-BE49-F238E27FC236}">
-                <a16:creationId xmlns:a16="http://schemas.microsoft.com/office/drawing/2014/main" id="{CE0D6551-A77B-48CD-A141-214769533617}"/>
+                <a16:creationId xmlns:a16="http://schemas.microsoft.com/office/drawing/2014/main" id="{AC94D895-3443-43DA-B9A9-80BF14C35DBA}"/>
               </a:ext>
             </a:extLst>
           </p:cNvPr>
@@ -6598,7 +7150,7 @@
           <p:cNvPr id="28" name="">
             <a:extLst xmlns:a="http://schemas.openxmlformats.org/drawingml/2006/main">
               <a:ext uri="{FF2B5EF4-FFF2-40B4-BE49-F238E27FC236}">
-                <a16:creationId xmlns:a16="http://schemas.microsoft.com/office/drawing/2014/main" id="{1684CF0A-7F92-4FA1-B17C-3C3812B8E2BF}"/>
+                <a16:creationId xmlns:a16="http://schemas.microsoft.com/office/drawing/2014/main" id="{7E877017-74B4-4DC6-8605-E9DD2DDBC567}"/>
               </a:ext>
             </a:extLst>
           </p:cNvPr>
@@ -6648,7 +7200,7 @@
           <p:cNvPr id="29" name="">
             <a:extLst xmlns:a="http://schemas.openxmlformats.org/drawingml/2006/main">
               <a:ext uri="{FF2B5EF4-FFF2-40B4-BE49-F238E27FC236}">
-                <a16:creationId xmlns:a16="http://schemas.microsoft.com/office/drawing/2014/main" id="{CAEA9EEA-6D7A-4456-9F20-0ACA9D4C6FB9}"/>
+                <a16:creationId xmlns:a16="http://schemas.microsoft.com/office/drawing/2014/main" id="{9CD6707C-340A-496C-B23C-CB8E03F2A033}"/>
               </a:ext>
             </a:extLst>
           </p:cNvPr>
@@ -6698,7 +7250,7 @@
           <p:cNvPr id="30" name="">
             <a:extLst xmlns:a="http://schemas.openxmlformats.org/drawingml/2006/main">
               <a:ext uri="{FF2B5EF4-FFF2-40B4-BE49-F238E27FC236}">
-                <a16:creationId xmlns:a16="http://schemas.microsoft.com/office/drawing/2014/main" id="{F8A6001C-432D-4E57-8018-FD8CC090B923}"/>
+                <a16:creationId xmlns:a16="http://schemas.microsoft.com/office/drawing/2014/main" id="{E114A699-08A8-4DFB-BC74-0B857B6C612F}"/>
               </a:ext>
             </a:extLst>
           </p:cNvPr>
@@ -6729,7 +7281,7 @@
           <p:cNvPr id="31" name="">
             <a:extLst xmlns:a="http://schemas.openxmlformats.org/drawingml/2006/main">
               <a:ext uri="{FF2B5EF4-FFF2-40B4-BE49-F238E27FC236}">
-                <a16:creationId xmlns:a16="http://schemas.microsoft.com/office/drawing/2014/main" id="{28176BB8-5F6A-4EAB-B840-8E61789B40C4}"/>
+                <a16:creationId xmlns:a16="http://schemas.microsoft.com/office/drawing/2014/main" id="{A0676292-E46F-4DF0-A5D1-64C97BC9FB29}"/>
               </a:ext>
             </a:extLst>
           </p:cNvPr>
@@ -6779,7 +7331,7 @@
           <p:cNvPr id="32" name="">
             <a:extLst xmlns:a="http://schemas.openxmlformats.org/drawingml/2006/main">
               <a:ext uri="{FF2B5EF4-FFF2-40B4-BE49-F238E27FC236}">
-                <a16:creationId xmlns:a16="http://schemas.microsoft.com/office/drawing/2014/main" id="{6C580A11-E365-48F7-87AC-F984138EC6B2}"/>
+                <a16:creationId xmlns:a16="http://schemas.microsoft.com/office/drawing/2014/main" id="{0536BED2-F1CC-400C-98AF-40E19A011099}"/>
               </a:ext>
             </a:extLst>
           </p:cNvPr>
@@ -6829,7 +7381,7 @@
           <p:cNvPr id="33" name="">
             <a:extLst xmlns:a="http://schemas.openxmlformats.org/drawingml/2006/main">
               <a:ext uri="{FF2B5EF4-FFF2-40B4-BE49-F238E27FC236}">
-                <a16:creationId xmlns:a16="http://schemas.microsoft.com/office/drawing/2014/main" id="{AEC10707-D4BC-42FB-B7A0-9FB4D4276A62}"/>
+                <a16:creationId xmlns:a16="http://schemas.microsoft.com/office/drawing/2014/main" id="{62EFE67C-A01E-46A4-9B8D-D5337E95DAFE}"/>
               </a:ext>
             </a:extLst>
           </p:cNvPr>
@@ -6860,7 +7412,7 @@
           <p:cNvPr id="34" name="">
             <a:extLst xmlns:a="http://schemas.openxmlformats.org/drawingml/2006/main">
               <a:ext uri="{FF2B5EF4-FFF2-40B4-BE49-F238E27FC236}">
-                <a16:creationId xmlns:a16="http://schemas.microsoft.com/office/drawing/2014/main" id="{0CD597B3-951C-4827-8416-06DEB9962275}"/>
+                <a16:creationId xmlns:a16="http://schemas.microsoft.com/office/drawing/2014/main" id="{EE7FEFE2-4177-47EF-A02E-F9551338EB00}"/>
               </a:ext>
             </a:extLst>
           </p:cNvPr>
@@ -6910,7 +7462,7 @@
           <p:cNvPr id="35" name="">
             <a:extLst xmlns:a="http://schemas.openxmlformats.org/drawingml/2006/main">
               <a:ext uri="{FF2B5EF4-FFF2-40B4-BE49-F238E27FC236}">
-                <a16:creationId xmlns:a16="http://schemas.microsoft.com/office/drawing/2014/main" id="{5F0B025A-6180-4C8F-9E38-39883CB79643}"/>
+                <a16:creationId xmlns:a16="http://schemas.microsoft.com/office/drawing/2014/main" id="{45464A34-FE57-4633-8E5D-C506F8AAF163}"/>
               </a:ext>
             </a:extLst>
           </p:cNvPr>
@@ -6960,7 +7512,7 @@
           <p:cNvPr id="36" name="">
             <a:extLst xmlns:a="http://schemas.openxmlformats.org/drawingml/2006/main">
               <a:ext uri="{FF2B5EF4-FFF2-40B4-BE49-F238E27FC236}">
-                <a16:creationId xmlns:a16="http://schemas.microsoft.com/office/drawing/2014/main" id="{8CE838E2-B737-41E4-AD8D-893FFC016EEE}"/>
+                <a16:creationId xmlns:a16="http://schemas.microsoft.com/office/drawing/2014/main" id="{F63ED617-2F85-49D0-8725-188111E62497}"/>
               </a:ext>
             </a:extLst>
           </p:cNvPr>
@@ -6991,7 +7543,7 @@
           <p:cNvPr id="37" name="">
             <a:extLst xmlns:a="http://schemas.openxmlformats.org/drawingml/2006/main">
               <a:ext uri="{FF2B5EF4-FFF2-40B4-BE49-F238E27FC236}">
-                <a16:creationId xmlns:a16="http://schemas.microsoft.com/office/drawing/2014/main" id="{A91BE9A8-9B1E-494E-A730-63C390C88704}"/>
+                <a16:creationId xmlns:a16="http://schemas.microsoft.com/office/drawing/2014/main" id="{1BF27FAC-0ACE-435B-90E6-199E5B98DADC}"/>
               </a:ext>
             </a:extLst>
           </p:cNvPr>
@@ -7041,7 +7593,7 @@
           <p:cNvPr id="38" name="">
             <a:extLst xmlns:a="http://schemas.openxmlformats.org/drawingml/2006/main">
               <a:ext uri="{FF2B5EF4-FFF2-40B4-BE49-F238E27FC236}">
-                <a16:creationId xmlns:a16="http://schemas.microsoft.com/office/drawing/2014/main" id="{14ECCE59-178E-45C7-A0A2-9B24ECB2C6EA}"/>
+                <a16:creationId xmlns:a16="http://schemas.microsoft.com/office/drawing/2014/main" id="{4701327E-3483-4DB9-A283-BE187602F484}"/>
               </a:ext>
             </a:extLst>
           </p:cNvPr>
@@ -7091,7 +7643,7 @@
           <p:cNvPr id="39" name="">
             <a:extLst xmlns:a="http://schemas.openxmlformats.org/drawingml/2006/main">
               <a:ext uri="{FF2B5EF4-FFF2-40B4-BE49-F238E27FC236}">
-                <a16:creationId xmlns:a16="http://schemas.microsoft.com/office/drawing/2014/main" id="{80B3BC51-2B49-483B-8980-6F6F8390BE74}"/>
+                <a16:creationId xmlns:a16="http://schemas.microsoft.com/office/drawing/2014/main" id="{62C24521-7DD6-4D9F-9228-2779DC8BA9A6}"/>
               </a:ext>
             </a:extLst>
           </p:cNvPr>
@@ -7139,7 +7691,7 @@
     </p:spTree>
     <p:extLst>
       <p:ext uri="{BB962C8B-B14F-4D97-AF65-F5344CB8AC3E}">
-        <p14:creationId xmlns:p14="http://schemas.microsoft.com/office/powerpoint/2010/main" val="915565448"/>
+        <p14:creationId xmlns:p14="http://schemas.microsoft.com/office/powerpoint/2010/main" val="837636578"/>
       </p:ext>
     </p:extLst>
   </p:cSld>
@@ -7170,7 +7722,7 @@
           <p:cNvPr id="18" name="">
             <a:extLst xmlns:a="http://schemas.openxmlformats.org/drawingml/2006/main">
               <a:ext uri="{FF2B5EF4-FFF2-40B4-BE49-F238E27FC236}">
-                <a16:creationId xmlns:a16="http://schemas.microsoft.com/office/drawing/2014/main" id="{FC4F47F2-EF89-4904-A168-A8E56B5B43E0}"/>
+                <a16:creationId xmlns:a16="http://schemas.microsoft.com/office/drawing/2014/main" id="{3BB6AC5E-5356-4751-88D1-9F9DBCB80E3A}"/>
               </a:ext>
             </a:extLst>
           </p:cNvPr>
@@ -7220,7 +7772,7 @@
           <p:cNvPr id="2" name="">
             <a:extLst xmlns:a="http://schemas.openxmlformats.org/drawingml/2006/main">
               <a:ext uri="{FF2B5EF4-FFF2-40B4-BE49-F238E27FC236}">
-                <a16:creationId xmlns:a16="http://schemas.microsoft.com/office/drawing/2014/main" id="{8483B683-8E55-462D-BE2E-AC827A11F959}"/>
+                <a16:creationId xmlns:a16="http://schemas.microsoft.com/office/drawing/2014/main" id="{0B74C753-BDB9-48D7-BC09-B0120EEFA5DC}"/>
               </a:ext>
             </a:extLst>
           </p:cNvPr>
@@ -7270,7 +7822,7 @@
           <p:cNvPr id="3" name="">
             <a:extLst xmlns:a="http://schemas.openxmlformats.org/drawingml/2006/main">
               <a:ext uri="{FF2B5EF4-FFF2-40B4-BE49-F238E27FC236}">
-                <a16:creationId xmlns:a16="http://schemas.microsoft.com/office/drawing/2014/main" id="{737A150B-B761-47D8-858E-15249A40CF5B}"/>
+                <a16:creationId xmlns:a16="http://schemas.microsoft.com/office/drawing/2014/main" id="{06CB0210-DF62-44BE-9715-39517D524F14}"/>
               </a:ext>
             </a:extLst>
           </p:cNvPr>
@@ -7301,7 +7853,7 @@
           <p:cNvPr id="4" name="">
             <a:extLst xmlns:a="http://schemas.openxmlformats.org/drawingml/2006/main">
               <a:ext uri="{FF2B5EF4-FFF2-40B4-BE49-F238E27FC236}">
-                <a16:creationId xmlns:a16="http://schemas.microsoft.com/office/drawing/2014/main" id="{1ECDD8E5-667E-4736-8F69-C0DF86981489}"/>
+                <a16:creationId xmlns:a16="http://schemas.microsoft.com/office/drawing/2014/main" id="{A8113DAD-138E-4DAA-A66A-8632F2FD230F}"/>
               </a:ext>
             </a:extLst>
           </p:cNvPr>
@@ -7332,7 +7884,7 @@
           <p:cNvPr id="5" name="">
             <a:extLst xmlns:a="http://schemas.openxmlformats.org/drawingml/2006/main">
               <a:ext uri="{FF2B5EF4-FFF2-40B4-BE49-F238E27FC236}">
-                <a16:creationId xmlns:a16="http://schemas.microsoft.com/office/drawing/2014/main" id="{C57BE8A4-EF9E-4431-A4C8-38A3D0B2C639}"/>
+                <a16:creationId xmlns:a16="http://schemas.microsoft.com/office/drawing/2014/main" id="{20DA7889-F428-4FEE-8A4D-92D600A0DBE2}"/>
               </a:ext>
             </a:extLst>
           </p:cNvPr>
@@ -7382,7 +7934,7 @@
           <p:cNvPr id="6" name="">
             <a:extLst xmlns:a="http://schemas.openxmlformats.org/drawingml/2006/main">
               <a:ext uri="{FF2B5EF4-FFF2-40B4-BE49-F238E27FC236}">
-                <a16:creationId xmlns:a16="http://schemas.microsoft.com/office/drawing/2014/main" id="{DE141DF3-E82F-44DF-97F8-FE32D0A55BF9}"/>
+                <a16:creationId xmlns:a16="http://schemas.microsoft.com/office/drawing/2014/main" id="{7896551E-B104-42C2-9126-A130474D4FD5}"/>
               </a:ext>
             </a:extLst>
           </p:cNvPr>
@@ -7421,7 +7973,7 @@
           <p:nvPr/>
         </p:nvPicPr>
         <p:blipFill>
-          <a:blip xmlns:r="http://schemas.openxmlformats.org/officeDocument/2006/relationships" xmlns:a="http://schemas.openxmlformats.org/drawingml/2006/main" r:embed="R08d778bcf78242d7"/>
+          <a:blip xmlns:r="http://schemas.openxmlformats.org/officeDocument/2006/relationships" xmlns:a="http://schemas.openxmlformats.org/drawingml/2006/main" r:embed="Ra9301ccf68354abe"/>
           <a:stretch xmlns:a="http://schemas.openxmlformats.org/drawingml/2006/main"/>
         </p:blipFill>
         <p:spPr>
@@ -7439,7 +7991,7 @@
           <p:cNvPr id="8" name="">
             <a:extLst xmlns:a="http://schemas.openxmlformats.org/drawingml/2006/main">
               <a:ext uri="{FF2B5EF4-FFF2-40B4-BE49-F238E27FC236}">
-                <a16:creationId xmlns:a16="http://schemas.microsoft.com/office/drawing/2014/main" id="{48E64EAB-A903-4FF9-95D4-5960B4D1928A}"/>
+                <a16:creationId xmlns:a16="http://schemas.microsoft.com/office/drawing/2014/main" id="{66BD7D67-CFA7-4E0E-BC80-79CDC92BAEDF}"/>
               </a:ext>
             </a:extLst>
           </p:cNvPr>
@@ -7489,7 +8041,7 @@
           <p:cNvPr id="9" name="">
             <a:extLst xmlns:a="http://schemas.openxmlformats.org/drawingml/2006/main">
               <a:ext uri="{FF2B5EF4-FFF2-40B4-BE49-F238E27FC236}">
-                <a16:creationId xmlns:a16="http://schemas.microsoft.com/office/drawing/2014/main" id="{D367876D-7283-4698-B474-4C4E4FC9A41E}"/>
+                <a16:creationId xmlns:a16="http://schemas.microsoft.com/office/drawing/2014/main" id="{100EF4B0-C095-4DEB-9347-60DC234C603B}"/>
               </a:ext>
             </a:extLst>
           </p:cNvPr>
@@ -7522,7 +8074,7 @@
           <p:cNvPr id="10" name="">
             <a:extLst xmlns:a="http://schemas.openxmlformats.org/drawingml/2006/main">
               <a:ext uri="{FF2B5EF4-FFF2-40B4-BE49-F238E27FC236}">
-                <a16:creationId xmlns:a16="http://schemas.microsoft.com/office/drawing/2014/main" id="{C7979601-4B0D-45D4-AD70-28B07138BB4F}"/>
+                <a16:creationId xmlns:a16="http://schemas.microsoft.com/office/drawing/2014/main" id="{9EFC8FBA-4365-4D28-9289-7A32A088DDAA}"/>
               </a:ext>
             </a:extLst>
           </p:cNvPr>
@@ -7572,7 +8124,7 @@
           <p:cNvPr id="11" name="">
             <a:extLst xmlns:a="http://schemas.openxmlformats.org/drawingml/2006/main">
               <a:ext uri="{FF2B5EF4-FFF2-40B4-BE49-F238E27FC236}">
-                <a16:creationId xmlns:a16="http://schemas.microsoft.com/office/drawing/2014/main" id="{728C8B2E-F4C5-4552-A210-EA59D915573F}"/>
+                <a16:creationId xmlns:a16="http://schemas.microsoft.com/office/drawing/2014/main" id="{C324DD65-4BC6-4410-9261-186631933422}"/>
               </a:ext>
             </a:extLst>
           </p:cNvPr>
@@ -7622,7 +8174,7 @@
           <p:cNvPr id="12" name="">
             <a:extLst xmlns:a="http://schemas.openxmlformats.org/drawingml/2006/main">
               <a:ext uri="{FF2B5EF4-FFF2-40B4-BE49-F238E27FC236}">
-                <a16:creationId xmlns:a16="http://schemas.microsoft.com/office/drawing/2014/main" id="{EAF23C35-7B38-4515-BCA1-20A01C3A6FA4}"/>
+                <a16:creationId xmlns:a16="http://schemas.microsoft.com/office/drawing/2014/main" id="{0F1EAFE6-B79D-49D6-80AF-4F0F3A307A78}"/>
               </a:ext>
             </a:extLst>
           </p:cNvPr>
@@ -7657,7 +8209,7 @@
           <p:cNvPr id="13" name="">
             <a:extLst xmlns:a="http://schemas.openxmlformats.org/drawingml/2006/main">
               <a:ext uri="{FF2B5EF4-FFF2-40B4-BE49-F238E27FC236}">
-                <a16:creationId xmlns:a16="http://schemas.microsoft.com/office/drawing/2014/main" id="{28B86277-448E-4DC3-B86A-2915B9768E9F}"/>
+                <a16:creationId xmlns:a16="http://schemas.microsoft.com/office/drawing/2014/main" id="{3C2E8726-F8CB-4275-9C47-96D88947BB44}"/>
               </a:ext>
             </a:extLst>
           </p:cNvPr>
@@ -7707,7 +8259,7 @@
           <p:cNvPr id="14" name="">
             <a:extLst xmlns:a="http://schemas.openxmlformats.org/drawingml/2006/main">
               <a:ext uri="{FF2B5EF4-FFF2-40B4-BE49-F238E27FC236}">
-                <a16:creationId xmlns:a16="http://schemas.microsoft.com/office/drawing/2014/main" id="{F5882343-D7D9-4EA2-917C-A1FB55FABCAE}"/>
+                <a16:creationId xmlns:a16="http://schemas.microsoft.com/office/drawing/2014/main" id="{8F7526A3-2D30-4AD3-86E7-ECF5D04FE53C}"/>
               </a:ext>
             </a:extLst>
           </p:cNvPr>
@@ -7757,7 +8309,7 @@
           <p:cNvPr id="15" name="">
             <a:extLst xmlns:a="http://schemas.openxmlformats.org/drawingml/2006/main">
               <a:ext uri="{FF2B5EF4-FFF2-40B4-BE49-F238E27FC236}">
-                <a16:creationId xmlns:a16="http://schemas.microsoft.com/office/drawing/2014/main" id="{2AAB819D-F26F-4AD9-9B9E-35ABB6B606B1}"/>
+                <a16:creationId xmlns:a16="http://schemas.microsoft.com/office/drawing/2014/main" id="{8750228A-71FA-4984-A714-8CD0EC50CE14}"/>
               </a:ext>
             </a:extLst>
           </p:cNvPr>
@@ -7788,7 +8340,7 @@
           <p:cNvPr id="16" name="">
             <a:extLst xmlns:a="http://schemas.openxmlformats.org/drawingml/2006/main">
               <a:ext uri="{FF2B5EF4-FFF2-40B4-BE49-F238E27FC236}">
-                <a16:creationId xmlns:a16="http://schemas.microsoft.com/office/drawing/2014/main" id="{F580CBAB-145B-4A35-818A-69AA27F5F76D}"/>
+                <a16:creationId xmlns:a16="http://schemas.microsoft.com/office/drawing/2014/main" id="{AED7F736-7D85-4F60-BF2A-D515FE102A93}"/>
               </a:ext>
             </a:extLst>
           </p:cNvPr>
@@ -7838,7 +8390,7 @@
           <p:cNvPr id="17" name="">
             <a:extLst xmlns:a="http://schemas.openxmlformats.org/drawingml/2006/main">
               <a:ext uri="{FF2B5EF4-FFF2-40B4-BE49-F238E27FC236}">
-                <a16:creationId xmlns:a16="http://schemas.microsoft.com/office/drawing/2014/main" id="{D4124180-A22E-4D68-A841-EBE95AB31F19}"/>
+                <a16:creationId xmlns:a16="http://schemas.microsoft.com/office/drawing/2014/main" id="{B53575E6-CC25-423B-B17D-8CA87DFFC495}"/>
               </a:ext>
             </a:extLst>
           </p:cNvPr>
@@ -7886,7 +8438,7 @@
     </p:spTree>
     <p:extLst>
       <p:ext uri="{BB962C8B-B14F-4D97-AF65-F5344CB8AC3E}">
-        <p14:creationId xmlns:p14="http://schemas.microsoft.com/office/powerpoint/2010/main" val="1214159557"/>
+        <p14:creationId xmlns:p14="http://schemas.microsoft.com/office/powerpoint/2010/main" val="1442085954"/>
       </p:ext>
     </p:extLst>
   </p:cSld>
@@ -7917,7 +8469,7 @@
           <p:cNvPr id="17" name="">
             <a:extLst xmlns:a="http://schemas.openxmlformats.org/drawingml/2006/main">
               <a:ext uri="{FF2B5EF4-FFF2-40B4-BE49-F238E27FC236}">
-                <a16:creationId xmlns:a16="http://schemas.microsoft.com/office/drawing/2014/main" id="{EB86D4F2-66C8-4265-AE0B-2CC335B2F043}"/>
+                <a16:creationId xmlns:a16="http://schemas.microsoft.com/office/drawing/2014/main" id="{54CC4606-2A13-4B03-B368-1152C9A0220A}"/>
               </a:ext>
             </a:extLst>
           </p:cNvPr>
@@ -7967,7 +8519,7 @@
           <p:cNvPr id="2" name="">
             <a:extLst xmlns:a="http://schemas.openxmlformats.org/drawingml/2006/main">
               <a:ext uri="{FF2B5EF4-FFF2-40B4-BE49-F238E27FC236}">
-                <a16:creationId xmlns:a16="http://schemas.microsoft.com/office/drawing/2014/main" id="{C75C48CB-03F6-4097-9288-82E7A2F30E68}"/>
+                <a16:creationId xmlns:a16="http://schemas.microsoft.com/office/drawing/2014/main" id="{752DCA8F-E4C2-4650-A3F7-0FC78268857C}"/>
               </a:ext>
             </a:extLst>
           </p:cNvPr>
@@ -8017,7 +8569,7 @@
           <p:cNvPr id="3" name="">
             <a:extLst xmlns:a="http://schemas.openxmlformats.org/drawingml/2006/main">
               <a:ext uri="{FF2B5EF4-FFF2-40B4-BE49-F238E27FC236}">
-                <a16:creationId xmlns:a16="http://schemas.microsoft.com/office/drawing/2014/main" id="{C9FB9898-EEF8-462B-B3CC-98DA587D5EFD}"/>
+                <a16:creationId xmlns:a16="http://schemas.microsoft.com/office/drawing/2014/main" id="{AED91791-4262-4602-9434-026FA789C9F6}"/>
               </a:ext>
             </a:extLst>
           </p:cNvPr>
@@ -8048,7 +8600,7 @@
           <p:cNvPr id="4" name="">
             <a:extLst xmlns:a="http://schemas.openxmlformats.org/drawingml/2006/main">
               <a:ext uri="{FF2B5EF4-FFF2-40B4-BE49-F238E27FC236}">
-                <a16:creationId xmlns:a16="http://schemas.microsoft.com/office/drawing/2014/main" id="{3AD2B02C-6673-4642-8070-328D999C127B}"/>
+                <a16:creationId xmlns:a16="http://schemas.microsoft.com/office/drawing/2014/main" id="{A304673F-3FFE-4402-877F-3A1C4F23DF38}"/>
               </a:ext>
             </a:extLst>
           </p:cNvPr>
@@ -8079,7 +8631,7 @@
           <p:cNvPr id="5" name="">
             <a:extLst xmlns:a="http://schemas.openxmlformats.org/drawingml/2006/main">
               <a:ext uri="{FF2B5EF4-FFF2-40B4-BE49-F238E27FC236}">
-                <a16:creationId xmlns:a16="http://schemas.microsoft.com/office/drawing/2014/main" id="{8D553222-C8A3-4CAD-8020-077A84D1E7CE}"/>
+                <a16:creationId xmlns:a16="http://schemas.microsoft.com/office/drawing/2014/main" id="{BB6EA322-F7B6-479B-8E2B-797DC7E061B0}"/>
               </a:ext>
             </a:extLst>
           </p:cNvPr>
@@ -8129,7 +8681,7 @@
           <p:cNvPr id="6" name="">
             <a:extLst xmlns:a="http://schemas.openxmlformats.org/drawingml/2006/main">
               <a:ext uri="{FF2B5EF4-FFF2-40B4-BE49-F238E27FC236}">
-                <a16:creationId xmlns:a16="http://schemas.microsoft.com/office/drawing/2014/main" id="{1DF8A39F-0B5C-422E-AC84-F99491935732}"/>
+                <a16:creationId xmlns:a16="http://schemas.microsoft.com/office/drawing/2014/main" id="{0A5FF7A9-345B-49F4-A0F8-B656F9B38FF4}"/>
               </a:ext>
             </a:extLst>
           </p:cNvPr>
@@ -8168,7 +8720,7 @@
           <p:nvPr/>
         </p:nvPicPr>
         <p:blipFill>
-          <a:blip xmlns:r="http://schemas.openxmlformats.org/officeDocument/2006/relationships" xmlns:a="http://schemas.openxmlformats.org/drawingml/2006/main" r:embed="R8a28dbf586e84936"/>
+          <a:blip xmlns:r="http://schemas.openxmlformats.org/officeDocument/2006/relationships" xmlns:a="http://schemas.openxmlformats.org/drawingml/2006/main" r:embed="R528c3d4c778f4dd8"/>
           <a:stretch xmlns:a="http://schemas.openxmlformats.org/drawingml/2006/main"/>
         </p:blipFill>
         <p:spPr>
@@ -8186,7 +8738,7 @@
           <p:cNvPr id="8" name="">
             <a:extLst xmlns:a="http://schemas.openxmlformats.org/drawingml/2006/main">
               <a:ext uri="{FF2B5EF4-FFF2-40B4-BE49-F238E27FC236}">
-                <a16:creationId xmlns:a16="http://schemas.microsoft.com/office/drawing/2014/main" id="{0A2D27B4-35D9-4738-B75B-906A91B2B5EF}"/>
+                <a16:creationId xmlns:a16="http://schemas.microsoft.com/office/drawing/2014/main" id="{9ACC8C88-040A-44A9-B6D8-5A3A79169020}"/>
               </a:ext>
             </a:extLst>
           </p:cNvPr>
@@ -8236,7 +8788,7 @@
           <p:cNvPr id="9" name="">
             <a:extLst xmlns:a="http://schemas.openxmlformats.org/drawingml/2006/main">
               <a:ext uri="{FF2B5EF4-FFF2-40B4-BE49-F238E27FC236}">
-                <a16:creationId xmlns:a16="http://schemas.microsoft.com/office/drawing/2014/main" id="{A28EF6D3-E4C8-48E0-A7D1-CE0D4BE51F03}"/>
+                <a16:creationId xmlns:a16="http://schemas.microsoft.com/office/drawing/2014/main" id="{8C34277C-79C3-4B9B-900E-198BCF23353A}"/>
               </a:ext>
             </a:extLst>
           </p:cNvPr>
@@ -8293,7 +8845,7 @@
         </p:xfrm>
         <a:graphic xmlns:a="http://schemas.openxmlformats.org/drawingml/2006/main">
           <a:graphicData uri="http://schemas.openxmlformats.org/drawingml/2006/chart">
-            <c:chart xmlns:r="http://schemas.openxmlformats.org/officeDocument/2006/relationships" xmlns:c="http://schemas.openxmlformats.org/drawingml/2006/chart" r:id="R5697bddb977341b4"/>
+            <c:chart xmlns:r="http://schemas.openxmlformats.org/officeDocument/2006/relationships" xmlns:c="http://schemas.openxmlformats.org/drawingml/2006/chart" r:id="Rf1d72ce629c448b1"/>
           </a:graphicData>
         </a:graphic>
       </p:graphicFrame>
@@ -8302,7 +8854,7 @@
           <p:cNvPr id="11" name="">
             <a:extLst xmlns:a="http://schemas.openxmlformats.org/drawingml/2006/main">
               <a:ext uri="{FF2B5EF4-FFF2-40B4-BE49-F238E27FC236}">
-                <a16:creationId xmlns:a16="http://schemas.microsoft.com/office/drawing/2014/main" id="{8848B8F1-706B-4CA5-8B73-A14C8A033007}"/>
+                <a16:creationId xmlns:a16="http://schemas.microsoft.com/office/drawing/2014/main" id="{82DDECC3-D5C8-4FD0-A7CF-3E02C6165AF1}"/>
               </a:ext>
             </a:extLst>
           </p:cNvPr>
@@ -8333,7 +8885,7 @@
           <p:cNvPr id="12" name="">
             <a:extLst xmlns:a="http://schemas.openxmlformats.org/drawingml/2006/main">
               <a:ext uri="{FF2B5EF4-FFF2-40B4-BE49-F238E27FC236}">
-                <a16:creationId xmlns:a16="http://schemas.microsoft.com/office/drawing/2014/main" id="{05D9DFBD-8C95-41FF-B023-CA459CCF7832}"/>
+                <a16:creationId xmlns:a16="http://schemas.microsoft.com/office/drawing/2014/main" id="{8FDD24EF-509D-4D04-95F0-848FA139ADE3}"/>
               </a:ext>
             </a:extLst>
           </p:cNvPr>
@@ -8383,7 +8935,7 @@
           <p:cNvPr id="13" name="">
             <a:extLst xmlns:a="http://schemas.openxmlformats.org/drawingml/2006/main">
               <a:ext uri="{FF2B5EF4-FFF2-40B4-BE49-F238E27FC236}">
-                <a16:creationId xmlns:a16="http://schemas.microsoft.com/office/drawing/2014/main" id="{A2FA977E-F1EC-4A56-9B35-2F279D240813}"/>
+                <a16:creationId xmlns:a16="http://schemas.microsoft.com/office/drawing/2014/main" id="{7BAFB414-705F-4EAC-92E3-A31A5F37D6E4}"/>
               </a:ext>
             </a:extLst>
           </p:cNvPr>
@@ -8433,7 +8985,7 @@
           <p:cNvPr id="14" name="">
             <a:extLst xmlns:a="http://schemas.openxmlformats.org/drawingml/2006/main">
               <a:ext uri="{FF2B5EF4-FFF2-40B4-BE49-F238E27FC236}">
-                <a16:creationId xmlns:a16="http://schemas.microsoft.com/office/drawing/2014/main" id="{15D112D9-1234-4EC2-8A9F-F545C2F15C92}"/>
+                <a16:creationId xmlns:a16="http://schemas.microsoft.com/office/drawing/2014/main" id="{3A0943A2-2955-4010-8557-66AAD6BDCCCB}"/>
               </a:ext>
             </a:extLst>
           </p:cNvPr>
@@ -8483,7 +9035,7 @@
           <p:cNvPr id="15" name="">
             <a:extLst xmlns:a="http://schemas.openxmlformats.org/drawingml/2006/main">
               <a:ext uri="{FF2B5EF4-FFF2-40B4-BE49-F238E27FC236}">
-                <a16:creationId xmlns:a16="http://schemas.microsoft.com/office/drawing/2014/main" id="{8597883E-7242-44FC-9467-F8B5E876923B}"/>
+                <a16:creationId xmlns:a16="http://schemas.microsoft.com/office/drawing/2014/main" id="{F810CAC2-1992-440B-BB1C-9E38E8B6CDAE}"/>
               </a:ext>
             </a:extLst>
           </p:cNvPr>
@@ -8533,7 +9085,7 @@
           <p:cNvPr id="16" name="">
             <a:extLst xmlns:a="http://schemas.openxmlformats.org/drawingml/2006/main">
               <a:ext uri="{FF2B5EF4-FFF2-40B4-BE49-F238E27FC236}">
-                <a16:creationId xmlns:a16="http://schemas.microsoft.com/office/drawing/2014/main" id="{92C17192-8D76-4001-99FD-BDAA18C819FB}"/>
+                <a16:creationId xmlns:a16="http://schemas.microsoft.com/office/drawing/2014/main" id="{79B324AA-5B06-4BA0-B5AE-3532424CD444}"/>
               </a:ext>
             </a:extLst>
           </p:cNvPr>
@@ -8581,7 +9133,7 @@
     </p:spTree>
     <p:extLst>
       <p:ext uri="{BB962C8B-B14F-4D97-AF65-F5344CB8AC3E}">
-        <p14:creationId xmlns:p14="http://schemas.microsoft.com/office/powerpoint/2010/main" val="536168642"/>
+        <p14:creationId xmlns:p14="http://schemas.microsoft.com/office/powerpoint/2010/main" val="1701459714"/>
       </p:ext>
     </p:extLst>
   </p:cSld>
@@ -8612,7 +9164,7 @@
           <p:cNvPr id="36" name="">
             <a:extLst xmlns:a="http://schemas.openxmlformats.org/drawingml/2006/main">
               <a:ext uri="{FF2B5EF4-FFF2-40B4-BE49-F238E27FC236}">
-                <a16:creationId xmlns:a16="http://schemas.microsoft.com/office/drawing/2014/main" id="{18FDFC21-FA17-4D90-B4DC-E956035C852A}"/>
+                <a16:creationId xmlns:a16="http://schemas.microsoft.com/office/drawing/2014/main" id="{ECDFFF5F-FB75-445A-B295-C4C78E0793F0}"/>
               </a:ext>
             </a:extLst>
           </p:cNvPr>
@@ -8662,7 +9214,7 @@
           <p:cNvPr id="2" name="">
             <a:extLst xmlns:a="http://schemas.openxmlformats.org/drawingml/2006/main">
               <a:ext uri="{FF2B5EF4-FFF2-40B4-BE49-F238E27FC236}">
-                <a16:creationId xmlns:a16="http://schemas.microsoft.com/office/drawing/2014/main" id="{AC984FFD-3E79-4B12-A392-7C3624A25DF9}"/>
+                <a16:creationId xmlns:a16="http://schemas.microsoft.com/office/drawing/2014/main" id="{1E5A4542-02C1-4324-8A66-715E48363C00}"/>
               </a:ext>
             </a:extLst>
           </p:cNvPr>
@@ -8712,7 +9264,7 @@
           <p:cNvPr id="3" name="">
             <a:extLst xmlns:a="http://schemas.openxmlformats.org/drawingml/2006/main">
               <a:ext uri="{FF2B5EF4-FFF2-40B4-BE49-F238E27FC236}">
-                <a16:creationId xmlns:a16="http://schemas.microsoft.com/office/drawing/2014/main" id="{207E935F-B262-4C68-AC4A-E40510BB9A06}"/>
+                <a16:creationId xmlns:a16="http://schemas.microsoft.com/office/drawing/2014/main" id="{0C2487E7-86F3-4553-8009-4E3A1CDD1997}"/>
               </a:ext>
             </a:extLst>
           </p:cNvPr>
@@ -8743,7 +9295,7 @@
           <p:cNvPr id="4" name="">
             <a:extLst xmlns:a="http://schemas.openxmlformats.org/drawingml/2006/main">
               <a:ext uri="{FF2B5EF4-FFF2-40B4-BE49-F238E27FC236}">
-                <a16:creationId xmlns:a16="http://schemas.microsoft.com/office/drawing/2014/main" id="{60BA9360-A84C-444C-8562-4D72C0FA0A5B}"/>
+                <a16:creationId xmlns:a16="http://schemas.microsoft.com/office/drawing/2014/main" id="{609FCC23-C0CE-40E9-B6C7-E581E24A75D4}"/>
               </a:ext>
             </a:extLst>
           </p:cNvPr>
@@ -8774,7 +9326,7 @@
           <p:cNvPr id="5" name="">
             <a:extLst xmlns:a="http://schemas.openxmlformats.org/drawingml/2006/main">
               <a:ext uri="{FF2B5EF4-FFF2-40B4-BE49-F238E27FC236}">
-                <a16:creationId xmlns:a16="http://schemas.microsoft.com/office/drawing/2014/main" id="{3D2533AE-A842-4AA7-9002-03F2C8A5DD80}"/>
+                <a16:creationId xmlns:a16="http://schemas.microsoft.com/office/drawing/2014/main" id="{12AC5769-235B-48F2-9CBB-203778EFFC8C}"/>
               </a:ext>
             </a:extLst>
           </p:cNvPr>
@@ -8824,7 +9376,7 @@
           <p:cNvPr id="6" name="">
             <a:extLst xmlns:a="http://schemas.openxmlformats.org/drawingml/2006/main">
               <a:ext uri="{FF2B5EF4-FFF2-40B4-BE49-F238E27FC236}">
-                <a16:creationId xmlns:a16="http://schemas.microsoft.com/office/drawing/2014/main" id="{13E3F45A-7380-4DCD-85B8-486730B08A05}"/>
+                <a16:creationId xmlns:a16="http://schemas.microsoft.com/office/drawing/2014/main" id="{983D566E-6C0C-4042-9FCF-82D825EC1DCE}"/>
               </a:ext>
             </a:extLst>
           </p:cNvPr>
@@ -8857,7 +9409,7 @@
           <p:cNvPr id="7" name="">
             <a:extLst xmlns:a="http://schemas.openxmlformats.org/drawingml/2006/main">
               <a:ext uri="{FF2B5EF4-FFF2-40B4-BE49-F238E27FC236}">
-                <a16:creationId xmlns:a16="http://schemas.microsoft.com/office/drawing/2014/main" id="{CA409C34-8313-491D-8115-268280D1B4D6}"/>
+                <a16:creationId xmlns:a16="http://schemas.microsoft.com/office/drawing/2014/main" id="{F6F94FD8-3BD5-4F6C-A9EC-F80A2064643B}"/>
               </a:ext>
             </a:extLst>
           </p:cNvPr>
@@ -8907,7 +9459,7 @@
           <p:cNvPr id="8" name="">
             <a:extLst xmlns:a="http://schemas.openxmlformats.org/drawingml/2006/main">
               <a:ext uri="{FF2B5EF4-FFF2-40B4-BE49-F238E27FC236}">
-                <a16:creationId xmlns:a16="http://schemas.microsoft.com/office/drawing/2014/main" id="{88309BF6-55FE-42C9-9899-C55361134C70}"/>
+                <a16:creationId xmlns:a16="http://schemas.microsoft.com/office/drawing/2014/main" id="{C8DE0C92-6744-4249-9768-2825F50F2A8F}"/>
               </a:ext>
             </a:extLst>
           </p:cNvPr>
@@ -8938,7 +9490,7 @@
           <p:cNvPr id="9" name="">
             <a:extLst xmlns:a="http://schemas.openxmlformats.org/drawingml/2006/main">
               <a:ext uri="{FF2B5EF4-FFF2-40B4-BE49-F238E27FC236}">
-                <a16:creationId xmlns:a16="http://schemas.microsoft.com/office/drawing/2014/main" id="{3329E20F-51EC-4BEE-B69B-3AB77A3F7681}"/>
+                <a16:creationId xmlns:a16="http://schemas.microsoft.com/office/drawing/2014/main" id="{10FDC0AB-06B8-40D3-9273-D3E3256506E4}"/>
               </a:ext>
             </a:extLst>
           </p:cNvPr>
@@ -8988,7 +9540,7 @@
           <p:cNvPr id="10" name="">
             <a:extLst xmlns:a="http://schemas.openxmlformats.org/drawingml/2006/main">
               <a:ext uri="{FF2B5EF4-FFF2-40B4-BE49-F238E27FC236}">
-                <a16:creationId xmlns:a16="http://schemas.microsoft.com/office/drawing/2014/main" id="{E7891B24-8AD0-4733-99FE-7AB555066D75}"/>
+                <a16:creationId xmlns:a16="http://schemas.microsoft.com/office/drawing/2014/main" id="{87F7A8FD-7A00-4D94-A55F-AD9C82C16BE9}"/>
               </a:ext>
             </a:extLst>
           </p:cNvPr>
@@ -9038,7 +9590,7 @@
           <p:cNvPr id="11" name="">
             <a:extLst xmlns:a="http://schemas.openxmlformats.org/drawingml/2006/main">
               <a:ext uri="{FF2B5EF4-FFF2-40B4-BE49-F238E27FC236}">
-                <a16:creationId xmlns:a16="http://schemas.microsoft.com/office/drawing/2014/main" id="{E354170F-99E0-4FEB-B3A4-3DFB8EA6AC84}"/>
+                <a16:creationId xmlns:a16="http://schemas.microsoft.com/office/drawing/2014/main" id="{69667BB4-478D-4B91-B37A-C879C653982F}"/>
               </a:ext>
             </a:extLst>
           </p:cNvPr>
@@ -9069,7 +9621,7 @@
           <p:cNvPr id="12" name="">
             <a:extLst xmlns:a="http://schemas.openxmlformats.org/drawingml/2006/main">
               <a:ext uri="{FF2B5EF4-FFF2-40B4-BE49-F238E27FC236}">
-                <a16:creationId xmlns:a16="http://schemas.microsoft.com/office/drawing/2014/main" id="{5B8E8B0D-8E83-4DCD-823C-348E8AA246E3}"/>
+                <a16:creationId xmlns:a16="http://schemas.microsoft.com/office/drawing/2014/main" id="{583C3CAD-215B-4C7E-95CA-534F84BBA4B2}"/>
               </a:ext>
             </a:extLst>
           </p:cNvPr>
@@ -9119,7 +9671,7 @@
           <p:cNvPr id="13" name="">
             <a:extLst xmlns:a="http://schemas.openxmlformats.org/drawingml/2006/main">
               <a:ext uri="{FF2B5EF4-FFF2-40B4-BE49-F238E27FC236}">
-                <a16:creationId xmlns:a16="http://schemas.microsoft.com/office/drawing/2014/main" id="{69FFA07D-00E8-478B-981E-D5DD6818F523}"/>
+                <a16:creationId xmlns:a16="http://schemas.microsoft.com/office/drawing/2014/main" id="{61411AF7-8216-422C-ABA6-6EC3C3190D43}"/>
               </a:ext>
             </a:extLst>
           </p:cNvPr>
@@ -9169,7 +9721,7 @@
           <p:cNvPr id="14" name="">
             <a:extLst xmlns:a="http://schemas.openxmlformats.org/drawingml/2006/main">
               <a:ext uri="{FF2B5EF4-FFF2-40B4-BE49-F238E27FC236}">
-                <a16:creationId xmlns:a16="http://schemas.microsoft.com/office/drawing/2014/main" id="{33C2F701-E3B1-490E-883A-E3D51E1F0A63}"/>
+                <a16:creationId xmlns:a16="http://schemas.microsoft.com/office/drawing/2014/main" id="{D6298A37-42FB-428B-BCCB-B3D41C12E18B}"/>
               </a:ext>
             </a:extLst>
           </p:cNvPr>
@@ -9200,7 +9752,7 @@
           <p:cNvPr id="15" name="">
             <a:extLst xmlns:a="http://schemas.openxmlformats.org/drawingml/2006/main">
               <a:ext uri="{FF2B5EF4-FFF2-40B4-BE49-F238E27FC236}">
-                <a16:creationId xmlns:a16="http://schemas.microsoft.com/office/drawing/2014/main" id="{FDC56EB1-4D69-44F3-8C01-AB6C32BACDDA}"/>
+                <a16:creationId xmlns:a16="http://schemas.microsoft.com/office/drawing/2014/main" id="{8E817958-1921-42BB-BDD0-78B7CBAAAA85}"/>
               </a:ext>
             </a:extLst>
           </p:cNvPr>
@@ -9250,7 +9802,7 @@
           <p:cNvPr id="16" name="">
             <a:extLst xmlns:a="http://schemas.openxmlformats.org/drawingml/2006/main">
               <a:ext uri="{FF2B5EF4-FFF2-40B4-BE49-F238E27FC236}">
-                <a16:creationId xmlns:a16="http://schemas.microsoft.com/office/drawing/2014/main" id="{0279DF14-021E-4B4A-A41E-67B752E01414}"/>
+                <a16:creationId xmlns:a16="http://schemas.microsoft.com/office/drawing/2014/main" id="{062062DC-BDF7-479D-B2CB-D95BECB7806B}"/>
               </a:ext>
             </a:extLst>
           </p:cNvPr>
@@ -9300,7 +9852,7 @@
           <p:cNvPr id="17" name="">
             <a:extLst xmlns:a="http://schemas.openxmlformats.org/drawingml/2006/main">
               <a:ext uri="{FF2B5EF4-FFF2-40B4-BE49-F238E27FC236}">
-                <a16:creationId xmlns:a16="http://schemas.microsoft.com/office/drawing/2014/main" id="{4BA67A26-2DF6-4DE1-9667-AF7F6FC815F0}"/>
+                <a16:creationId xmlns:a16="http://schemas.microsoft.com/office/drawing/2014/main" id="{B0D1432D-8EDB-41FF-A9A9-F553EB5CD3BC}"/>
               </a:ext>
             </a:extLst>
           </p:cNvPr>
@@ -9331,7 +9883,7 @@
           <p:cNvPr id="18" name="">
             <a:extLst xmlns:a="http://schemas.openxmlformats.org/drawingml/2006/main">
               <a:ext uri="{FF2B5EF4-FFF2-40B4-BE49-F238E27FC236}">
-                <a16:creationId xmlns:a16="http://schemas.microsoft.com/office/drawing/2014/main" id="{2F3244D9-686A-46CE-8872-06E1753B328B}"/>
+                <a16:creationId xmlns:a16="http://schemas.microsoft.com/office/drawing/2014/main" id="{79F48511-5788-4AE2-A1F6-77603B91E7F8}"/>
               </a:ext>
             </a:extLst>
           </p:cNvPr>
@@ -9381,7 +9933,7 @@
           <p:cNvPr id="19" name="">
             <a:extLst xmlns:a="http://schemas.openxmlformats.org/drawingml/2006/main">
               <a:ext uri="{FF2B5EF4-FFF2-40B4-BE49-F238E27FC236}">
-                <a16:creationId xmlns:a16="http://schemas.microsoft.com/office/drawing/2014/main" id="{4DC856E2-2691-4137-B578-BB3539025ED8}"/>
+                <a16:creationId xmlns:a16="http://schemas.microsoft.com/office/drawing/2014/main" id="{D861D6CD-0C58-4127-87E7-942FA90EA6D3}"/>
               </a:ext>
             </a:extLst>
           </p:cNvPr>
@@ -9431,7 +9983,7 @@
           <p:cNvPr id="20" name="">
             <a:extLst xmlns:a="http://schemas.openxmlformats.org/drawingml/2006/main">
               <a:ext uri="{FF2B5EF4-FFF2-40B4-BE49-F238E27FC236}">
-                <a16:creationId xmlns:a16="http://schemas.microsoft.com/office/drawing/2014/main" id="{5D5C44E4-8C4E-456D-8B2B-9B3C42EE40EB}"/>
+                <a16:creationId xmlns:a16="http://schemas.microsoft.com/office/drawing/2014/main" id="{904229F2-1E54-4DEC-BEA9-76E6893E4AEB}"/>
               </a:ext>
             </a:extLst>
           </p:cNvPr>
@@ -9462,7 +10014,7 @@
           <p:cNvPr id="21" name="">
             <a:extLst xmlns:a="http://schemas.openxmlformats.org/drawingml/2006/main">
               <a:ext uri="{FF2B5EF4-FFF2-40B4-BE49-F238E27FC236}">
-                <a16:creationId xmlns:a16="http://schemas.microsoft.com/office/drawing/2014/main" id="{490AF7DF-F03A-4001-A9C9-6DD6E11622A9}"/>
+                <a16:creationId xmlns:a16="http://schemas.microsoft.com/office/drawing/2014/main" id="{A17EA9B5-7D02-4AFE-B64F-92021AFA812D}"/>
               </a:ext>
             </a:extLst>
           </p:cNvPr>
@@ -9512,7 +10064,7 @@
           <p:cNvPr id="22" name="">
             <a:extLst xmlns:a="http://schemas.openxmlformats.org/drawingml/2006/main">
               <a:ext uri="{FF2B5EF4-FFF2-40B4-BE49-F238E27FC236}">
-                <a16:creationId xmlns:a16="http://schemas.microsoft.com/office/drawing/2014/main" id="{455CE806-4106-4FC2-A717-BE3FE422406B}"/>
+                <a16:creationId xmlns:a16="http://schemas.microsoft.com/office/drawing/2014/main" id="{16A28B13-BC8A-460F-8A0D-885BFA560BFF}"/>
               </a:ext>
             </a:extLst>
           </p:cNvPr>
@@ -9562,7 +10114,7 @@
           <p:cNvPr id="23" name="">
             <a:extLst xmlns:a="http://schemas.openxmlformats.org/drawingml/2006/main">
               <a:ext uri="{FF2B5EF4-FFF2-40B4-BE49-F238E27FC236}">
-                <a16:creationId xmlns:a16="http://schemas.microsoft.com/office/drawing/2014/main" id="{9B591675-9CD5-4614-B8FA-5FE277EB3C92}"/>
+                <a16:creationId xmlns:a16="http://schemas.microsoft.com/office/drawing/2014/main" id="{E0540335-D110-4A54-9BDD-59AA011F6767}"/>
               </a:ext>
             </a:extLst>
           </p:cNvPr>
@@ -9597,7 +10149,7 @@
           <p:cNvPr id="24" name="">
             <a:extLst xmlns:a="http://schemas.openxmlformats.org/drawingml/2006/main">
               <a:ext uri="{FF2B5EF4-FFF2-40B4-BE49-F238E27FC236}">
-                <a16:creationId xmlns:a16="http://schemas.microsoft.com/office/drawing/2014/main" id="{7BB06391-8097-4528-9180-10D6EF0B4879}"/>
+                <a16:creationId xmlns:a16="http://schemas.microsoft.com/office/drawing/2014/main" id="{C648721D-0736-43B0-BF8F-9F72F89E046F}"/>
               </a:ext>
             </a:extLst>
           </p:cNvPr>
@@ -9647,7 +10199,7 @@
           <p:cNvPr id="25" name="">
             <a:extLst xmlns:a="http://schemas.openxmlformats.org/drawingml/2006/main">
               <a:ext uri="{FF2B5EF4-FFF2-40B4-BE49-F238E27FC236}">
-                <a16:creationId xmlns:a16="http://schemas.microsoft.com/office/drawing/2014/main" id="{16B6DFBA-1590-4668-A350-98C9797A52CC}"/>
+                <a16:creationId xmlns:a16="http://schemas.microsoft.com/office/drawing/2014/main" id="{07696D39-B275-4C7E-A36D-4A59847AD489}"/>
               </a:ext>
             </a:extLst>
           </p:cNvPr>
@@ -9678,7 +10230,7 @@
           <p:cNvPr id="26" name="">
             <a:extLst xmlns:a="http://schemas.openxmlformats.org/drawingml/2006/main">
               <a:ext uri="{FF2B5EF4-FFF2-40B4-BE49-F238E27FC236}">
-                <a16:creationId xmlns:a16="http://schemas.microsoft.com/office/drawing/2014/main" id="{2B1A0AA8-B2D5-46E1-A954-6CDE621AC48E}"/>
+                <a16:creationId xmlns:a16="http://schemas.microsoft.com/office/drawing/2014/main" id="{A61713EA-A5A0-4A44-A929-0597131F8301}"/>
               </a:ext>
             </a:extLst>
           </p:cNvPr>
@@ -9728,7 +10280,7 @@
           <p:cNvPr id="27" name="">
             <a:extLst xmlns:a="http://schemas.openxmlformats.org/drawingml/2006/main">
               <a:ext uri="{FF2B5EF4-FFF2-40B4-BE49-F238E27FC236}">
-                <a16:creationId xmlns:a16="http://schemas.microsoft.com/office/drawing/2014/main" id="{FE76C26F-10CF-4641-BD40-3679DD23AD28}"/>
+                <a16:creationId xmlns:a16="http://schemas.microsoft.com/office/drawing/2014/main" id="{077CE782-B0E5-49C4-B9C5-DCAE78F9847E}"/>
               </a:ext>
             </a:extLst>
           </p:cNvPr>
@@ -9778,7 +10330,7 @@
           <p:cNvPr id="28" name="">
             <a:extLst xmlns:a="http://schemas.openxmlformats.org/drawingml/2006/main">
               <a:ext uri="{FF2B5EF4-FFF2-40B4-BE49-F238E27FC236}">
-                <a16:creationId xmlns:a16="http://schemas.microsoft.com/office/drawing/2014/main" id="{BA63F7F1-50FC-4F20-8FCD-E78DAFB5745E}"/>
+                <a16:creationId xmlns:a16="http://schemas.microsoft.com/office/drawing/2014/main" id="{A4326A46-8D65-45BC-84AD-6F7A8F9CC3BD}"/>
               </a:ext>
             </a:extLst>
           </p:cNvPr>
@@ -9809,7 +10361,7 @@
           <p:cNvPr id="29" name="">
             <a:extLst xmlns:a="http://schemas.openxmlformats.org/drawingml/2006/main">
               <a:ext uri="{FF2B5EF4-FFF2-40B4-BE49-F238E27FC236}">
-                <a16:creationId xmlns:a16="http://schemas.microsoft.com/office/drawing/2014/main" id="{E471005A-DAEF-45E0-BD4D-67A3457E18B1}"/>
+                <a16:creationId xmlns:a16="http://schemas.microsoft.com/office/drawing/2014/main" id="{29BD84D9-BBD3-4FF8-B48B-D3BE9B5AB02A}"/>
               </a:ext>
             </a:extLst>
           </p:cNvPr>
@@ -9859,7 +10411,7 @@
           <p:cNvPr id="30" name="">
             <a:extLst xmlns:a="http://schemas.openxmlformats.org/drawingml/2006/main">
               <a:ext uri="{FF2B5EF4-FFF2-40B4-BE49-F238E27FC236}">
-                <a16:creationId xmlns:a16="http://schemas.microsoft.com/office/drawing/2014/main" id="{E2FCEC46-9FB6-4569-ACD0-FB5E79AC3B82}"/>
+                <a16:creationId xmlns:a16="http://schemas.microsoft.com/office/drawing/2014/main" id="{53D37644-3759-4F71-B08A-D003F2375865}"/>
               </a:ext>
             </a:extLst>
           </p:cNvPr>
@@ -9909,7 +10461,7 @@
           <p:cNvPr id="31" name="">
             <a:extLst xmlns:a="http://schemas.openxmlformats.org/drawingml/2006/main">
               <a:ext uri="{FF2B5EF4-FFF2-40B4-BE49-F238E27FC236}">
-                <a16:creationId xmlns:a16="http://schemas.microsoft.com/office/drawing/2014/main" id="{BC6CC5FC-EEB0-40ED-AB2B-39980656DB66}"/>
+                <a16:creationId xmlns:a16="http://schemas.microsoft.com/office/drawing/2014/main" id="{11C6F735-ED2C-4787-BD84-6D5D545B0049}"/>
               </a:ext>
             </a:extLst>
           </p:cNvPr>
@@ -9940,7 +10492,7 @@
           <p:cNvPr id="32" name="">
             <a:extLst xmlns:a="http://schemas.openxmlformats.org/drawingml/2006/main">
               <a:ext uri="{FF2B5EF4-FFF2-40B4-BE49-F238E27FC236}">
-                <a16:creationId xmlns:a16="http://schemas.microsoft.com/office/drawing/2014/main" id="{AE14EE5E-C390-4570-9DBE-F64BEBDAC8E9}"/>
+                <a16:creationId xmlns:a16="http://schemas.microsoft.com/office/drawing/2014/main" id="{756AAE55-B598-4C2C-BE21-5ECBB4349094}"/>
               </a:ext>
             </a:extLst>
           </p:cNvPr>
@@ -9990,7 +10542,7 @@
           <p:cNvPr id="33" name="">
             <a:extLst xmlns:a="http://schemas.openxmlformats.org/drawingml/2006/main">
               <a:ext uri="{FF2B5EF4-FFF2-40B4-BE49-F238E27FC236}">
-                <a16:creationId xmlns:a16="http://schemas.microsoft.com/office/drawing/2014/main" id="{8B0690A4-8C2F-4A7E-8FC3-A0815285E185}"/>
+                <a16:creationId xmlns:a16="http://schemas.microsoft.com/office/drawing/2014/main" id="{8AE14441-5306-4DAA-B336-141803B0835B}"/>
               </a:ext>
             </a:extLst>
           </p:cNvPr>
@@ -10040,7 +10592,7 @@
           <p:cNvPr id="34" name="">
             <a:extLst xmlns:a="http://schemas.openxmlformats.org/drawingml/2006/main">
               <a:ext uri="{FF2B5EF4-FFF2-40B4-BE49-F238E27FC236}">
-                <a16:creationId xmlns:a16="http://schemas.microsoft.com/office/drawing/2014/main" id="{9298C0C6-C550-4EE3-815E-E0C88F42EAB0}"/>
+                <a16:creationId xmlns:a16="http://schemas.microsoft.com/office/drawing/2014/main" id="{97F6D7D8-F1AD-4946-B743-E4F6B36DDD61}"/>
               </a:ext>
             </a:extLst>
           </p:cNvPr>
@@ -10073,7 +10625,7 @@
           <p:cNvPr id="35" name="">
             <a:extLst xmlns:a="http://schemas.openxmlformats.org/drawingml/2006/main">
               <a:ext uri="{FF2B5EF4-FFF2-40B4-BE49-F238E27FC236}">
-                <a16:creationId xmlns:a16="http://schemas.microsoft.com/office/drawing/2014/main" id="{7ACB5A51-56E9-460E-BFA7-F59EFCFDEC88}"/>
+                <a16:creationId xmlns:a16="http://schemas.microsoft.com/office/drawing/2014/main" id="{1C60C101-A915-4F15-A9E4-BEF7F0CB2018}"/>
               </a:ext>
             </a:extLst>
           </p:cNvPr>
@@ -10121,7 +10673,7 @@
     </p:spTree>
     <p:extLst>
       <p:ext uri="{BB962C8B-B14F-4D97-AF65-F5344CB8AC3E}">
-        <p14:creationId xmlns:p14="http://schemas.microsoft.com/office/powerpoint/2010/main" val="1428828932"/>
+        <p14:creationId xmlns:p14="http://schemas.microsoft.com/office/powerpoint/2010/main" val="429661009"/>
       </p:ext>
     </p:extLst>
   </p:cSld>

</xml_diff>

<commit_message>
Clarify CFD slide 3 boundary visuals
</commit_message>
<xml_diff>
--- a/references/cfd.pptx
+++ b/references/cfd.pptx
@@ -2,20 +2,20 @@
 <file path=ppt/presentation.xml><?xml version="1.0" encoding="utf-8"?>
 <p:presentation xmlns:p="http://schemas.openxmlformats.org/presentationml/2006/main">
   <p:sldMasterIdLst>
-    <p:sldMasterId xmlns:r="http://schemas.openxmlformats.org/officeDocument/2006/relationships" id="2147483648" r:id="Rd52d1fdcc9a54afd"/>
+    <p:sldMasterId xmlns:r="http://schemas.openxmlformats.org/officeDocument/2006/relationships" id="2147483648" r:id="Rbab8f14c63b4488f"/>
   </p:sldMasterIdLst>
   <p:notesMasterIdLst>
-    <p:notesMasterId xmlns:r="http://schemas.openxmlformats.org/officeDocument/2006/relationships" r:id="Rd6465588ac30467c"/>
+    <p:notesMasterId xmlns:r="http://schemas.openxmlformats.org/officeDocument/2006/relationships" r:id="R2828f5a6f8d4417c"/>
   </p:notesMasterIdLst>
   <p:sldIdLst>
-    <p:sldId xmlns:r="http://schemas.openxmlformats.org/officeDocument/2006/relationships" id="256" r:id="R08e9d7bf483d483b"/>
-    <p:sldId xmlns:r="http://schemas.openxmlformats.org/officeDocument/2006/relationships" id="257" r:id="Rdbcd0e9241104e90"/>
-    <p:sldId xmlns:r="http://schemas.openxmlformats.org/officeDocument/2006/relationships" id="258" r:id="R7506b929b3b84edd"/>
-    <p:sldId xmlns:r="http://schemas.openxmlformats.org/officeDocument/2006/relationships" id="259" r:id="Rf150c493c81e4ad1"/>
-    <p:sldId xmlns:r="http://schemas.openxmlformats.org/officeDocument/2006/relationships" id="260" r:id="Re2bd0c908b854658"/>
-    <p:sldId xmlns:r="http://schemas.openxmlformats.org/officeDocument/2006/relationships" id="261" r:id="Rb7b41bc4264a4420"/>
-    <p:sldId xmlns:r="http://schemas.openxmlformats.org/officeDocument/2006/relationships" id="262" r:id="R891fe0c576c043a0"/>
-    <p:sldId xmlns:r="http://schemas.openxmlformats.org/officeDocument/2006/relationships" id="263" r:id="R573237f4f3cb49de"/>
+    <p:sldId xmlns:r="http://schemas.openxmlformats.org/officeDocument/2006/relationships" id="256" r:id="Rb136236c3acb4bf3"/>
+    <p:sldId xmlns:r="http://schemas.openxmlformats.org/officeDocument/2006/relationships" id="257" r:id="R550075d9898d40ae"/>
+    <p:sldId xmlns:r="http://schemas.openxmlformats.org/officeDocument/2006/relationships" id="258" r:id="Rc42772b8e98f4eed"/>
+    <p:sldId xmlns:r="http://schemas.openxmlformats.org/officeDocument/2006/relationships" id="259" r:id="R0c66861576ba480f"/>
+    <p:sldId xmlns:r="http://schemas.openxmlformats.org/officeDocument/2006/relationships" id="260" r:id="Ra8bd56505316424b"/>
+    <p:sldId xmlns:r="http://schemas.openxmlformats.org/officeDocument/2006/relationships" id="261" r:id="R7b941b13372a4d46"/>
+    <p:sldId xmlns:r="http://schemas.openxmlformats.org/officeDocument/2006/relationships" id="262" r:id="Rbd0d565dd93a4c9e"/>
+    <p:sldId xmlns:r="http://schemas.openxmlformats.org/officeDocument/2006/relationships" id="263" r:id="Rb955ea014dea4736"/>
   </p:sldIdLst>
   <p:sldSz cx="12192000" cy="6858000"/>
   <p:notesSz cx="6858000" cy="9144000"/>
@@ -1177,7 +1177,7 @@
   </p:cSld>
   <p:clrMap bg1="lt1" tx1="dk1" bg2="lt2" tx2="dk2" accent1="accent1" accent2="accent2" accent3="accent3" accent4="accent4" accent5="accent5" accent6="accent6" hlink="hlink" folHlink="folHlink"/>
   <p:sldLayoutIdLst>
-    <p:sldLayoutId xmlns:r="http://schemas.openxmlformats.org/officeDocument/2006/relationships" id="2147483649" r:id="R35aa52cb7b444609"/>
+    <p:sldLayoutId xmlns:r="http://schemas.openxmlformats.org/officeDocument/2006/relationships" id="2147483649" r:id="R87092b578ad34723"/>
   </p:sldLayoutIdLst>
   <p:txStyles>
     <p:titleStyle>
@@ -1993,6 +1993,7 @@
           <a:lstStyle xmlns:a="http://schemas.openxmlformats.org/drawingml/2006/main"/>
           <a:p xmlns:a="http://schemas.openxmlformats.org/drawingml/2006/main">
             <a:pPr algn="l">
+              <a:buNone/>
               <a:defRPr sz="900" b="1">
                 <a:solidFill>
                   <a:srgbClr val="2A7F76"/>
@@ -2043,6 +2044,7 @@
           <a:lstStyle xmlns:a="http://schemas.openxmlformats.org/drawingml/2006/main"/>
           <a:p xmlns:a="http://schemas.openxmlformats.org/drawingml/2006/main">
             <a:pPr algn="l">
+              <a:buNone/>
               <a:defRPr sz="3600" b="1">
                 <a:solidFill>
                   <a:srgbClr val="1F2933"/>
@@ -2093,6 +2095,7 @@
           <a:lstStyle xmlns:a="http://schemas.openxmlformats.org/drawingml/2006/main"/>
           <a:p xmlns:a="http://schemas.openxmlformats.org/drawingml/2006/main">
             <a:pPr algn="l">
+              <a:buNone/>
               <a:defRPr sz="1575" b="0">
                 <a:solidFill>
                   <a:srgbClr val="66747E"/>
@@ -2174,6 +2177,7 @@
           <a:lstStyle xmlns:a="http://schemas.openxmlformats.org/drawingml/2006/main"/>
           <a:p xmlns:a="http://schemas.openxmlformats.org/drawingml/2006/main">
             <a:pPr algn="l">
+              <a:buNone/>
               <a:defRPr sz="1275" b="1">
                 <a:solidFill>
                   <a:srgbClr val="163A5F"/>
@@ -2228,14 +2232,14 @@
       </p:sp>
       <p:pic>
         <p:nvPicPr>
-          <p:cNvPr id="17" name=""/>
+          <p:cNvPr id="19" name=""/>
           <p:cNvPicPr>
             <a:picLocks xmlns:a="http://schemas.openxmlformats.org/drawingml/2006/main" noChangeAspect="1"/>
           </p:cNvPicPr>
           <p:nvPr/>
         </p:nvPicPr>
         <p:blipFill>
-          <a:blip xmlns:r="http://schemas.openxmlformats.org/officeDocument/2006/relationships" xmlns:a="http://schemas.openxmlformats.org/drawingml/2006/main" r:embed="Rf37e854226a24cf0"/>
+          <a:blip xmlns:r="http://schemas.openxmlformats.org/officeDocument/2006/relationships" xmlns:a="http://schemas.openxmlformats.org/drawingml/2006/main" r:embed="R4acad348f74f4afb"/>
           <a:stretch xmlns:a="http://schemas.openxmlformats.org/drawingml/2006/main"/>
         </p:blipFill>
         <p:spPr>
@@ -2281,6 +2285,7 @@
           <a:lstStyle xmlns:a="http://schemas.openxmlformats.org/drawingml/2006/main"/>
           <a:p xmlns:a="http://schemas.openxmlformats.org/drawingml/2006/main">
             <a:pPr algn="r">
+              <a:buNone/>
               <a:defRPr sz="825" b="0">
                 <a:solidFill>
                   <a:srgbClr val="66747E"/>
@@ -2360,6 +2365,7 @@
           <a:lstStyle xmlns:a="http://schemas.openxmlformats.org/drawingml/2006/main"/>
           <a:p xmlns:a="http://schemas.openxmlformats.org/drawingml/2006/main">
             <a:pPr algn="l">
+              <a:buNone/>
               <a:defRPr sz="2400" b="1">
                 <a:solidFill>
                   <a:srgbClr val="1F2933"/>
@@ -2410,6 +2416,7 @@
           <a:lstStyle xmlns:a="http://schemas.openxmlformats.org/drawingml/2006/main"/>
           <a:p xmlns:a="http://schemas.openxmlformats.org/drawingml/2006/main">
             <a:pPr algn="r">
+              <a:buNone/>
               <a:defRPr sz="900" b="1">
                 <a:solidFill>
                   <a:srgbClr val="2A7F76"/>
@@ -2522,6 +2529,7 @@
           <a:lstStyle xmlns:a="http://schemas.openxmlformats.org/drawingml/2006/main"/>
           <a:p xmlns:a="http://schemas.openxmlformats.org/drawingml/2006/main">
             <a:pPr algn="r">
+              <a:buNone/>
               <a:defRPr sz="825" b="0">
                 <a:solidFill>
                   <a:srgbClr val="66747E"/>
@@ -2638,6 +2646,7 @@
           <a:lstStyle xmlns:a="http://schemas.openxmlformats.org/drawingml/2006/main"/>
           <a:p xmlns:a="http://schemas.openxmlformats.org/drawingml/2006/main">
             <a:pPr algn="l">
+              <a:buNone/>
               <a:defRPr sz="1050" b="1">
                 <a:solidFill>
                   <a:srgbClr val="2A7F76"/>
@@ -2688,6 +2697,7 @@
           <a:lstStyle xmlns:a="http://schemas.openxmlformats.org/drawingml/2006/main"/>
           <a:p xmlns:a="http://schemas.openxmlformats.org/drawingml/2006/main">
             <a:pPr algn="l">
+              <a:buNone/>
               <a:defRPr sz="1650" b="1">
                 <a:solidFill>
                   <a:srgbClr val="1F2933"/>
@@ -2740,14 +2750,14 @@
       </p:sp>
       <p:pic>
         <p:nvPicPr>
-          <p:cNvPr id="40" name=""/>
+          <p:cNvPr id="102" name=""/>
           <p:cNvPicPr>
             <a:picLocks xmlns:a="http://schemas.openxmlformats.org/drawingml/2006/main" noChangeAspect="1"/>
           </p:cNvPicPr>
           <p:nvPr/>
         </p:nvPicPr>
         <p:blipFill>
-          <a:blip xmlns:r="http://schemas.openxmlformats.org/officeDocument/2006/relationships" xmlns:a="http://schemas.openxmlformats.org/drawingml/2006/main" r:embed="R06ef710f93674f05"/>
+          <a:blip xmlns:r="http://schemas.openxmlformats.org/officeDocument/2006/relationships" xmlns:a="http://schemas.openxmlformats.org/drawingml/2006/main" r:embed="Rc91bd1670a1c4c30"/>
           <a:stretch xmlns:a="http://schemas.openxmlformats.org/drawingml/2006/main"/>
         </p:blipFill>
         <p:spPr>
@@ -2793,6 +2803,7 @@
           <a:lstStyle xmlns:a="http://schemas.openxmlformats.org/drawingml/2006/main"/>
           <a:p xmlns:a="http://schemas.openxmlformats.org/drawingml/2006/main">
             <a:pPr algn="l">
+              <a:buNone/>
               <a:defRPr sz="1275" b="0">
                 <a:solidFill>
                   <a:srgbClr val="66747E"/>
@@ -2909,6 +2920,7 @@
           <a:lstStyle xmlns:a="http://schemas.openxmlformats.org/drawingml/2006/main"/>
           <a:p xmlns:a="http://schemas.openxmlformats.org/drawingml/2006/main">
             <a:pPr algn="l">
+              <a:buNone/>
               <a:defRPr sz="1050" b="1">
                 <a:solidFill>
                   <a:srgbClr val="2A7F76"/>
@@ -2959,6 +2971,7 @@
           <a:lstStyle xmlns:a="http://schemas.openxmlformats.org/drawingml/2006/main"/>
           <a:p xmlns:a="http://schemas.openxmlformats.org/drawingml/2006/main">
             <a:pPr algn="l">
+              <a:buNone/>
               <a:defRPr sz="1650" b="1">
                 <a:solidFill>
                   <a:srgbClr val="1F2933"/>
@@ -3011,14 +3024,14 @@
       </p:sp>
       <p:pic>
         <p:nvPicPr>
-          <p:cNvPr id="47" name=""/>
+          <p:cNvPr id="109" name=""/>
           <p:cNvPicPr>
             <a:picLocks xmlns:a="http://schemas.openxmlformats.org/drawingml/2006/main" noChangeAspect="1"/>
           </p:cNvPicPr>
           <p:nvPr/>
         </p:nvPicPr>
         <p:blipFill>
-          <a:blip xmlns:r="http://schemas.openxmlformats.org/officeDocument/2006/relationships" xmlns:a="http://schemas.openxmlformats.org/drawingml/2006/main" r:embed="Rd2d00e27299a4632"/>
+          <a:blip xmlns:r="http://schemas.openxmlformats.org/officeDocument/2006/relationships" xmlns:a="http://schemas.openxmlformats.org/drawingml/2006/main" r:embed="R33614ffcab3e40d5"/>
           <a:stretch xmlns:a="http://schemas.openxmlformats.org/drawingml/2006/main"/>
         </p:blipFill>
         <p:spPr>
@@ -3064,6 +3077,7 @@
           <a:lstStyle xmlns:a="http://schemas.openxmlformats.org/drawingml/2006/main"/>
           <a:p xmlns:a="http://schemas.openxmlformats.org/drawingml/2006/main">
             <a:pPr algn="l">
+              <a:buNone/>
               <a:defRPr sz="1275" b="0">
                 <a:solidFill>
                   <a:srgbClr val="66747E"/>
@@ -3180,6 +3194,7 @@
           <a:lstStyle xmlns:a="http://schemas.openxmlformats.org/drawingml/2006/main"/>
           <a:p xmlns:a="http://schemas.openxmlformats.org/drawingml/2006/main">
             <a:pPr algn="l">
+              <a:buNone/>
               <a:defRPr sz="1050" b="1">
                 <a:solidFill>
                   <a:srgbClr val="2A7F76"/>
@@ -3230,6 +3245,7 @@
           <a:lstStyle xmlns:a="http://schemas.openxmlformats.org/drawingml/2006/main"/>
           <a:p xmlns:a="http://schemas.openxmlformats.org/drawingml/2006/main">
             <a:pPr algn="l">
+              <a:buNone/>
               <a:defRPr sz="1650" b="1">
                 <a:solidFill>
                   <a:srgbClr val="1F2933"/>
@@ -3282,14 +3298,14 @@
       </p:sp>
       <p:pic>
         <p:nvPicPr>
-          <p:cNvPr id="54" name=""/>
+          <p:cNvPr id="116" name=""/>
           <p:cNvPicPr>
             <a:picLocks xmlns:a="http://schemas.openxmlformats.org/drawingml/2006/main" noChangeAspect="1"/>
           </p:cNvPicPr>
           <p:nvPr/>
         </p:nvPicPr>
         <p:blipFill>
-          <a:blip xmlns:r="http://schemas.openxmlformats.org/officeDocument/2006/relationships" xmlns:a="http://schemas.openxmlformats.org/drawingml/2006/main" r:embed="R0de50503837640a5"/>
+          <a:blip xmlns:r="http://schemas.openxmlformats.org/officeDocument/2006/relationships" xmlns:a="http://schemas.openxmlformats.org/drawingml/2006/main" r:embed="R88711e0bc3a1485d"/>
           <a:stretch xmlns:a="http://schemas.openxmlformats.org/drawingml/2006/main"/>
         </p:blipFill>
         <p:spPr>
@@ -3335,6 +3351,7 @@
           <a:lstStyle xmlns:a="http://schemas.openxmlformats.org/drawingml/2006/main"/>
           <a:p xmlns:a="http://schemas.openxmlformats.org/drawingml/2006/main">
             <a:pPr algn="l">
+              <a:buNone/>
               <a:defRPr sz="1275" b="0">
                 <a:solidFill>
                   <a:srgbClr val="66747E"/>
@@ -3354,7 +3371,7 @@
       </p:sp>
       <p:cxnSp>
         <p:nvCxnSpPr>
-          <p:cNvPr id="56" name=""/>
+          <p:cNvPr id="118" name=""/>
           <p:cNvCxnSpPr>
             <a:stCxn xmlns:a="http://schemas.openxmlformats.org/drawingml/2006/main" id="6" idx="3"/>
             <a:endCxn xmlns:a="http://schemas.openxmlformats.org/drawingml/2006/main" id="13" idx="1"/>
@@ -3380,7 +3397,7 @@
       </p:cxnSp>
       <p:cxnSp>
         <p:nvCxnSpPr>
-          <p:cNvPr id="57" name=""/>
+          <p:cNvPr id="119" name=""/>
           <p:cNvCxnSpPr>
             <a:stCxn xmlns:a="http://schemas.openxmlformats.org/drawingml/2006/main" id="13" idx="3"/>
             <a:endCxn xmlns:a="http://schemas.openxmlformats.org/drawingml/2006/main" id="20" idx="1"/>
@@ -3437,6 +3454,7 @@
           <a:lstStyle xmlns:a="http://schemas.openxmlformats.org/drawingml/2006/main"/>
           <a:p xmlns:a="http://schemas.openxmlformats.org/drawingml/2006/main">
             <a:pPr algn="l">
+              <a:buNone/>
               <a:defRPr sz="1125" b="1">
                 <a:solidFill>
                   <a:srgbClr val="163A5F"/>
@@ -3516,6 +3534,7 @@
           <a:lstStyle xmlns:a="http://schemas.openxmlformats.org/drawingml/2006/main"/>
           <a:p xmlns:a="http://schemas.openxmlformats.org/drawingml/2006/main">
             <a:pPr algn="l">
+              <a:buNone/>
               <a:defRPr sz="2400" b="1">
                 <a:solidFill>
                   <a:srgbClr val="1F2933"/>
@@ -3566,6 +3585,7 @@
           <a:lstStyle xmlns:a="http://schemas.openxmlformats.org/drawingml/2006/main"/>
           <a:p xmlns:a="http://schemas.openxmlformats.org/drawingml/2006/main">
             <a:pPr algn="r">
+              <a:buNone/>
               <a:defRPr sz="900" b="1">
                 <a:solidFill>
                   <a:srgbClr val="2A7F76"/>
@@ -3678,6 +3698,7 @@
           <a:lstStyle xmlns:a="http://schemas.openxmlformats.org/drawingml/2006/main"/>
           <a:p xmlns:a="http://schemas.openxmlformats.org/drawingml/2006/main">
             <a:pPr algn="r">
+              <a:buNone/>
               <a:defRPr sz="825" b="0">
                 <a:solidFill>
                   <a:srgbClr val="66747E"/>
@@ -3732,14 +3753,14 @@
       </p:sp>
       <p:pic>
         <p:nvPicPr>
-          <p:cNvPr id="39" name=""/>
+          <p:cNvPr id="42" name=""/>
           <p:cNvPicPr>
             <a:picLocks xmlns:a="http://schemas.openxmlformats.org/drawingml/2006/main" noChangeAspect="1"/>
           </p:cNvPicPr>
           <p:nvPr/>
         </p:nvPicPr>
         <p:blipFill>
-          <a:blip xmlns:r="http://schemas.openxmlformats.org/officeDocument/2006/relationships" xmlns:a="http://schemas.openxmlformats.org/drawingml/2006/main" r:embed="Rc25c206abcd747dc"/>
+          <a:blip xmlns:r="http://schemas.openxmlformats.org/officeDocument/2006/relationships" xmlns:a="http://schemas.openxmlformats.org/drawingml/2006/main" r:embed="Rac5e8b30be604551"/>
           <a:stretch xmlns:a="http://schemas.openxmlformats.org/drawingml/2006/main"/>
         </p:blipFill>
         <p:spPr>
@@ -3768,8 +3789,8 @@
         </p:nvSpPr>
         <p:spPr>
           <a:xfrm xmlns:a="http://schemas.openxmlformats.org/drawingml/2006/main">
-            <a:off x="723900" y="1390650"/>
-            <a:ext cx="1524000" cy="247650"/>
+            <a:off x="723900" y="1371600"/>
+            <a:ext cx="3762375" cy="285750"/>
           </a:xfrm>
           <a:prstGeom xmlns:a="http://schemas.openxmlformats.org/drawingml/2006/main" prst="rect">
             <a:avLst/>
@@ -3785,19 +3806,20 @@
           <a:lstStyle xmlns:a="http://schemas.openxmlformats.org/drawingml/2006/main"/>
           <a:p xmlns:a="http://schemas.openxmlformats.org/drawingml/2006/main">
             <a:pPr algn="l">
-              <a:defRPr sz="975" b="1">
+              <a:buNone/>
+              <a:defRPr sz="1125" b="1">
                 <a:solidFill>
                   <a:srgbClr val="163A5F"/>
                 </a:solidFill>
               </a:defRPr>
             </a:pPr>
             <a:r>
-              <a:rPr sz="975" b="1">
+              <a:rPr sz="1125" b="1">
                 <a:solidFill>
                   <a:srgbClr val="163A5F"/>
                 </a:solidFill>
               </a:rPr>
-              <a:t>Global network</a:t>
+              <a:t>Global network · color bar: pressure, p (Pa)</a:t>
             </a:r>
           </a:p>
         </p:txBody>
@@ -3839,20 +3861,21 @@
       </p:sp>
       <p:pic>
         <p:nvPicPr>
-          <p:cNvPr id="42" name=""/>
+          <p:cNvPr id="45" name=""/>
           <p:cNvPicPr>
             <a:picLocks xmlns:a="http://schemas.openxmlformats.org/drawingml/2006/main" noChangeAspect="1"/>
           </p:cNvPicPr>
           <p:nvPr/>
         </p:nvPicPr>
         <p:blipFill>
-          <a:blip xmlns:r="http://schemas.openxmlformats.org/officeDocument/2006/relationships" xmlns:a="http://schemas.openxmlformats.org/drawingml/2006/main" r:embed="Rf6fb36e636b54bf6"/>
+          <a:blip xmlns:r="http://schemas.openxmlformats.org/officeDocument/2006/relationships" xmlns:a="http://schemas.openxmlformats.org/drawingml/2006/main" r:embed="R24846038d4e04358"/>
+          <a:srcRect xmlns:a="http://schemas.openxmlformats.org/drawingml/2006/main" l="2000" t="8000" r="2000" b="10000"/>
           <a:stretch xmlns:a="http://schemas.openxmlformats.org/drawingml/2006/main"/>
         </p:blipFill>
         <p:spPr>
           <a:xfrm xmlns:a="http://schemas.openxmlformats.org/drawingml/2006/main">
-            <a:off x="1563103" y="3724275"/>
-            <a:ext cx="2931695" cy="2266950"/>
+            <a:off x="619125" y="3781425"/>
+            <a:ext cx="3333750" cy="2190750"/>
           </a:xfrm>
           <a:prstGeom xmlns:a="http://schemas.openxmlformats.org/drawingml/2006/main" prst="rect">
             <a:avLst/>
@@ -3875,8 +3898,8 @@
         </p:nvSpPr>
         <p:spPr>
           <a:xfrm xmlns:a="http://schemas.openxmlformats.org/drawingml/2006/main">
-            <a:off x="723900" y="3781425"/>
-            <a:ext cx="1524000" cy="247650"/>
+            <a:off x="4048125" y="3810000"/>
+            <a:ext cx="1381125" cy="2114550"/>
           </a:xfrm>
           <a:prstGeom xmlns:a="http://schemas.openxmlformats.org/drawingml/2006/main" prst="rect">
             <a:avLst/>
@@ -3892,19 +3915,110 @@
           <a:lstStyle xmlns:a="http://schemas.openxmlformats.org/drawingml/2006/main"/>
           <a:p xmlns:a="http://schemas.openxmlformats.org/drawingml/2006/main">
             <a:pPr algn="l">
-              <a:defRPr sz="975" b="1">
+              <a:buNone/>
+              <a:defRPr sz="1275" b="1">
                 <a:solidFill>
                   <a:srgbClr val="163A5F"/>
                 </a:solidFill>
               </a:defRPr>
             </a:pPr>
             <a:r>
-              <a:rPr sz="975" b="1">
+              <a:rPr sz="1275" b="1">
                 <a:solidFill>
                   <a:srgbClr val="163A5F"/>
                 </a:solidFill>
               </a:rPr>
               <a:t>Local ROI ports</a:t>
+            </a:r>
+          </a:p>
+          <a:p xmlns:a="http://schemas.openxmlformats.org/drawingml/2006/main">
+            <a:pPr algn="l">
+              <a:buNone/>
+              <a:defRPr sz="1275" b="1">
+                <a:solidFill>
+                  <a:srgbClr val="163A5F"/>
+                </a:solidFill>
+              </a:defRPr>
+            </a:pPr>
+            <a:r>
+              <a:rPr sz="1275" b="1">
+                <a:solidFill>
+                  <a:srgbClr val="163A5F"/>
+                </a:solidFill>
+              </a:rPr>
+              <a:t>Q [pL/s] · p [Pa]</a:t>
+            </a:r>
+          </a:p>
+          <a:p xmlns:a="http://schemas.openxmlformats.org/drawingml/2006/main">
+            <a:pPr algn="l">
+              <a:buNone/>
+              <a:defRPr sz="1275" b="1">
+                <a:solidFill>
+                  <a:srgbClr val="163A5F"/>
+                </a:solidFill>
+              </a:defRPr>
+            </a:pPr>
+            <a:r>
+              <a:rPr sz="1275" b="1">
+                <a:solidFill>
+                  <a:srgbClr val="163A5F"/>
+                </a:solidFill>
+              </a:rPr>
+              <a:t>IN   0.769 · 216</a:t>
+            </a:r>
+          </a:p>
+          <a:p xmlns:a="http://schemas.openxmlformats.org/drawingml/2006/main">
+            <a:pPr algn="l">
+              <a:buNone/>
+              <a:defRPr sz="1275" b="1">
+                <a:solidFill>
+                  <a:srgbClr val="163A5F"/>
+                </a:solidFill>
+              </a:defRPr>
+            </a:pPr>
+            <a:r>
+              <a:rPr sz="1275" b="1">
+                <a:solidFill>
+                  <a:srgbClr val="163A5F"/>
+                </a:solidFill>
+              </a:rPr>
+              <a:t>O1   0.0485 · 17</a:t>
+            </a:r>
+          </a:p>
+          <a:p xmlns:a="http://schemas.openxmlformats.org/drawingml/2006/main">
+            <a:pPr algn="l">
+              <a:buNone/>
+              <a:defRPr sz="1275" b="1">
+                <a:solidFill>
+                  <a:srgbClr val="163A5F"/>
+                </a:solidFill>
+              </a:defRPr>
+            </a:pPr>
+            <a:r>
+              <a:rPr sz="1275" b="1">
+                <a:solidFill>
+                  <a:srgbClr val="163A5F"/>
+                </a:solidFill>
+              </a:rPr>
+              <a:t>O2   0.382 · 152</a:t>
+            </a:r>
+          </a:p>
+          <a:p xmlns:a="http://schemas.openxmlformats.org/drawingml/2006/main">
+            <a:pPr algn="l">
+              <a:buNone/>
+              <a:defRPr sz="1275" b="1">
+                <a:solidFill>
+                  <a:srgbClr val="163A5F"/>
+                </a:solidFill>
+              </a:defRPr>
+            </a:pPr>
+            <a:r>
+              <a:rPr sz="1275" b="1">
+                <a:solidFill>
+                  <a:srgbClr val="163A5F"/>
+                </a:solidFill>
+              </a:rPr>
+              <a:t>O3   0.339 · 0</a:t>
             </a:r>
           </a:p>
         </p:txBody>
@@ -3977,6 +4091,7 @@
           <a:lstStyle xmlns:a="http://schemas.openxmlformats.org/drawingml/2006/main"/>
           <a:p xmlns:a="http://schemas.openxmlformats.org/drawingml/2006/main">
             <a:pPr algn="l">
+              <a:buNone/>
               <a:defRPr sz="1650" b="1">
                 <a:solidFill>
                   <a:srgbClr val="1F2933"/>
@@ -4058,6 +4173,7 @@
           <a:lstStyle xmlns:a="http://schemas.openxmlformats.org/drawingml/2006/main"/>
           <a:p xmlns:a="http://schemas.openxmlformats.org/drawingml/2006/main">
             <a:pPr algn="l">
+              <a:buNone/>
               <a:defRPr sz="1350" b="1">
                 <a:solidFill>
                   <a:srgbClr val="163A5F"/>
@@ -4108,6 +4224,7 @@
           <a:lstStyle xmlns:a="http://schemas.openxmlformats.org/drawingml/2006/main"/>
           <a:p xmlns:a="http://schemas.openxmlformats.org/drawingml/2006/main">
             <a:pPr algn="l">
+              <a:buNone/>
               <a:defRPr sz="1800" b="1">
                 <a:solidFill>
                   <a:srgbClr val="1F2933"/>
@@ -4158,6 +4275,7 @@
           <a:lstStyle xmlns:a="http://schemas.openxmlformats.org/drawingml/2006/main"/>
           <a:p xmlns:a="http://schemas.openxmlformats.org/drawingml/2006/main">
             <a:pPr algn="l">
+              <a:buNone/>
               <a:defRPr sz="1425" b="1">
                 <a:solidFill>
                   <a:srgbClr val="1F2933"/>
@@ -4208,6 +4326,7 @@
           <a:lstStyle xmlns:a="http://schemas.openxmlformats.org/drawingml/2006/main"/>
           <a:p xmlns:a="http://schemas.openxmlformats.org/drawingml/2006/main">
             <a:pPr algn="l">
+              <a:buNone/>
               <a:defRPr sz="1200" b="0">
                 <a:solidFill>
                   <a:srgbClr val="66747E"/>
@@ -4289,6 +4408,7 @@
           <a:lstStyle xmlns:a="http://schemas.openxmlformats.org/drawingml/2006/main"/>
           <a:p xmlns:a="http://schemas.openxmlformats.org/drawingml/2006/main">
             <a:pPr algn="l">
+              <a:buNone/>
               <a:defRPr sz="1350" b="1">
                 <a:solidFill>
                   <a:srgbClr val="2A7F76"/>
@@ -4339,6 +4459,7 @@
           <a:lstStyle xmlns:a="http://schemas.openxmlformats.org/drawingml/2006/main"/>
           <a:p xmlns:a="http://schemas.openxmlformats.org/drawingml/2006/main">
             <a:pPr algn="l">
+              <a:buNone/>
               <a:defRPr sz="1575" b="1">
                 <a:solidFill>
                   <a:srgbClr val="1F2933"/>
@@ -4389,6 +4510,7 @@
           <a:lstStyle xmlns:a="http://schemas.openxmlformats.org/drawingml/2006/main"/>
           <a:p xmlns:a="http://schemas.openxmlformats.org/drawingml/2006/main">
             <a:pPr algn="l">
+              <a:buNone/>
               <a:defRPr sz="1425" b="1">
                 <a:solidFill>
                   <a:srgbClr val="1F2933"/>
@@ -4439,6 +4561,7 @@
           <a:lstStyle xmlns:a="http://schemas.openxmlformats.org/drawingml/2006/main"/>
           <a:p xmlns:a="http://schemas.openxmlformats.org/drawingml/2006/main">
             <a:pPr algn="l">
+              <a:buNone/>
               <a:defRPr sz="1200" b="0">
                 <a:solidFill>
                   <a:srgbClr val="66747E"/>
@@ -4520,6 +4643,7 @@
           <a:lstStyle xmlns:a="http://schemas.openxmlformats.org/drawingml/2006/main"/>
           <a:p xmlns:a="http://schemas.openxmlformats.org/drawingml/2006/main">
             <a:pPr algn="l">
+              <a:buNone/>
               <a:defRPr sz="1350" b="1">
                 <a:solidFill>
                   <a:srgbClr val="009E73"/>
@@ -4570,6 +4694,7 @@
           <a:lstStyle xmlns:a="http://schemas.openxmlformats.org/drawingml/2006/main"/>
           <a:p xmlns:a="http://schemas.openxmlformats.org/drawingml/2006/main">
             <a:pPr algn="l">
+              <a:buNone/>
               <a:defRPr sz="975" b="1">
                 <a:solidFill>
                   <a:srgbClr val="D55E00"/>
@@ -4620,6 +4745,7 @@
           <a:lstStyle xmlns:a="http://schemas.openxmlformats.org/drawingml/2006/main"/>
           <a:p xmlns:a="http://schemas.openxmlformats.org/drawingml/2006/main">
             <a:pPr algn="l">
+              <a:buNone/>
               <a:defRPr sz="1275" b="1">
                 <a:solidFill>
                   <a:srgbClr val="1F2933"/>
@@ -4670,6 +4796,7 @@
           <a:lstStyle xmlns:a="http://schemas.openxmlformats.org/drawingml/2006/main"/>
           <a:p xmlns:a="http://schemas.openxmlformats.org/drawingml/2006/main">
             <a:pPr algn="l">
+              <a:buNone/>
               <a:defRPr sz="1200" b="0">
                 <a:solidFill>
                   <a:srgbClr val="66747E"/>
@@ -4720,6 +4847,7 @@
           <a:lstStyle xmlns:a="http://schemas.openxmlformats.org/drawingml/2006/main"/>
           <a:p xmlns:a="http://schemas.openxmlformats.org/drawingml/2006/main">
             <a:pPr algn="l">
+              <a:buNone/>
               <a:defRPr sz="975" b="1">
                 <a:solidFill>
                   <a:srgbClr val="0072B2"/>
@@ -4770,6 +4898,7 @@
           <a:lstStyle xmlns:a="http://schemas.openxmlformats.org/drawingml/2006/main"/>
           <a:p xmlns:a="http://schemas.openxmlformats.org/drawingml/2006/main">
             <a:pPr algn="l">
+              <a:buNone/>
               <a:defRPr sz="1275" b="1">
                 <a:solidFill>
                   <a:srgbClr val="1F2933"/>
@@ -4820,6 +4949,7 @@
           <a:lstStyle xmlns:a="http://schemas.openxmlformats.org/drawingml/2006/main"/>
           <a:p xmlns:a="http://schemas.openxmlformats.org/drawingml/2006/main">
             <a:pPr algn="l">
+              <a:buNone/>
               <a:defRPr sz="975" b="1">
                 <a:solidFill>
                   <a:srgbClr val="163A5F"/>
@@ -4870,6 +5000,7 @@
           <a:lstStyle xmlns:a="http://schemas.openxmlformats.org/drawingml/2006/main"/>
           <a:p xmlns:a="http://schemas.openxmlformats.org/drawingml/2006/main">
             <a:pPr algn="l">
+              <a:buNone/>
               <a:defRPr sz="1275" b="1">
                 <a:solidFill>
                   <a:srgbClr val="1F2933"/>
@@ -4949,6 +5080,7 @@
           <a:lstStyle xmlns:a="http://schemas.openxmlformats.org/drawingml/2006/main"/>
           <a:p xmlns:a="http://schemas.openxmlformats.org/drawingml/2006/main">
             <a:pPr algn="l">
+              <a:buNone/>
               <a:defRPr sz="2400" b="1">
                 <a:solidFill>
                   <a:srgbClr val="1F2933"/>
@@ -4999,6 +5131,7 @@
           <a:lstStyle xmlns:a="http://schemas.openxmlformats.org/drawingml/2006/main"/>
           <a:p xmlns:a="http://schemas.openxmlformats.org/drawingml/2006/main">
             <a:pPr algn="r">
+              <a:buNone/>
               <a:defRPr sz="900" b="1">
                 <a:solidFill>
                   <a:srgbClr val="2A7F76"/>
@@ -5111,6 +5244,7 @@
           <a:lstStyle xmlns:a="http://schemas.openxmlformats.org/drawingml/2006/main"/>
           <a:p xmlns:a="http://schemas.openxmlformats.org/drawingml/2006/main">
             <a:pPr algn="r">
+              <a:buNone/>
               <a:defRPr sz="825" b="0">
                 <a:solidFill>
                   <a:srgbClr val="66747E"/>
@@ -5165,14 +5299,14 @@
       </p:sp>
       <p:pic>
         <p:nvPicPr>
-          <p:cNvPr id="32" name=""/>
+          <p:cNvPr id="34" name=""/>
           <p:cNvPicPr>
             <a:picLocks xmlns:a="http://schemas.openxmlformats.org/drawingml/2006/main" noChangeAspect="1"/>
           </p:cNvPicPr>
           <p:nvPr/>
         </p:nvPicPr>
         <p:blipFill>
-          <a:blip xmlns:r="http://schemas.openxmlformats.org/officeDocument/2006/relationships" xmlns:a="http://schemas.openxmlformats.org/drawingml/2006/main" r:embed="Ra758dfdc999c4d08"/>
+          <a:blip xmlns:r="http://schemas.openxmlformats.org/officeDocument/2006/relationships" xmlns:a="http://schemas.openxmlformats.org/drawingml/2006/main" r:embed="Rcf5e65f9384b4c85"/>
           <a:stretch xmlns:a="http://schemas.openxmlformats.org/drawingml/2006/main"/>
         </p:blipFill>
         <p:spPr>
@@ -5218,6 +5352,7 @@
           <a:lstStyle xmlns:a="http://schemas.openxmlformats.org/drawingml/2006/main"/>
           <a:p xmlns:a="http://schemas.openxmlformats.org/drawingml/2006/main">
             <a:pPr algn="l">
+              <a:buNone/>
               <a:defRPr sz="1125" b="1">
                 <a:solidFill>
                   <a:srgbClr val="66747E"/>
@@ -5268,6 +5403,7 @@
           <a:lstStyle xmlns:a="http://schemas.openxmlformats.org/drawingml/2006/main"/>
           <a:p xmlns:a="http://schemas.openxmlformats.org/drawingml/2006/main">
             <a:pPr algn="l">
+              <a:buNone/>
               <a:defRPr sz="1125" b="1">
                 <a:solidFill>
                   <a:srgbClr val="2A7F76"/>
@@ -5384,6 +5520,7 @@
           <a:lstStyle xmlns:a="http://schemas.openxmlformats.org/drawingml/2006/main"/>
           <a:p xmlns:a="http://schemas.openxmlformats.org/drawingml/2006/main">
             <a:pPr algn="l">
+              <a:buNone/>
               <a:defRPr sz="1350" b="1">
                 <a:solidFill>
                   <a:srgbClr val="163A5F"/>
@@ -5434,6 +5571,7 @@
           <a:lstStyle xmlns:a="http://schemas.openxmlformats.org/drawingml/2006/main"/>
           <a:p xmlns:a="http://schemas.openxmlformats.org/drawingml/2006/main">
             <a:pPr algn="l">
+              <a:buNone/>
               <a:defRPr sz="1050" b="0">
                 <a:solidFill>
                   <a:srgbClr val="66747E"/>
@@ -5484,6 +5622,7 @@
           <a:lstStyle xmlns:a="http://schemas.openxmlformats.org/drawingml/2006/main"/>
           <a:p xmlns:a="http://schemas.openxmlformats.org/drawingml/2006/main">
             <a:pPr algn="l">
+              <a:buNone/>
               <a:defRPr sz="1350" b="1">
                 <a:solidFill>
                   <a:srgbClr val="2A7F76"/>
@@ -5534,6 +5673,7 @@
           <a:lstStyle xmlns:a="http://schemas.openxmlformats.org/drawingml/2006/main"/>
           <a:p xmlns:a="http://schemas.openxmlformats.org/drawingml/2006/main">
             <a:pPr algn="l">
+              <a:buNone/>
               <a:defRPr sz="1050" b="0">
                 <a:solidFill>
                   <a:srgbClr val="66747E"/>
@@ -5584,6 +5724,7 @@
           <a:lstStyle xmlns:a="http://schemas.openxmlformats.org/drawingml/2006/main"/>
           <a:p xmlns:a="http://schemas.openxmlformats.org/drawingml/2006/main">
             <a:pPr algn="l">
+              <a:buNone/>
               <a:defRPr sz="1350" b="1">
                 <a:solidFill>
                   <a:srgbClr val="1F2933"/>
@@ -5634,6 +5775,7 @@
           <a:lstStyle xmlns:a="http://schemas.openxmlformats.org/drawingml/2006/main"/>
           <a:p xmlns:a="http://schemas.openxmlformats.org/drawingml/2006/main">
             <a:pPr algn="l">
+              <a:buNone/>
               <a:defRPr sz="1050" b="0">
                 <a:solidFill>
                   <a:srgbClr val="66747E"/>
@@ -5715,6 +5857,7 @@
           <a:lstStyle xmlns:a="http://schemas.openxmlformats.org/drawingml/2006/main"/>
           <a:p xmlns:a="http://schemas.openxmlformats.org/drawingml/2006/main">
             <a:pPr algn="l">
+              <a:buNone/>
               <a:defRPr sz="825" b="0">
                 <a:solidFill>
                   <a:srgbClr val="66747E"/>
@@ -5796,6 +5939,7 @@
           <a:lstStyle xmlns:a="http://schemas.openxmlformats.org/drawingml/2006/main"/>
           <a:p xmlns:a="http://schemas.openxmlformats.org/drawingml/2006/main">
             <a:pPr algn="l">
+              <a:buNone/>
               <a:defRPr sz="825" b="0">
                 <a:solidFill>
                   <a:srgbClr val="66747E"/>
@@ -5877,6 +6021,7 @@
           <a:lstStyle xmlns:a="http://schemas.openxmlformats.org/drawingml/2006/main"/>
           <a:p xmlns:a="http://schemas.openxmlformats.org/drawingml/2006/main">
             <a:pPr algn="l">
+              <a:buNone/>
               <a:defRPr sz="825" b="0">
                 <a:solidFill>
                   <a:srgbClr val="66747E"/>
@@ -5958,6 +6103,7 @@
           <a:lstStyle xmlns:a="http://schemas.openxmlformats.org/drawingml/2006/main"/>
           <a:p xmlns:a="http://schemas.openxmlformats.org/drawingml/2006/main">
             <a:pPr algn="l">
+              <a:buNone/>
               <a:defRPr sz="825" b="0">
                 <a:solidFill>
                   <a:srgbClr val="66747E"/>
@@ -6037,6 +6183,7 @@
           <a:lstStyle xmlns:a="http://schemas.openxmlformats.org/drawingml/2006/main"/>
           <a:p xmlns:a="http://schemas.openxmlformats.org/drawingml/2006/main">
             <a:pPr algn="l">
+              <a:buNone/>
               <a:defRPr sz="2400" b="1">
                 <a:solidFill>
                   <a:srgbClr val="1F2933"/>
@@ -6087,6 +6234,7 @@
           <a:lstStyle xmlns:a="http://schemas.openxmlformats.org/drawingml/2006/main"/>
           <a:p xmlns:a="http://schemas.openxmlformats.org/drawingml/2006/main">
             <a:pPr algn="r">
+              <a:buNone/>
               <a:defRPr sz="900" b="1">
                 <a:solidFill>
                   <a:srgbClr val="2A7F76"/>
@@ -6199,6 +6347,7 @@
           <a:lstStyle xmlns:a="http://schemas.openxmlformats.org/drawingml/2006/main"/>
           <a:p xmlns:a="http://schemas.openxmlformats.org/drawingml/2006/main">
             <a:pPr algn="r">
+              <a:buNone/>
               <a:defRPr sz="825" b="0">
                 <a:solidFill>
                   <a:srgbClr val="66747E"/>
@@ -6249,6 +6398,7 @@
           <a:lstStyle xmlns:a="http://schemas.openxmlformats.org/drawingml/2006/main"/>
           <a:p xmlns:a="http://schemas.openxmlformats.org/drawingml/2006/main">
             <a:pPr algn="l">
+              <a:buNone/>
               <a:defRPr sz="1350" b="0">
                 <a:solidFill>
                   <a:srgbClr val="66747E"/>
@@ -6365,6 +6515,7 @@
           <a:lstStyle xmlns:a="http://schemas.openxmlformats.org/drawingml/2006/main"/>
           <a:p xmlns:a="http://schemas.openxmlformats.org/drawingml/2006/main">
             <a:pPr algn="l">
+              <a:buNone/>
               <a:defRPr sz="1575" b="1">
                 <a:solidFill>
                   <a:srgbClr val="1F2933"/>
@@ -6415,6 +6566,7 @@
           <a:lstStyle xmlns:a="http://schemas.openxmlformats.org/drawingml/2006/main"/>
           <a:p xmlns:a="http://schemas.openxmlformats.org/drawingml/2006/main">
             <a:pPr algn="l">
+              <a:buNone/>
               <a:defRPr sz="1200" b="0">
                 <a:solidFill>
                   <a:srgbClr val="66747E"/>
@@ -6531,6 +6683,7 @@
           <a:lstStyle xmlns:a="http://schemas.openxmlformats.org/drawingml/2006/main"/>
           <a:p xmlns:a="http://schemas.openxmlformats.org/drawingml/2006/main">
             <a:pPr algn="l">
+              <a:buNone/>
               <a:defRPr sz="1575" b="1">
                 <a:solidFill>
                   <a:srgbClr val="1F2933"/>
@@ -6581,6 +6734,7 @@
           <a:lstStyle xmlns:a="http://schemas.openxmlformats.org/drawingml/2006/main"/>
           <a:p xmlns:a="http://schemas.openxmlformats.org/drawingml/2006/main">
             <a:pPr algn="l">
+              <a:buNone/>
               <a:defRPr sz="1200" b="0">
                 <a:solidFill>
                   <a:srgbClr val="66747E"/>
@@ -6697,6 +6851,7 @@
           <a:lstStyle xmlns:a="http://schemas.openxmlformats.org/drawingml/2006/main"/>
           <a:p xmlns:a="http://schemas.openxmlformats.org/drawingml/2006/main">
             <a:pPr algn="l">
+              <a:buNone/>
               <a:defRPr sz="1575" b="1">
                 <a:solidFill>
                   <a:srgbClr val="1F2933"/>
@@ -6747,6 +6902,7 @@
           <a:lstStyle xmlns:a="http://schemas.openxmlformats.org/drawingml/2006/main"/>
           <a:p xmlns:a="http://schemas.openxmlformats.org/drawingml/2006/main">
             <a:pPr algn="l">
+              <a:buNone/>
               <a:defRPr sz="1200" b="0">
                 <a:solidFill>
                   <a:srgbClr val="66747E"/>
@@ -6766,7 +6922,7 @@
       </p:sp>
       <p:cxnSp>
         <p:nvCxnSpPr>
-          <p:cNvPr id="58" name=""/>
+          <p:cNvPr id="98" name=""/>
           <p:cNvCxnSpPr>
             <a:stCxn xmlns:a="http://schemas.openxmlformats.org/drawingml/2006/main" id="7" idx="3"/>
             <a:endCxn xmlns:a="http://schemas.openxmlformats.org/drawingml/2006/main" id="11" idx="1"/>
@@ -6792,7 +6948,7 @@
       </p:cxnSp>
       <p:cxnSp>
         <p:nvCxnSpPr>
-          <p:cNvPr id="59" name=""/>
+          <p:cNvPr id="99" name=""/>
           <p:cNvCxnSpPr>
             <a:stCxn xmlns:a="http://schemas.openxmlformats.org/drawingml/2006/main" id="11" idx="3"/>
             <a:endCxn xmlns:a="http://schemas.openxmlformats.org/drawingml/2006/main" id="15" idx="1"/>
@@ -6882,6 +7038,7 @@
           <a:lstStyle xmlns:a="http://schemas.openxmlformats.org/drawingml/2006/main"/>
           <a:p xmlns:a="http://schemas.openxmlformats.org/drawingml/2006/main">
             <a:pPr algn="ctr">
+              <a:buNone/>
               <a:defRPr sz="900" b="1">
                 <a:solidFill>
                   <a:srgbClr val="2A7F76"/>
@@ -6932,6 +7089,7 @@
           <a:lstStyle xmlns:a="http://schemas.openxmlformats.org/drawingml/2006/main"/>
           <a:p xmlns:a="http://schemas.openxmlformats.org/drawingml/2006/main">
             <a:pPr algn="ctr">
+              <a:buNone/>
               <a:defRPr sz="1200" b="1">
                 <a:solidFill>
                   <a:srgbClr val="163A5F"/>
@@ -6949,6 +7107,7 @@
           </a:p>
           <a:p xmlns:a="http://schemas.openxmlformats.org/drawingml/2006/main">
             <a:pPr algn="ctr">
+              <a:buNone/>
               <a:defRPr sz="1200" b="1">
                 <a:solidFill>
                   <a:srgbClr val="163A5F"/>
@@ -7030,6 +7189,7 @@
           <a:lstStyle xmlns:a="http://schemas.openxmlformats.org/drawingml/2006/main"/>
           <a:p xmlns:a="http://schemas.openxmlformats.org/drawingml/2006/main">
             <a:pPr algn="ctr">
+              <a:buNone/>
               <a:defRPr sz="1125" b="0">
                 <a:solidFill>
                   <a:srgbClr val="1F2933"/>
@@ -7047,6 +7207,7 @@
           </a:p>
           <a:p xmlns:a="http://schemas.openxmlformats.org/drawingml/2006/main">
             <a:pPr algn="ctr">
+              <a:buNone/>
               <a:defRPr sz="1125" b="0">
                 <a:solidFill>
                   <a:srgbClr val="1F2933"/>
@@ -7097,6 +7258,7 @@
           <a:lstStyle xmlns:a="http://schemas.openxmlformats.org/drawingml/2006/main"/>
           <a:p xmlns:a="http://schemas.openxmlformats.org/drawingml/2006/main">
             <a:pPr algn="l">
+              <a:buNone/>
               <a:defRPr sz="1650" b="1">
                 <a:solidFill>
                   <a:srgbClr val="1F2933"/>
@@ -7178,6 +7340,7 @@
           <a:lstStyle xmlns:a="http://schemas.openxmlformats.org/drawingml/2006/main"/>
           <a:p xmlns:a="http://schemas.openxmlformats.org/drawingml/2006/main">
             <a:pPr algn="l">
+              <a:buNone/>
               <a:defRPr sz="1050" b="1">
                 <a:solidFill>
                   <a:srgbClr val="66747E"/>
@@ -7228,6 +7391,7 @@
           <a:lstStyle xmlns:a="http://schemas.openxmlformats.org/drawingml/2006/main"/>
           <a:p xmlns:a="http://schemas.openxmlformats.org/drawingml/2006/main">
             <a:pPr algn="l">
+              <a:buNone/>
               <a:defRPr sz="1725" b="1">
                 <a:solidFill>
                   <a:srgbClr val="1F2933"/>
@@ -7309,6 +7473,7 @@
           <a:lstStyle xmlns:a="http://schemas.openxmlformats.org/drawingml/2006/main"/>
           <a:p xmlns:a="http://schemas.openxmlformats.org/drawingml/2006/main">
             <a:pPr algn="l">
+              <a:buNone/>
               <a:defRPr sz="1050" b="1">
                 <a:solidFill>
                   <a:srgbClr val="66747E"/>
@@ -7359,6 +7524,7 @@
           <a:lstStyle xmlns:a="http://schemas.openxmlformats.org/drawingml/2006/main"/>
           <a:p xmlns:a="http://schemas.openxmlformats.org/drawingml/2006/main">
             <a:pPr algn="l">
+              <a:buNone/>
               <a:defRPr sz="1725" b="1">
                 <a:solidFill>
                   <a:srgbClr val="1F2933"/>
@@ -7440,6 +7606,7 @@
           <a:lstStyle xmlns:a="http://schemas.openxmlformats.org/drawingml/2006/main"/>
           <a:p xmlns:a="http://schemas.openxmlformats.org/drawingml/2006/main">
             <a:pPr algn="l">
+              <a:buNone/>
               <a:defRPr sz="1050" b="1">
                 <a:solidFill>
                   <a:srgbClr val="66747E"/>
@@ -7490,6 +7657,7 @@
           <a:lstStyle xmlns:a="http://schemas.openxmlformats.org/drawingml/2006/main"/>
           <a:p xmlns:a="http://schemas.openxmlformats.org/drawingml/2006/main">
             <a:pPr algn="l">
+              <a:buNone/>
               <a:defRPr sz="1725" b="1">
                 <a:solidFill>
                   <a:srgbClr val="1F2933"/>
@@ -7571,6 +7739,7 @@
           <a:lstStyle xmlns:a="http://schemas.openxmlformats.org/drawingml/2006/main"/>
           <a:p xmlns:a="http://schemas.openxmlformats.org/drawingml/2006/main">
             <a:pPr algn="l">
+              <a:buNone/>
               <a:defRPr sz="1050" b="1">
                 <a:solidFill>
                   <a:srgbClr val="66747E"/>
@@ -7621,6 +7790,7 @@
           <a:lstStyle xmlns:a="http://schemas.openxmlformats.org/drawingml/2006/main"/>
           <a:p xmlns:a="http://schemas.openxmlformats.org/drawingml/2006/main">
             <a:pPr algn="l">
+              <a:buNone/>
               <a:defRPr sz="1725" b="1">
                 <a:solidFill>
                   <a:srgbClr val="1F2933"/>
@@ -7671,6 +7841,7 @@
           <a:lstStyle xmlns:a="http://schemas.openxmlformats.org/drawingml/2006/main"/>
           <a:p xmlns:a="http://schemas.openxmlformats.org/drawingml/2006/main">
             <a:pPr algn="l">
+              <a:buNone/>
               <a:defRPr sz="1050" b="0">
                 <a:solidFill>
                   <a:srgbClr val="66747E"/>
@@ -7750,6 +7921,7 @@
           <a:lstStyle xmlns:a="http://schemas.openxmlformats.org/drawingml/2006/main"/>
           <a:p xmlns:a="http://schemas.openxmlformats.org/drawingml/2006/main">
             <a:pPr algn="l">
+              <a:buNone/>
               <a:defRPr sz="2400" b="1">
                 <a:solidFill>
                   <a:srgbClr val="1F2933"/>
@@ -7800,6 +7972,7 @@
           <a:lstStyle xmlns:a="http://schemas.openxmlformats.org/drawingml/2006/main"/>
           <a:p xmlns:a="http://schemas.openxmlformats.org/drawingml/2006/main">
             <a:pPr algn="r">
+              <a:buNone/>
               <a:defRPr sz="900" b="1">
                 <a:solidFill>
                   <a:srgbClr val="2A7F76"/>
@@ -7912,6 +8085,7 @@
           <a:lstStyle xmlns:a="http://schemas.openxmlformats.org/drawingml/2006/main"/>
           <a:p xmlns:a="http://schemas.openxmlformats.org/drawingml/2006/main">
             <a:pPr algn="r">
+              <a:buNone/>
               <a:defRPr sz="825" b="0">
                 <a:solidFill>
                   <a:srgbClr val="66747E"/>
@@ -7966,14 +8140,14 @@
       </p:sp>
       <p:pic>
         <p:nvPicPr>
-          <p:cNvPr id="24" name=""/>
+          <p:cNvPr id="26" name=""/>
           <p:cNvPicPr>
             <a:picLocks xmlns:a="http://schemas.openxmlformats.org/drawingml/2006/main" noChangeAspect="1"/>
           </p:cNvPicPr>
           <p:nvPr/>
         </p:nvPicPr>
         <p:blipFill>
-          <a:blip xmlns:r="http://schemas.openxmlformats.org/officeDocument/2006/relationships" xmlns:a="http://schemas.openxmlformats.org/drawingml/2006/main" r:embed="Ra9301ccf68354abe"/>
+          <a:blip xmlns:r="http://schemas.openxmlformats.org/officeDocument/2006/relationships" xmlns:a="http://schemas.openxmlformats.org/drawingml/2006/main" r:embed="R45f1fb53f45c4809"/>
           <a:stretch xmlns:a="http://schemas.openxmlformats.org/drawingml/2006/main"/>
         </p:blipFill>
         <p:spPr>
@@ -8019,6 +8193,7 @@
           <a:lstStyle xmlns:a="http://schemas.openxmlformats.org/drawingml/2006/main"/>
           <a:p xmlns:a="http://schemas.openxmlformats.org/drawingml/2006/main">
             <a:pPr algn="l">
+              <a:buNone/>
               <a:defRPr sz="900" b="1">
                 <a:solidFill>
                   <a:srgbClr val="163A5F"/>
@@ -8102,6 +8277,7 @@
           <a:lstStyle xmlns:a="http://schemas.openxmlformats.org/drawingml/2006/main"/>
           <a:p xmlns:a="http://schemas.openxmlformats.org/drawingml/2006/main">
             <a:pPr algn="l">
+              <a:buNone/>
               <a:defRPr sz="1875" b="1">
                 <a:solidFill>
                   <a:srgbClr val="163A5F"/>
@@ -8152,6 +8328,7 @@
           <a:lstStyle xmlns:a="http://schemas.openxmlformats.org/drawingml/2006/main"/>
           <a:p xmlns:a="http://schemas.openxmlformats.org/drawingml/2006/main">
             <a:pPr algn="l">
+              <a:buNone/>
               <a:defRPr sz="1050" b="0">
                 <a:solidFill>
                   <a:srgbClr val="66747E"/>
@@ -8237,6 +8414,7 @@
           <a:lstStyle xmlns:a="http://schemas.openxmlformats.org/drawingml/2006/main"/>
           <a:p xmlns:a="http://schemas.openxmlformats.org/drawingml/2006/main">
             <a:pPr algn="l">
+              <a:buNone/>
               <a:defRPr sz="1875" b="1">
                 <a:solidFill>
                   <a:srgbClr val="2A7F76"/>
@@ -8287,6 +8465,7 @@
           <a:lstStyle xmlns:a="http://schemas.openxmlformats.org/drawingml/2006/main"/>
           <a:p xmlns:a="http://schemas.openxmlformats.org/drawingml/2006/main">
             <a:pPr algn="l">
+              <a:buNone/>
               <a:defRPr sz="1050" b="0">
                 <a:solidFill>
                   <a:srgbClr val="66747E"/>
@@ -8368,6 +8547,7 @@
           <a:lstStyle xmlns:a="http://schemas.openxmlformats.org/drawingml/2006/main"/>
           <a:p xmlns:a="http://schemas.openxmlformats.org/drawingml/2006/main">
             <a:pPr algn="l">
+              <a:buNone/>
               <a:defRPr sz="1200" b="1">
                 <a:solidFill>
                   <a:srgbClr val="1F2933"/>
@@ -8418,6 +8598,7 @@
           <a:lstStyle xmlns:a="http://schemas.openxmlformats.org/drawingml/2006/main"/>
           <a:p xmlns:a="http://schemas.openxmlformats.org/drawingml/2006/main">
             <a:pPr algn="l">
+              <a:buNone/>
               <a:defRPr sz="1275" b="0">
                 <a:solidFill>
                   <a:srgbClr val="66747E"/>
@@ -8497,6 +8678,7 @@
           <a:lstStyle xmlns:a="http://schemas.openxmlformats.org/drawingml/2006/main"/>
           <a:p xmlns:a="http://schemas.openxmlformats.org/drawingml/2006/main">
             <a:pPr algn="l">
+              <a:buNone/>
               <a:defRPr sz="2400" b="1">
                 <a:solidFill>
                   <a:srgbClr val="1F2933"/>
@@ -8547,6 +8729,7 @@
           <a:lstStyle xmlns:a="http://schemas.openxmlformats.org/drawingml/2006/main"/>
           <a:p xmlns:a="http://schemas.openxmlformats.org/drawingml/2006/main">
             <a:pPr algn="r">
+              <a:buNone/>
               <a:defRPr sz="900" b="1">
                 <a:solidFill>
                   <a:srgbClr val="2A7F76"/>
@@ -8659,6 +8842,7 @@
           <a:lstStyle xmlns:a="http://schemas.openxmlformats.org/drawingml/2006/main"/>
           <a:p xmlns:a="http://schemas.openxmlformats.org/drawingml/2006/main">
             <a:pPr algn="r">
+              <a:buNone/>
               <a:defRPr sz="825" b="0">
                 <a:solidFill>
                   <a:srgbClr val="66747E"/>
@@ -8713,14 +8897,14 @@
       </p:sp>
       <p:pic>
         <p:nvPicPr>
-          <p:cNvPr id="23" name=""/>
+          <p:cNvPr id="26" name=""/>
           <p:cNvPicPr>
             <a:picLocks xmlns:a="http://schemas.openxmlformats.org/drawingml/2006/main" noChangeAspect="1"/>
           </p:cNvPicPr>
           <p:nvPr/>
         </p:nvPicPr>
         <p:blipFill>
-          <a:blip xmlns:r="http://schemas.openxmlformats.org/officeDocument/2006/relationships" xmlns:a="http://schemas.openxmlformats.org/drawingml/2006/main" r:embed="R528c3d4c778f4dd8"/>
+          <a:blip xmlns:r="http://schemas.openxmlformats.org/officeDocument/2006/relationships" xmlns:a="http://schemas.openxmlformats.org/drawingml/2006/main" r:embed="R6ed62f8d53fa4758"/>
           <a:stretch xmlns:a="http://schemas.openxmlformats.org/drawingml/2006/main"/>
         </p:blipFill>
         <p:spPr>
@@ -8766,6 +8950,7 @@
           <a:lstStyle xmlns:a="http://schemas.openxmlformats.org/drawingml/2006/main"/>
           <a:p xmlns:a="http://schemas.openxmlformats.org/drawingml/2006/main">
             <a:pPr algn="l">
+              <a:buNone/>
               <a:defRPr sz="900" b="1">
                 <a:solidFill>
                   <a:srgbClr val="163A5F"/>
@@ -8816,6 +9001,7 @@
           <a:lstStyle xmlns:a="http://schemas.openxmlformats.org/drawingml/2006/main"/>
           <a:p xmlns:a="http://schemas.openxmlformats.org/drawingml/2006/main">
             <a:pPr algn="l">
+              <a:buNone/>
               <a:defRPr sz="1650" b="1">
                 <a:solidFill>
                   <a:srgbClr val="1F2933"/>
@@ -8835,7 +9021,7 @@
       </p:sp>
       <p:graphicFrame>
         <p:nvGraphicFramePr>
-          <p:cNvPr id="26" name="Chart"/>
+          <p:cNvPr id="29" name="Chart"/>
           <p:cNvGraphicFramePr/>
           <p:nvPr/>
         </p:nvGraphicFramePr>
@@ -8845,7 +9031,7 @@
         </p:xfrm>
         <a:graphic xmlns:a="http://schemas.openxmlformats.org/drawingml/2006/main">
           <a:graphicData uri="http://schemas.openxmlformats.org/drawingml/2006/chart">
-            <c:chart xmlns:r="http://schemas.openxmlformats.org/officeDocument/2006/relationships" xmlns:c="http://schemas.openxmlformats.org/drawingml/2006/chart" r:id="Rf1d72ce629c448b1"/>
+            <c:chart xmlns:r="http://schemas.openxmlformats.org/officeDocument/2006/relationships" xmlns:c="http://schemas.openxmlformats.org/drawingml/2006/chart" r:id="R7a5fb372bece4240"/>
           </a:graphicData>
         </a:graphic>
       </p:graphicFrame>
@@ -8913,6 +9099,7 @@
           <a:lstStyle xmlns:a="http://schemas.openxmlformats.org/drawingml/2006/main"/>
           <a:p xmlns:a="http://schemas.openxmlformats.org/drawingml/2006/main">
             <a:pPr algn="l">
+              <a:buNone/>
               <a:defRPr sz="1800" b="1">
                 <a:solidFill>
                   <a:srgbClr val="163A5F"/>
@@ -8963,6 +9150,7 @@
           <a:lstStyle xmlns:a="http://schemas.openxmlformats.org/drawingml/2006/main"/>
           <a:p xmlns:a="http://schemas.openxmlformats.org/drawingml/2006/main">
             <a:pPr algn="l">
+              <a:buNone/>
               <a:defRPr sz="975" b="0">
                 <a:solidFill>
                   <a:srgbClr val="66747E"/>
@@ -9013,6 +9201,7 @@
           <a:lstStyle xmlns:a="http://schemas.openxmlformats.org/drawingml/2006/main"/>
           <a:p xmlns:a="http://schemas.openxmlformats.org/drawingml/2006/main">
             <a:pPr algn="l">
+              <a:buNone/>
               <a:defRPr sz="1800" b="1">
                 <a:solidFill>
                   <a:srgbClr val="2A7F76"/>
@@ -9063,6 +9252,7 @@
           <a:lstStyle xmlns:a="http://schemas.openxmlformats.org/drawingml/2006/main"/>
           <a:p xmlns:a="http://schemas.openxmlformats.org/drawingml/2006/main">
             <a:pPr algn="l">
+              <a:buNone/>
               <a:defRPr sz="975" b="0">
                 <a:solidFill>
                   <a:srgbClr val="66747E"/>
@@ -9113,6 +9303,7 @@
           <a:lstStyle xmlns:a="http://schemas.openxmlformats.org/drawingml/2006/main"/>
           <a:p xmlns:a="http://schemas.openxmlformats.org/drawingml/2006/main">
             <a:pPr algn="l">
+              <a:buNone/>
               <a:defRPr sz="1275" b="1">
                 <a:solidFill>
                   <a:srgbClr val="1F2933"/>
@@ -9192,6 +9383,7 @@
           <a:lstStyle xmlns:a="http://schemas.openxmlformats.org/drawingml/2006/main"/>
           <a:p xmlns:a="http://schemas.openxmlformats.org/drawingml/2006/main">
             <a:pPr algn="l">
+              <a:buNone/>
               <a:defRPr sz="2400" b="1">
                 <a:solidFill>
                   <a:srgbClr val="1F2933"/>
@@ -9242,6 +9434,7 @@
           <a:lstStyle xmlns:a="http://schemas.openxmlformats.org/drawingml/2006/main"/>
           <a:p xmlns:a="http://schemas.openxmlformats.org/drawingml/2006/main">
             <a:pPr algn="r">
+              <a:buNone/>
               <a:defRPr sz="900" b="1">
                 <a:solidFill>
                   <a:srgbClr val="2A7F76"/>
@@ -9354,6 +9547,7 @@
           <a:lstStyle xmlns:a="http://schemas.openxmlformats.org/drawingml/2006/main"/>
           <a:p xmlns:a="http://schemas.openxmlformats.org/drawingml/2006/main">
             <a:pPr algn="r">
+              <a:buNone/>
               <a:defRPr sz="825" b="0">
                 <a:solidFill>
                   <a:srgbClr val="66747E"/>
@@ -9437,6 +9631,7 @@
           <a:lstStyle xmlns:a="http://schemas.openxmlformats.org/drawingml/2006/main"/>
           <a:p xmlns:a="http://schemas.openxmlformats.org/drawingml/2006/main">
             <a:pPr algn="l">
+              <a:buNone/>
               <a:defRPr sz="1125" b="1">
                 <a:solidFill>
                   <a:srgbClr val="2A7F76"/>
@@ -9518,6 +9713,7 @@
           <a:lstStyle xmlns:a="http://schemas.openxmlformats.org/drawingml/2006/main"/>
           <a:p xmlns:a="http://schemas.openxmlformats.org/drawingml/2006/main">
             <a:pPr algn="l">
+              <a:buNone/>
               <a:defRPr sz="1200" b="1">
                 <a:solidFill>
                   <a:srgbClr val="1F2933"/>
@@ -9568,6 +9764,7 @@
           <a:lstStyle xmlns:a="http://schemas.openxmlformats.org/drawingml/2006/main"/>
           <a:p xmlns:a="http://schemas.openxmlformats.org/drawingml/2006/main">
             <a:pPr algn="r">
+              <a:buNone/>
               <a:defRPr sz="1050" b="0">
                 <a:solidFill>
                   <a:srgbClr val="66747E"/>
@@ -9649,6 +9846,7 @@
           <a:lstStyle xmlns:a="http://schemas.openxmlformats.org/drawingml/2006/main"/>
           <a:p xmlns:a="http://schemas.openxmlformats.org/drawingml/2006/main">
             <a:pPr algn="l">
+              <a:buNone/>
               <a:defRPr sz="1200" b="1">
                 <a:solidFill>
                   <a:srgbClr val="1F2933"/>
@@ -9699,6 +9897,7 @@
           <a:lstStyle xmlns:a="http://schemas.openxmlformats.org/drawingml/2006/main"/>
           <a:p xmlns:a="http://schemas.openxmlformats.org/drawingml/2006/main">
             <a:pPr algn="r">
+              <a:buNone/>
               <a:defRPr sz="1050" b="0">
                 <a:solidFill>
                   <a:srgbClr val="66747E"/>
@@ -9780,6 +9979,7 @@
           <a:lstStyle xmlns:a="http://schemas.openxmlformats.org/drawingml/2006/main"/>
           <a:p xmlns:a="http://schemas.openxmlformats.org/drawingml/2006/main">
             <a:pPr algn="l">
+              <a:buNone/>
               <a:defRPr sz="1200" b="1">
                 <a:solidFill>
                   <a:srgbClr val="1F2933"/>
@@ -9830,6 +10030,7 @@
           <a:lstStyle xmlns:a="http://schemas.openxmlformats.org/drawingml/2006/main"/>
           <a:p xmlns:a="http://schemas.openxmlformats.org/drawingml/2006/main">
             <a:pPr algn="r">
+              <a:buNone/>
               <a:defRPr sz="1050" b="0">
                 <a:solidFill>
                   <a:srgbClr val="66747E"/>
@@ -9911,6 +10112,7 @@
           <a:lstStyle xmlns:a="http://schemas.openxmlformats.org/drawingml/2006/main"/>
           <a:p xmlns:a="http://schemas.openxmlformats.org/drawingml/2006/main">
             <a:pPr algn="l">
+              <a:buNone/>
               <a:defRPr sz="1200" b="1">
                 <a:solidFill>
                   <a:srgbClr val="1F2933"/>
@@ -9961,6 +10163,7 @@
           <a:lstStyle xmlns:a="http://schemas.openxmlformats.org/drawingml/2006/main"/>
           <a:p xmlns:a="http://schemas.openxmlformats.org/drawingml/2006/main">
             <a:pPr algn="r">
+              <a:buNone/>
               <a:defRPr sz="1050" b="0">
                 <a:solidFill>
                   <a:srgbClr val="66747E"/>
@@ -10042,6 +10245,7 @@
           <a:lstStyle xmlns:a="http://schemas.openxmlformats.org/drawingml/2006/main"/>
           <a:p xmlns:a="http://schemas.openxmlformats.org/drawingml/2006/main">
             <a:pPr algn="l">
+              <a:buNone/>
               <a:defRPr sz="1200" b="1">
                 <a:solidFill>
                   <a:srgbClr val="1F2933"/>
@@ -10092,6 +10296,7 @@
           <a:lstStyle xmlns:a="http://schemas.openxmlformats.org/drawingml/2006/main"/>
           <a:p xmlns:a="http://schemas.openxmlformats.org/drawingml/2006/main">
             <a:pPr algn="r">
+              <a:buNone/>
               <a:defRPr sz="1050" b="0">
                 <a:solidFill>
                   <a:srgbClr val="66747E"/>
@@ -10177,6 +10382,7 @@
           <a:lstStyle xmlns:a="http://schemas.openxmlformats.org/drawingml/2006/main"/>
           <a:p xmlns:a="http://schemas.openxmlformats.org/drawingml/2006/main">
             <a:pPr algn="l">
+              <a:buNone/>
               <a:defRPr sz="1125" b="1">
                 <a:solidFill>
                   <a:srgbClr val="163A5F"/>
@@ -10258,6 +10464,7 @@
           <a:lstStyle xmlns:a="http://schemas.openxmlformats.org/drawingml/2006/main"/>
           <a:p xmlns:a="http://schemas.openxmlformats.org/drawingml/2006/main">
             <a:pPr algn="l">
+              <a:buNone/>
               <a:defRPr sz="1275" b="1">
                 <a:solidFill>
                   <a:srgbClr val="1F2933"/>
@@ -10308,6 +10515,7 @@
           <a:lstStyle xmlns:a="http://schemas.openxmlformats.org/drawingml/2006/main"/>
           <a:p xmlns:a="http://schemas.openxmlformats.org/drawingml/2006/main">
             <a:pPr algn="l">
+              <a:buNone/>
               <a:defRPr sz="1125" b="0">
                 <a:solidFill>
                   <a:srgbClr val="66747E"/>
@@ -10389,6 +10597,7 @@
           <a:lstStyle xmlns:a="http://schemas.openxmlformats.org/drawingml/2006/main"/>
           <a:p xmlns:a="http://schemas.openxmlformats.org/drawingml/2006/main">
             <a:pPr algn="l">
+              <a:buNone/>
               <a:defRPr sz="1275" b="1">
                 <a:solidFill>
                   <a:srgbClr val="1F2933"/>
@@ -10439,6 +10648,7 @@
           <a:lstStyle xmlns:a="http://schemas.openxmlformats.org/drawingml/2006/main"/>
           <a:p xmlns:a="http://schemas.openxmlformats.org/drawingml/2006/main">
             <a:pPr algn="l">
+              <a:buNone/>
               <a:defRPr sz="1125" b="0">
                 <a:solidFill>
                   <a:srgbClr val="66747E"/>
@@ -10520,6 +10730,7 @@
           <a:lstStyle xmlns:a="http://schemas.openxmlformats.org/drawingml/2006/main"/>
           <a:p xmlns:a="http://schemas.openxmlformats.org/drawingml/2006/main">
             <a:pPr algn="l">
+              <a:buNone/>
               <a:defRPr sz="1275" b="1">
                 <a:solidFill>
                   <a:srgbClr val="1F2933"/>
@@ -10570,6 +10781,7 @@
           <a:lstStyle xmlns:a="http://schemas.openxmlformats.org/drawingml/2006/main"/>
           <a:p xmlns:a="http://schemas.openxmlformats.org/drawingml/2006/main">
             <a:pPr algn="l">
+              <a:buNone/>
               <a:defRPr sz="1125" b="0">
                 <a:solidFill>
                   <a:srgbClr val="66747E"/>
@@ -10653,6 +10865,7 @@
           <a:lstStyle xmlns:a="http://schemas.openxmlformats.org/drawingml/2006/main"/>
           <a:p xmlns:a="http://schemas.openxmlformats.org/drawingml/2006/main">
             <a:pPr algn="ctr">
+              <a:buNone/>
               <a:defRPr sz="1575" b="1">
                 <a:solidFill>
                   <a:srgbClr val="FFFFFF"/>

</xml_diff>